<commit_message>
docs(poster): improve A1 print readability
</commit_message>
<xml_diff>
--- a/docs/poster/EIMS_COOP_POSTER_2026.pptx
+++ b/docs/poster/EIMS_COOP_POSTER_2026.pptx
@@ -3096,8 +3096,8 @@
         </p:nvSpPr>
         <p:spPr>
           <a:xfrm>
-            <a:off x="576000" y="432000"/>
-            <a:ext cx="20232000" cy="2880000"/>
+            <a:off x="576000" y="360000"/>
+            <a:ext cx="20232000" cy="2952000"/>
           </a:xfrm>
           <a:prstGeom prst="rect">
             <a:avLst/>
@@ -3126,11 +3126,14 @@
           </a:fontRef>
         </p:style>
         <p:txBody>
-          <a:bodyPr rtlCol="0" anchor="ctr" wrap="square" lIns="360000" rIns="360000" tIns="180000" bIns="144000"/>
+          <a:bodyPr rtlCol="0" anchor="ctr" wrap="square" lIns="288000" rIns="288000" tIns="180000" bIns="144000"/>
           <a:lstStyle/>
           <a:p>
             <a:pPr algn="ctr">
-              <a:defRPr sz="1700" b="1">
+              <a:spcAft>
+                <a:spcPts val="200"/>
+              </a:spcAft>
+              <a:defRPr sz="1950" b="1">
                 <a:solidFill>
                   <a:srgbClr val="94A3B8"/>
                 </a:solidFill>
@@ -3149,7 +3152,7 @@
               <a:spcAft>
                 <a:spcPts val="200"/>
               </a:spcAft>
-              <a:defRPr sz="3600" b="1">
+              <a:defRPr sz="5000" b="1">
                 <a:solidFill>
                   <a:srgbClr val="FFFFFF"/>
                 </a:solidFill>
@@ -3158,24 +3161,27 @@
             </a:pPr>
             <a:r>
               <a:t>Development of an Enterprise Infrastructure Management System (EIMS)</a:t>
+            </a:r>
+          </a:p>
+          <a:p>
+            <a:pPr algn="ctr">
+              <a:spcAft>
+                <a:spcPts val="100"/>
+              </a:spcAft>
+              <a:defRPr sz="2000" b="1">
+                <a:solidFill>
+                  <a:srgbClr val="E2E8F0"/>
+                </a:solidFill>
+                <a:latin typeface="TH Sarabun New"/>
+              </a:defRPr>
+            </a:pPr>
+            <a:r>
+              <a:t>Author: Ratthabhumi Peansukmanee (Student ID: 66011198) | Computer Engineering (International Program)</a:t>
             </a:r>
           </a:p>
           <a:p>
             <a:pPr algn="ctr">
               <a:defRPr sz="1800">
-                <a:solidFill>
-                  <a:srgbClr val="E2E8F0"/>
-                </a:solidFill>
-                <a:latin typeface="TH Sarabun New"/>
-              </a:defRPr>
-            </a:pPr>
-            <a:r>
-              <a:t>Author: Ratthabhumi Peansukmanee (Student ID: 66011198) | Computer Engineering (International Program)</a:t>
-            </a:r>
-          </a:p>
-          <a:p>
-            <a:pPr algn="ctr">
-              <a:defRPr sz="1650">
                 <a:solidFill>
                   <a:srgbClr val="CBD5E1"/>
                 </a:solidFill>
@@ -3197,7 +3203,7 @@
         <p:spPr>
           <a:xfrm>
             <a:off x="576000" y="3528000"/>
-            <a:ext cx="9828000" cy="2880000"/>
+            <a:ext cx="9828000" cy="2772000"/>
           </a:xfrm>
           <a:prstGeom prst="roundRect">
             <a:avLst/>
@@ -3242,7 +3248,7 @@
         <p:spPr>
           <a:xfrm>
             <a:off x="576000" y="3528000"/>
-            <a:ext cx="9828000" cy="504000"/>
+            <a:ext cx="9828000" cy="612000"/>
           </a:xfrm>
           <a:prstGeom prst="rect">
             <a:avLst/>
@@ -3271,11 +3277,11 @@
           </a:fontRef>
         </p:style>
         <p:txBody>
-          <a:bodyPr rtlCol="0" anchor="ctr" wrap="square" lIns="288000" tIns="54000"/>
+          <a:bodyPr rtlCol="0" anchor="ctr" wrap="square" lIns="288000" tIns="72000"/>
           <a:lstStyle/>
           <a:p>
             <a:pPr algn="l">
-              <a:defRPr sz="2000" b="1">
+              <a:defRPr sz="2600" b="1">
                 <a:solidFill>
                   <a:srgbClr val="FFFFFF"/>
                 </a:solidFill>
@@ -3296,8 +3302,8 @@
         </p:nvSpPr>
         <p:spPr>
           <a:xfrm>
-            <a:off x="720000" y="4068000"/>
-            <a:ext cx="9540000" cy="2268000"/>
+            <a:off x="720000" y="4176000"/>
+            <a:ext cx="9540000" cy="2052000"/>
           </a:xfrm>
           <a:prstGeom prst="rect">
             <a:avLst/>
@@ -3305,16 +3311,16 @@
           <a:noFill/>
         </p:spPr>
         <p:txBody>
-          <a:bodyPr wrap="square" lIns="72000" tIns="36000">
+          <a:bodyPr wrap="square" lIns="108000" tIns="36000">
             <a:spAutoFit/>
           </a:bodyPr>
           <a:lstStyle/>
           <a:p>
             <a:pPr>
               <a:spcAft>
-                <a:spcPts val="200"/>
+                <a:spcPts val="350"/>
               </a:spcAft>
-              <a:defRPr sz="1550">
+              <a:defRPr sz="1900">
                 <a:latin typeface="TH Sarabun New"/>
               </a:defRPr>
             </a:pPr>
@@ -3338,9 +3344,9 @@
           <a:p>
             <a:pPr>
               <a:spcAft>
-                <a:spcPts val="200"/>
+                <a:spcPts val="350"/>
               </a:spcAft>
-              <a:defRPr sz="1550">
+              <a:defRPr sz="1900">
                 <a:latin typeface="TH Sarabun New"/>
               </a:defRPr>
             </a:pPr>
@@ -3358,15 +3364,15 @@
                   <a:srgbClr val="000000"/>
                 </a:solidFill>
               </a:rPr>
-              <a:t>DHCP leases and renames break asset history without hardware-anchored identity.</a:t>
+              <a:t>DHCP leases and host renames break asset history without hardware-anchored identity.</a:t>
             </a:r>
           </a:p>
           <a:p>
             <a:pPr>
               <a:spcAft>
-                <a:spcPts val="200"/>
+                <a:spcPts val="350"/>
               </a:spcAft>
-              <a:defRPr sz="1550">
+              <a:defRPr sz="1900">
                 <a:latin typeface="TH Sarabun New"/>
               </a:defRPr>
             </a:pPr>
@@ -3390,9 +3396,9 @@
           <a:p>
             <a:pPr>
               <a:spcAft>
-                <a:spcPts val="200"/>
+                <a:spcPts val="350"/>
               </a:spcAft>
-              <a:defRPr sz="1550">
+              <a:defRPr sz="1900">
                 <a:latin typeface="TH Sarabun New"/>
               </a:defRPr>
             </a:pPr>
@@ -3423,8 +3429,8 @@
         </p:nvSpPr>
         <p:spPr>
           <a:xfrm>
-            <a:off x="576000" y="6588000"/>
-            <a:ext cx="9828000" cy="3420000"/>
+            <a:off x="576000" y="6480000"/>
+            <a:ext cx="9828000" cy="3528000"/>
           </a:xfrm>
           <a:prstGeom prst="roundRect">
             <a:avLst/>
@@ -3468,8 +3474,8 @@
         </p:nvSpPr>
         <p:spPr>
           <a:xfrm>
-            <a:off x="576000" y="6588000"/>
-            <a:ext cx="9828000" cy="504000"/>
+            <a:off x="576000" y="6480000"/>
+            <a:ext cx="9828000" cy="612000"/>
           </a:xfrm>
           <a:prstGeom prst="rect">
             <a:avLst/>
@@ -3498,11 +3504,11 @@
           </a:fontRef>
         </p:style>
         <p:txBody>
-          <a:bodyPr rtlCol="0" anchor="ctr" wrap="square" lIns="288000" tIns="54000"/>
+          <a:bodyPr rtlCol="0" anchor="ctr" wrap="square" lIns="288000" tIns="72000"/>
           <a:lstStyle/>
           <a:p>
             <a:pPr algn="l">
-              <a:defRPr sz="2000" b="1">
+              <a:defRPr sz="2600" b="1">
                 <a:solidFill>
                   <a:srgbClr val="FFFFFF"/>
                 </a:solidFill>
@@ -3532,16 +3538,16 @@
           <a:noFill/>
         </p:spPr>
         <p:txBody>
-          <a:bodyPr wrap="square" lIns="72000" tIns="36000">
+          <a:bodyPr wrap="square" lIns="108000" tIns="36000">
             <a:spAutoFit/>
           </a:bodyPr>
           <a:lstStyle/>
           <a:p>
             <a:pPr>
               <a:spcAft>
-                <a:spcPts val="150"/>
+                <a:spcPts val="250"/>
               </a:spcAft>
-              <a:defRPr sz="1400">
+              <a:defRPr sz="1750">
                 <a:latin typeface="TH Sarabun New"/>
               </a:defRPr>
             </a:pPr>
@@ -3565,9 +3571,9 @@
           <a:p>
             <a:pPr>
               <a:spcAft>
-                <a:spcPts val="150"/>
+                <a:spcPts val="250"/>
               </a:spcAft>
-              <a:defRPr sz="1400">
+              <a:defRPr sz="1750">
                 <a:latin typeface="TH Sarabun New"/>
               </a:defRPr>
             </a:pPr>
@@ -3591,9 +3597,9 @@
           <a:p>
             <a:pPr>
               <a:spcAft>
-                <a:spcPts val="150"/>
+                <a:spcPts val="250"/>
               </a:spcAft>
-              <a:defRPr sz="1400">
+              <a:defRPr sz="1750">
                 <a:latin typeface="TH Sarabun New"/>
               </a:defRPr>
             </a:pPr>
@@ -3617,9 +3623,9 @@
           <a:p>
             <a:pPr>
               <a:spcAft>
-                <a:spcPts val="150"/>
+                <a:spcPts val="250"/>
               </a:spcAft>
-              <a:defRPr sz="1400">
+              <a:defRPr sz="1750">
                 <a:latin typeface="TH Sarabun New"/>
               </a:defRPr>
             </a:pPr>
@@ -3643,9 +3649,9 @@
           <a:p>
             <a:pPr>
               <a:spcAft>
-                <a:spcPts val="150"/>
+                <a:spcPts val="250"/>
               </a:spcAft>
-              <a:defRPr sz="1400">
+              <a:defRPr sz="1750">
                 <a:latin typeface="TH Sarabun New"/>
               </a:defRPr>
             </a:pPr>
@@ -3669,9 +3675,9 @@
           <a:p>
             <a:pPr>
               <a:spcAft>
-                <a:spcPts val="150"/>
+                <a:spcPts val="250"/>
               </a:spcAft>
-              <a:defRPr sz="1400">
+              <a:defRPr sz="1750">
                 <a:latin typeface="TH Sarabun New"/>
               </a:defRPr>
             </a:pPr>
@@ -3695,9 +3701,9 @@
           <a:p>
             <a:pPr>
               <a:spcAft>
-                <a:spcPts val="150"/>
+                <a:spcPts val="250"/>
               </a:spcAft>
-              <a:defRPr sz="1400">
+              <a:defRPr sz="1750">
                 <a:latin typeface="TH Sarabun New"/>
               </a:defRPr>
             </a:pPr>
@@ -3774,7 +3780,7 @@
         <p:spPr>
           <a:xfrm>
             <a:off x="576000" y="10188000"/>
-            <a:ext cx="9828000" cy="504000"/>
+            <a:ext cx="9828000" cy="612000"/>
           </a:xfrm>
           <a:prstGeom prst="rect">
             <a:avLst/>
@@ -3803,11 +3809,11 @@
           </a:fontRef>
         </p:style>
         <p:txBody>
-          <a:bodyPr rtlCol="0" anchor="ctr" wrap="square" lIns="288000" tIns="54000"/>
+          <a:bodyPr rtlCol="0" anchor="ctr" wrap="square" lIns="288000" tIns="72000"/>
           <a:lstStyle/>
           <a:p>
             <a:pPr algn="l">
-              <a:defRPr sz="2000" b="1">
+              <a:defRPr sz="2600" b="1">
                 <a:solidFill>
                   <a:srgbClr val="FFFFFF"/>
                 </a:solidFill>
@@ -3836,8 +3842,8 @@
         </p:blipFill>
         <p:spPr>
           <a:xfrm>
-            <a:off x="792000" y="10764000"/>
-            <a:ext cx="9396000" cy="5760000"/>
+            <a:off x="792000" y="10836000"/>
+            <a:ext cx="9396000" cy="5328000"/>
           </a:xfrm>
           <a:prstGeom prst="rect">
             <a:avLst/>
@@ -3852,8 +3858,8 @@
         </p:nvSpPr>
         <p:spPr>
           <a:xfrm>
-            <a:off x="720000" y="16632000"/>
-            <a:ext cx="9540000" cy="2664000"/>
+            <a:off x="720000" y="16308000"/>
+            <a:ext cx="9540000" cy="2952000"/>
           </a:xfrm>
           <a:prstGeom prst="rect">
             <a:avLst/>
@@ -3861,16 +3867,16 @@
           <a:noFill/>
         </p:spPr>
         <p:txBody>
-          <a:bodyPr wrap="square" lIns="72000" tIns="0">
+          <a:bodyPr wrap="square" lIns="108000" tIns="36000">
             <a:spAutoFit/>
           </a:bodyPr>
           <a:lstStyle/>
           <a:p>
             <a:pPr>
               <a:spcAft>
-                <a:spcPts val="250"/>
+                <a:spcPts val="300"/>
               </a:spcAft>
-              <a:defRPr sz="1400">
+              <a:defRPr sz="1800">
                 <a:latin typeface="TH Sarabun New"/>
               </a:defRPr>
             </a:pPr>
@@ -3894,9 +3900,9 @@
           <a:p>
             <a:pPr>
               <a:spcAft>
-                <a:spcPts val="250"/>
+                <a:spcPts val="300"/>
               </a:spcAft>
-              <a:defRPr sz="1400">
+              <a:defRPr sz="1800">
                 <a:latin typeface="TH Sarabun New"/>
               </a:defRPr>
             </a:pPr>
@@ -3920,9 +3926,9 @@
           <a:p>
             <a:pPr>
               <a:spcAft>
-                <a:spcPts val="250"/>
+                <a:spcPts val="300"/>
               </a:spcAft>
-              <a:defRPr sz="1400">
+              <a:defRPr sz="1800">
                 <a:latin typeface="TH Sarabun New"/>
               </a:defRPr>
             </a:pPr>
@@ -3999,7 +4005,7 @@
         <p:spPr>
           <a:xfrm>
             <a:off x="576000" y="19548000"/>
-            <a:ext cx="9828000" cy="504000"/>
+            <a:ext cx="9828000" cy="612000"/>
           </a:xfrm>
           <a:prstGeom prst="rect">
             <a:avLst/>
@@ -4028,11 +4034,11 @@
           </a:fontRef>
         </p:style>
         <p:txBody>
-          <a:bodyPr rtlCol="0" anchor="ctr" wrap="square" lIns="288000" tIns="54000"/>
+          <a:bodyPr rtlCol="0" anchor="ctr" wrap="square" lIns="288000" tIns="72000"/>
           <a:lstStyle/>
           <a:p>
             <a:pPr algn="l">
-              <a:defRPr sz="2000" b="1">
+              <a:defRPr sz="2600" b="1">
                 <a:solidFill>
                   <a:srgbClr val="FFFFFF"/>
                 </a:solidFill>
@@ -4053,8 +4059,8 @@
         </p:nvSpPr>
         <p:spPr>
           <a:xfrm>
-            <a:off x="720000" y="20088000"/>
-            <a:ext cx="9540000" cy="3528000"/>
+            <a:off x="720000" y="20196000"/>
+            <a:ext cx="9540000" cy="3420000"/>
           </a:xfrm>
           <a:prstGeom prst="rect">
             <a:avLst/>
@@ -4062,16 +4068,16 @@
           <a:noFill/>
         </p:spPr>
         <p:txBody>
-          <a:bodyPr wrap="square" lIns="72000" tIns="36000">
+          <a:bodyPr wrap="square" lIns="108000" tIns="36000">
             <a:spAutoFit/>
           </a:bodyPr>
           <a:lstStyle/>
           <a:p>
             <a:pPr>
               <a:spcAft>
-                <a:spcPts val="200"/>
+                <a:spcPts val="350"/>
               </a:spcAft>
-              <a:defRPr sz="1400">
+              <a:defRPr sz="1800">
                 <a:latin typeface="TH Sarabun New"/>
               </a:defRPr>
             </a:pPr>
@@ -4095,9 +4101,9 @@
           <a:p>
             <a:pPr>
               <a:spcAft>
-                <a:spcPts val="200"/>
+                <a:spcPts val="350"/>
               </a:spcAft>
-              <a:defRPr sz="1400">
+              <a:defRPr sz="1800">
                 <a:latin typeface="TH Sarabun New"/>
               </a:defRPr>
             </a:pPr>
@@ -4121,9 +4127,9 @@
           <a:p>
             <a:pPr>
               <a:spcAft>
-                <a:spcPts val="200"/>
+                <a:spcPts val="350"/>
               </a:spcAft>
-              <a:defRPr sz="1400">
+              <a:defRPr sz="1800">
                 <a:latin typeface="TH Sarabun New"/>
               </a:defRPr>
             </a:pPr>
@@ -4147,9 +4153,9 @@
           <a:p>
             <a:pPr>
               <a:spcAft>
-                <a:spcPts val="200"/>
+                <a:spcPts val="350"/>
               </a:spcAft>
-              <a:defRPr sz="1400">
+              <a:defRPr sz="1800">
                 <a:latin typeface="TH Sarabun New"/>
               </a:defRPr>
             </a:pPr>
@@ -4173,9 +4179,9 @@
           <a:p>
             <a:pPr>
               <a:spcAft>
-                <a:spcPts val="200"/>
+                <a:spcPts val="350"/>
               </a:spcAft>
-              <a:defRPr sz="1400">
+              <a:defRPr sz="1800">
                 <a:latin typeface="TH Sarabun New"/>
               </a:defRPr>
             </a:pPr>
@@ -4199,9 +4205,9 @@
           <a:p>
             <a:pPr>
               <a:spcAft>
-                <a:spcPts val="200"/>
+                <a:spcPts val="350"/>
               </a:spcAft>
-              <a:defRPr sz="1400">
+              <a:defRPr sz="1800">
                 <a:latin typeface="TH Sarabun New"/>
               </a:defRPr>
             </a:pPr>
@@ -4278,7 +4284,7 @@
         <p:spPr>
           <a:xfrm>
             <a:off x="576000" y="23868000"/>
-            <a:ext cx="9828000" cy="504000"/>
+            <a:ext cx="9828000" cy="612000"/>
           </a:xfrm>
           <a:prstGeom prst="rect">
             <a:avLst/>
@@ -4307,11 +4313,11 @@
           </a:fontRef>
         </p:style>
         <p:txBody>
-          <a:bodyPr rtlCol="0" anchor="ctr" wrap="square" lIns="288000" tIns="54000"/>
+          <a:bodyPr rtlCol="0" anchor="ctr" wrap="square" lIns="288000" tIns="72000"/>
           <a:lstStyle/>
           <a:p>
             <a:pPr algn="l">
-              <a:defRPr sz="2000" b="1">
+              <a:defRPr sz="2600" b="1">
                 <a:solidFill>
                   <a:srgbClr val="FFFFFF"/>
                 </a:solidFill>
@@ -4332,8 +4338,8 @@
         </p:nvSpPr>
         <p:spPr>
           <a:xfrm>
-            <a:off x="720000" y="24408000"/>
-            <a:ext cx="9540000" cy="5256000"/>
+            <a:off x="720000" y="24516000"/>
+            <a:ext cx="9540000" cy="5148000"/>
           </a:xfrm>
           <a:prstGeom prst="rect">
             <a:avLst/>
@@ -4341,16 +4347,16 @@
           <a:noFill/>
         </p:spPr>
         <p:txBody>
-          <a:bodyPr wrap="square" lIns="72000" tIns="36000">
+          <a:bodyPr wrap="square" lIns="108000" tIns="36000">
             <a:spAutoFit/>
           </a:bodyPr>
           <a:lstStyle/>
           <a:p>
             <a:pPr>
               <a:spcAft>
-                <a:spcPts val="200"/>
+                <a:spcPts val="300"/>
               </a:spcAft>
-              <a:defRPr sz="1200" b="1">
+              <a:defRPr sz="1500" b="1">
                 <a:solidFill>
                   <a:srgbClr val="1E40AF"/>
                 </a:solidFill>
@@ -4364,9 +4370,9 @@
           <a:p>
             <a:pPr>
               <a:spcAft>
-                <a:spcPts val="200"/>
+                <a:spcPts val="300"/>
               </a:spcAft>
-              <a:defRPr sz="1400">
+              <a:defRPr sz="1800">
                 <a:latin typeface="TH Sarabun New"/>
               </a:defRPr>
             </a:pPr>
@@ -4390,9 +4396,9 @@
           <a:p>
             <a:pPr>
               <a:spcAft>
-                <a:spcPts val="200"/>
+                <a:spcPts val="300"/>
               </a:spcAft>
-              <a:defRPr sz="1400">
+              <a:defRPr sz="1800">
                 <a:latin typeface="TH Sarabun New"/>
               </a:defRPr>
             </a:pPr>
@@ -4416,9 +4422,9 @@
           <a:p>
             <a:pPr>
               <a:spcAft>
-                <a:spcPts val="200"/>
+                <a:spcPts val="300"/>
               </a:spcAft>
-              <a:defRPr sz="1400">
+              <a:defRPr sz="1800">
                 <a:latin typeface="TH Sarabun New"/>
               </a:defRPr>
             </a:pPr>
@@ -4442,9 +4448,9 @@
           <a:p>
             <a:pPr>
               <a:spcAft>
-                <a:spcPts val="200"/>
+                <a:spcPts val="300"/>
               </a:spcAft>
-              <a:defRPr sz="1400">
+              <a:defRPr sz="1800">
                 <a:latin typeface="TH Sarabun New"/>
               </a:defRPr>
             </a:pPr>
@@ -4468,9 +4474,9 @@
           <a:p>
             <a:pPr>
               <a:spcAft>
-                <a:spcPts val="200"/>
+                <a:spcPts val="300"/>
               </a:spcAft>
-              <a:defRPr sz="1400">
+              <a:defRPr sz="1800">
                 <a:latin typeface="TH Sarabun New"/>
               </a:defRPr>
             </a:pPr>
@@ -4547,7 +4553,7 @@
         <p:spPr>
           <a:xfrm>
             <a:off x="10980000" y="3528000"/>
-            <a:ext cx="9828000" cy="504000"/>
+            <a:ext cx="9828000" cy="612000"/>
           </a:xfrm>
           <a:prstGeom prst="rect">
             <a:avLst/>
@@ -4576,11 +4582,11 @@
           </a:fontRef>
         </p:style>
         <p:txBody>
-          <a:bodyPr rtlCol="0" anchor="ctr" wrap="square" lIns="288000" tIns="54000"/>
+          <a:bodyPr rtlCol="0" anchor="ctr" wrap="square" lIns="288000" tIns="72000"/>
           <a:lstStyle/>
           <a:p>
             <a:pPr algn="l">
-              <a:defRPr sz="2000" b="1">
+              <a:defRPr sz="2600" b="1">
                 <a:solidFill>
                   <a:srgbClr val="FFFFFF"/>
                 </a:solidFill>
@@ -4609,8 +4615,8 @@
         </p:blipFill>
         <p:spPr>
           <a:xfrm>
-            <a:off x="11196000" y="4068000"/>
-            <a:ext cx="9396000" cy="5400000"/>
+            <a:off x="11196000" y="4176000"/>
+            <a:ext cx="9396000" cy="4896000"/>
           </a:xfrm>
           <a:prstGeom prst="rect">
             <a:avLst/>
@@ -4625,8 +4631,8 @@
         </p:nvSpPr>
         <p:spPr>
           <a:xfrm>
-            <a:off x="11124000" y="9540000"/>
-            <a:ext cx="9540000" cy="2448000"/>
+            <a:off x="11124000" y="9144000"/>
+            <a:ext cx="9540000" cy="2880000"/>
           </a:xfrm>
           <a:prstGeom prst="rect">
             <a:avLst/>
@@ -4634,16 +4640,16 @@
           <a:noFill/>
         </p:spPr>
         <p:txBody>
-          <a:bodyPr wrap="square" lIns="72000" tIns="0">
+          <a:bodyPr wrap="square" lIns="108000" tIns="36000">
             <a:spAutoFit/>
           </a:bodyPr>
           <a:lstStyle/>
           <a:p>
             <a:pPr>
               <a:spcAft>
-                <a:spcPts val="200"/>
+                <a:spcPts val="300"/>
               </a:spcAft>
-              <a:defRPr sz="1400">
+              <a:defRPr sz="1800">
                 <a:latin typeface="TH Sarabun New"/>
               </a:defRPr>
             </a:pPr>
@@ -4667,9 +4673,9 @@
           <a:p>
             <a:pPr>
               <a:spcAft>
-                <a:spcPts val="200"/>
+                <a:spcPts val="300"/>
               </a:spcAft>
-              <a:defRPr sz="1400">
+              <a:defRPr sz="1800">
                 <a:latin typeface="TH Sarabun New"/>
               </a:defRPr>
             </a:pPr>
@@ -4693,9 +4699,9 @@
           <a:p>
             <a:pPr>
               <a:spcAft>
-                <a:spcPts val="200"/>
+                <a:spcPts val="300"/>
               </a:spcAft>
-              <a:defRPr sz="1400">
+              <a:defRPr sz="1800">
                 <a:latin typeface="TH Sarabun New"/>
               </a:defRPr>
             </a:pPr>
@@ -4719,9 +4725,9 @@
           <a:p>
             <a:pPr>
               <a:spcAft>
-                <a:spcPts val="200"/>
+                <a:spcPts val="300"/>
               </a:spcAft>
-              <a:defRPr sz="1400">
+              <a:defRPr sz="1800">
                 <a:latin typeface="TH Sarabun New"/>
               </a:defRPr>
             </a:pPr>
@@ -4798,7 +4804,7 @@
         <p:spPr>
           <a:xfrm>
             <a:off x="10980000" y="12276000"/>
-            <a:ext cx="9828000" cy="504000"/>
+            <a:ext cx="9828000" cy="612000"/>
           </a:xfrm>
           <a:prstGeom prst="rect">
             <a:avLst/>
@@ -4827,11 +4833,11 @@
           </a:fontRef>
         </p:style>
         <p:txBody>
-          <a:bodyPr rtlCol="0" anchor="ctr" wrap="square" lIns="288000" tIns="54000"/>
+          <a:bodyPr rtlCol="0" anchor="ctr" wrap="square" lIns="288000" tIns="72000"/>
           <a:lstStyle/>
           <a:p>
             <a:pPr algn="l">
-              <a:defRPr sz="2000" b="1">
+              <a:defRPr sz="2600" b="1">
                 <a:solidFill>
                   <a:srgbClr val="FFFFFF"/>
                 </a:solidFill>
@@ -4852,8 +4858,8 @@
         </p:nvSpPr>
         <p:spPr>
           <a:xfrm>
-            <a:off x="11124000" y="12816000"/>
-            <a:ext cx="3060000" cy="1224000"/>
+            <a:off x="11124000" y="12924000"/>
+            <a:ext cx="3060000" cy="1440000"/>
           </a:xfrm>
           <a:prstGeom prst="roundRect">
             <a:avLst/>
@@ -4886,7 +4892,10 @@
           <a:lstStyle/>
           <a:p>
             <a:pPr algn="ctr">
-              <a:defRPr sz="1700" b="1">
+              <a:spcAft>
+                <a:spcPts val="100"/>
+              </a:spcAft>
+              <a:defRPr sz="3200" b="1">
                 <a:solidFill>
                   <a:srgbClr val="047857"/>
                 </a:solidFill>
@@ -4899,7 +4908,7 @@
           </a:p>
           <a:p>
             <a:pPr algn="ctr">
-              <a:defRPr sz="1250" b="1">
+              <a:defRPr sz="1600" b="1">
                 <a:solidFill>
                   <a:srgbClr val="0F172A"/>
                 </a:solidFill>
@@ -4907,12 +4916,12 @@
               </a:defRPr>
             </a:pPr>
             <a:r>
-              <a:t>Sprint 13 Test Suite</a:t>
+              <a:t>Hermetic Test Suite</a:t>
             </a:r>
           </a:p>
           <a:p>
             <a:pPr algn="ctr">
-              <a:defRPr sz="1000">
+              <a:defRPr sz="1300">
                 <a:solidFill>
                   <a:srgbClr val="475569"/>
                 </a:solidFill>
@@ -4920,7 +4929,7 @@
               </a:defRPr>
             </a:pPr>
             <a:r>
-              <a:t>37 passed, 0 failed, 4 warnings (hermetic mocked suite)</a:t>
+              <a:t>37 passed, 0 failed, 4 warnings</a:t>
             </a:r>
           </a:p>
         </p:txBody>
@@ -4933,8 +4942,8 @@
         </p:nvSpPr>
         <p:spPr>
           <a:xfrm>
-            <a:off x="14400000" y="12816000"/>
-            <a:ext cx="3060000" cy="1224000"/>
+            <a:off x="14364000" y="12924000"/>
+            <a:ext cx="3060000" cy="1440000"/>
           </a:xfrm>
           <a:prstGeom prst="roundRect">
             <a:avLst/>
@@ -4967,7 +4976,10 @@
           <a:lstStyle/>
           <a:p>
             <a:pPr algn="ctr">
-              <a:defRPr sz="1700" b="1">
+              <a:spcAft>
+                <a:spcPts val="100"/>
+              </a:spcAft>
+              <a:defRPr sz="3200" b="1">
                 <a:solidFill>
                   <a:srgbClr val="0F172A"/>
                 </a:solidFill>
@@ -4980,7 +4992,7 @@
           </a:p>
           <a:p>
             <a:pPr algn="ctr">
-              <a:defRPr sz="1250" b="1">
+              <a:defRPr sz="1600" b="1">
                 <a:solidFill>
                   <a:srgbClr val="0F172A"/>
                 </a:solidFill>
@@ -4993,7 +5005,7 @@
           </a:p>
           <a:p>
             <a:pPr algn="ctr">
-              <a:defRPr sz="1000">
+              <a:defRPr sz="1300">
                 <a:solidFill>
                   <a:srgbClr val="475569"/>
                 </a:solidFill>
@@ -5001,7 +5013,7 @@
               </a:defRPr>
             </a:pPr>
             <a:r>
-              <a:t>34 System + 15 Application events (24h window)</a:t>
+              <a:t>34 System + 15 Application</a:t>
             </a:r>
           </a:p>
         </p:txBody>
@@ -5014,8 +5026,8 @@
         </p:nvSpPr>
         <p:spPr>
           <a:xfrm>
-            <a:off x="17676000" y="12816000"/>
-            <a:ext cx="3060000" cy="1224000"/>
+            <a:off x="17604000" y="12924000"/>
+            <a:ext cx="3060000" cy="1440000"/>
           </a:xfrm>
           <a:prstGeom prst="roundRect">
             <a:avLst/>
@@ -5048,7 +5060,10 @@
           <a:lstStyle/>
           <a:p>
             <a:pPr algn="ctr">
-              <a:defRPr sz="1700" b="1">
+              <a:spcAft>
+                <a:spcPts val="100"/>
+              </a:spcAft>
+              <a:defRPr sz="3200" b="1">
                 <a:solidFill>
                   <a:srgbClr val="047857"/>
                 </a:solidFill>
@@ -5061,7 +5076,7 @@
           </a:p>
           <a:p>
             <a:pPr algn="ctr">
-              <a:defRPr sz="1250" b="1">
+              <a:defRPr sz="1600" b="1">
                 <a:solidFill>
                   <a:srgbClr val="0F172A"/>
                 </a:solidFill>
@@ -5074,7 +5089,7 @@
           </a:p>
           <a:p>
             <a:pPr algn="ctr">
-              <a:defRPr sz="1000">
+              <a:defRPr sz="1300">
                 <a:solidFill>
                   <a:srgbClr val="475569"/>
                 </a:solidFill>
@@ -5082,7 +5097,7 @@
               </a:defRPr>
             </a:pPr>
             <a:r>
-              <a:t>10/10 prioritized events triaged (bounded cap &lt;= 10)</a:t>
+              <a:t>10/10 prioritized events triaged</a:t>
             </a:r>
           </a:p>
         </p:txBody>
@@ -5095,8 +5110,8 @@
         </p:nvSpPr>
         <p:spPr>
           <a:xfrm>
-            <a:off x="11124000" y="14184000"/>
-            <a:ext cx="3060000" cy="1224000"/>
+            <a:off x="11124000" y="14508000"/>
+            <a:ext cx="3060000" cy="1440000"/>
           </a:xfrm>
           <a:prstGeom prst="roundRect">
             <a:avLst/>
@@ -5129,7 +5144,10 @@
           <a:lstStyle/>
           <a:p>
             <a:pPr algn="ctr">
-              <a:defRPr sz="1700" b="1">
+              <a:spcAft>
+                <a:spcPts val="100"/>
+              </a:spcAft>
+              <a:defRPr sz="3200" b="1">
                 <a:solidFill>
                   <a:srgbClr val="047857"/>
                 </a:solidFill>
@@ -5142,7 +5160,7 @@
           </a:p>
           <a:p>
             <a:pPr algn="ctr">
-              <a:defRPr sz="1250" b="1">
+              <a:defRPr sz="1600" b="1">
                 <a:solidFill>
                   <a:srgbClr val="0F172A"/>
                 </a:solidFill>
@@ -5155,7 +5173,7 @@
           </a:p>
           <a:p>
             <a:pPr algn="ctr">
-              <a:defRPr sz="1000">
+              <a:defRPr sz="1300">
                 <a:solidFill>
                   <a:srgbClr val="475569"/>
                 </a:solidFill>
@@ -5163,7 +5181,7 @@
               </a:defRPr>
             </a:pPr>
             <a:r>
-              <a:t>GET /api/v1/history?asset_id=... returned asset records</a:t>
+              <a:t>GET /api/v1/history?asset_id=...</a:t>
             </a:r>
           </a:p>
         </p:txBody>
@@ -5176,8 +5194,8 @@
         </p:nvSpPr>
         <p:spPr>
           <a:xfrm>
-            <a:off x="14400000" y="14184000"/>
-            <a:ext cx="3060000" cy="1224000"/>
+            <a:off x="14364000" y="14508000"/>
+            <a:ext cx="3060000" cy="1440000"/>
           </a:xfrm>
           <a:prstGeom prst="roundRect">
             <a:avLst/>
@@ -5210,7 +5228,10 @@
           <a:lstStyle/>
           <a:p>
             <a:pPr algn="ctr">
-              <a:defRPr sz="1700" b="1">
+              <a:spcAft>
+                <a:spcPts val="100"/>
+              </a:spcAft>
+              <a:defRPr sz="3200" b="1">
                 <a:solidFill>
                   <a:srgbClr val="047857"/>
                 </a:solidFill>
@@ -5223,7 +5244,7 @@
           </a:p>
           <a:p>
             <a:pPr algn="ctr">
-              <a:defRPr sz="1250" b="1">
+              <a:defRPr sz="1600" b="1">
                 <a:solidFill>
                   <a:srgbClr val="0F172A"/>
                 </a:solidFill>
@@ -5231,12 +5252,12 @@
               </a:defRPr>
             </a:pPr>
             <a:r>
-              <a:t>Browser Runtime Verification</a:t>
+              <a:t>Browser Runtime Gate</a:t>
             </a:r>
           </a:p>
           <a:p>
             <a:pPr algn="ctr">
-              <a:defRPr sz="1000">
+              <a:defRPr sz="1300">
                 <a:solidFill>
                   <a:srgbClr val="475569"/>
                 </a:solidFill>
@@ -5244,7 +5265,7 @@
               </a:defRPr>
             </a:pPr>
             <a:r>
-              <a:t>Simultaneous display of 49 events and active AI findings</a:t>
+              <a:t>49 events + active AI findings</a:t>
             </a:r>
           </a:p>
         </p:txBody>
@@ -5257,8 +5278,8 @@
         </p:nvSpPr>
         <p:spPr>
           <a:xfrm>
-            <a:off x="17676000" y="14184000"/>
-            <a:ext cx="3060000" cy="1224000"/>
+            <a:off x="17604000" y="14508000"/>
+            <a:ext cx="3060000" cy="1440000"/>
           </a:xfrm>
           <a:prstGeom prst="roundRect">
             <a:avLst/>
@@ -5291,7 +5312,10 @@
           <a:lstStyle/>
           <a:p>
             <a:pPr algn="ctr">
-              <a:defRPr sz="1700" b="1">
+              <a:spcAft>
+                <a:spcPts val="100"/>
+              </a:spcAft>
+              <a:defRPr sz="3200" b="1">
                 <a:solidFill>
                   <a:srgbClr val="047857"/>
                 </a:solidFill>
@@ -5304,7 +5328,7 @@
           </a:p>
           <a:p>
             <a:pPr algn="ctr">
-              <a:defRPr sz="1250" b="1">
+              <a:defRPr sz="1600" b="1">
                 <a:solidFill>
                   <a:srgbClr val="0F172A"/>
                 </a:solidFill>
@@ -5317,7 +5341,7 @@
           </a:p>
           <a:p>
             <a:pPr algn="ctr">
-              <a:defRPr sz="1000">
+              <a:defRPr sz="1300">
                 <a:solidFill>
                   <a:srgbClr val="475569"/>
                 </a:solidFill>
@@ -5325,7 +5349,7 @@
               </a:defRPr>
             </a:pPr>
             <a:r>
-              <a:t>Strict tsc --noEmit &amp; Next.js production build PASS</a:t>
+              <a:t>Strict tsc &amp; Next.js build PASS</a:t>
             </a:r>
           </a:p>
         </p:txBody>
@@ -5338,8 +5362,8 @@
         </p:nvSpPr>
         <p:spPr>
           <a:xfrm>
-            <a:off x="11124000" y="15660000"/>
-            <a:ext cx="9540000" cy="3600000"/>
+            <a:off x="11124000" y="16200000"/>
+            <a:ext cx="9540000" cy="3096000"/>
           </a:xfrm>
           <a:prstGeom prst="rect">
             <a:avLst/>
@@ -5347,16 +5371,16 @@
           <a:noFill/>
         </p:spPr>
         <p:txBody>
-          <a:bodyPr wrap="square" lIns="72000" tIns="36000">
+          <a:bodyPr wrap="square" lIns="108000" tIns="36000">
             <a:spAutoFit/>
           </a:bodyPr>
           <a:lstStyle/>
           <a:p>
             <a:pPr>
               <a:spcAft>
-                <a:spcPts val="200"/>
+                <a:spcPts val="250"/>
               </a:spcAft>
-              <a:defRPr sz="1350">
+              <a:defRPr sz="1750">
                 <a:latin typeface="TH Sarabun New"/>
               </a:defRPr>
             </a:pPr>
@@ -5380,9 +5404,9 @@
           <a:p>
             <a:pPr>
               <a:spcAft>
-                <a:spcPts val="200"/>
+                <a:spcPts val="250"/>
               </a:spcAft>
-              <a:defRPr sz="1350">
+              <a:defRPr sz="1750">
                 <a:latin typeface="TH Sarabun New"/>
               </a:defRPr>
             </a:pPr>
@@ -5406,9 +5430,9 @@
           <a:p>
             <a:pPr>
               <a:spcAft>
-                <a:spcPts val="200"/>
+                <a:spcPts val="250"/>
               </a:spcAft>
-              <a:defRPr sz="1350">
+              <a:defRPr sz="1750">
                 <a:latin typeface="TH Sarabun New"/>
               </a:defRPr>
             </a:pPr>
@@ -5485,7 +5509,7 @@
         <p:spPr>
           <a:xfrm>
             <a:off x="10980000" y="19548000"/>
-            <a:ext cx="9828000" cy="504000"/>
+            <a:ext cx="9828000" cy="612000"/>
           </a:xfrm>
           <a:prstGeom prst="rect">
             <a:avLst/>
@@ -5514,11 +5538,11 @@
           </a:fontRef>
         </p:style>
         <p:txBody>
-          <a:bodyPr rtlCol="0" anchor="ctr" wrap="square" lIns="288000" tIns="54000"/>
+          <a:bodyPr rtlCol="0" anchor="ctr" wrap="square" lIns="288000" tIns="72000"/>
           <a:lstStyle/>
           <a:p>
             <a:pPr algn="l">
-              <a:defRPr sz="2000" b="1">
+              <a:defRPr sz="2600" b="1">
                 <a:solidFill>
                   <a:srgbClr val="FFFFFF"/>
                 </a:solidFill>
@@ -5539,8 +5563,8 @@
         </p:nvSpPr>
         <p:spPr>
           <a:xfrm>
-            <a:off x="11124000" y="20088000"/>
-            <a:ext cx="9540000" cy="3528000"/>
+            <a:off x="11124000" y="20196000"/>
+            <a:ext cx="9540000" cy="3420000"/>
           </a:xfrm>
           <a:prstGeom prst="rect">
             <a:avLst/>
@@ -5548,16 +5572,16 @@
           <a:noFill/>
         </p:spPr>
         <p:txBody>
-          <a:bodyPr wrap="square" lIns="72000" tIns="36000">
+          <a:bodyPr wrap="square" lIns="108000" tIns="36000">
             <a:spAutoFit/>
           </a:bodyPr>
           <a:lstStyle/>
           <a:p>
             <a:pPr>
               <a:spcAft>
-                <a:spcPts val="150"/>
+                <a:spcPts val="200"/>
               </a:spcAft>
-              <a:defRPr sz="1350">
+              <a:defRPr sz="1750">
                 <a:latin typeface="TH Sarabun New"/>
               </a:defRPr>
             </a:pPr>
@@ -5581,9 +5605,9 @@
           <a:p>
             <a:pPr>
               <a:spcAft>
-                <a:spcPts val="150"/>
+                <a:spcPts val="200"/>
               </a:spcAft>
-              <a:defRPr sz="1350">
+              <a:defRPr sz="1750">
                 <a:latin typeface="TH Sarabun New"/>
               </a:defRPr>
             </a:pPr>
@@ -5607,9 +5631,9 @@
           <a:p>
             <a:pPr>
               <a:spcAft>
-                <a:spcPts val="150"/>
+                <a:spcPts val="200"/>
               </a:spcAft>
-              <a:defRPr sz="1350">
+              <a:defRPr sz="1750">
                 <a:latin typeface="TH Sarabun New"/>
               </a:defRPr>
             </a:pPr>
@@ -5633,9 +5657,9 @@
           <a:p>
             <a:pPr>
               <a:spcAft>
-                <a:spcPts val="150"/>
+                <a:spcPts val="200"/>
               </a:spcAft>
-              <a:defRPr sz="1350">
+              <a:defRPr sz="1750">
                 <a:latin typeface="TH Sarabun New"/>
               </a:defRPr>
             </a:pPr>
@@ -5659,9 +5683,9 @@
           <a:p>
             <a:pPr>
               <a:spcAft>
-                <a:spcPts val="150"/>
+                <a:spcPts val="200"/>
               </a:spcAft>
-              <a:defRPr sz="1350">
+              <a:defRPr sz="1750">
                 <a:latin typeface="TH Sarabun New"/>
               </a:defRPr>
             </a:pPr>
@@ -5685,9 +5709,9 @@
           <a:p>
             <a:pPr>
               <a:spcAft>
-                <a:spcPts val="150"/>
+                <a:spcPts val="200"/>
               </a:spcAft>
-              <a:defRPr sz="1350">
+              <a:defRPr sz="1750">
                 <a:latin typeface="TH Sarabun New"/>
               </a:defRPr>
             </a:pPr>
@@ -5764,7 +5788,7 @@
         <p:spPr>
           <a:xfrm>
             <a:off x="10980000" y="23868000"/>
-            <a:ext cx="9828000" cy="504000"/>
+            <a:ext cx="9828000" cy="612000"/>
           </a:xfrm>
           <a:prstGeom prst="rect">
             <a:avLst/>
@@ -5793,11 +5817,11 @@
           </a:fontRef>
         </p:style>
         <p:txBody>
-          <a:bodyPr rtlCol="0" anchor="ctr" wrap="square" lIns="288000" tIns="54000"/>
+          <a:bodyPr rtlCol="0" anchor="ctr" wrap="square" lIns="288000" tIns="72000"/>
           <a:lstStyle/>
           <a:p>
             <a:pPr algn="l">
-              <a:defRPr sz="2000" b="1">
+              <a:defRPr sz="2600" b="1">
                 <a:solidFill>
                   <a:srgbClr val="FFFFFF"/>
                 </a:solidFill>
@@ -5818,8 +5842,8 @@
         </p:nvSpPr>
         <p:spPr>
           <a:xfrm>
-            <a:off x="11124000" y="24408000"/>
-            <a:ext cx="9540000" cy="5256000"/>
+            <a:off x="11124000" y="24516000"/>
+            <a:ext cx="9540000" cy="5148000"/>
           </a:xfrm>
           <a:prstGeom prst="rect">
             <a:avLst/>
@@ -5827,7 +5851,7 @@
           <a:noFill/>
         </p:spPr>
         <p:txBody>
-          <a:bodyPr wrap="square" lIns="72000" tIns="36000">
+          <a:bodyPr wrap="square" lIns="108000" tIns="36000">
             <a:spAutoFit/>
           </a:bodyPr>
           <a:lstStyle/>
@@ -5836,7 +5860,7 @@
               <a:spcAft>
                 <a:spcPts val="100"/>
               </a:spcAft>
-              <a:defRPr sz="1500" b="1">
+              <a:defRPr sz="1900" b="1">
                 <a:solidFill>
                   <a:srgbClr val="0F172A"/>
                 </a:solidFill>
@@ -5844,71 +5868,111 @@
               </a:defRPr>
             </a:pPr>
             <a:r>
-              <a:t>Summary of Achievements:</a:t>
+              <a:t>Summary of Key Achievements:</a:t>
             </a:r>
           </a:p>
           <a:p>
             <a:pPr>
               <a:spcAft>
-                <a:spcPts val="100"/>
+                <a:spcPts val="150"/>
               </a:spcAft>
-              <a:defRPr sz="1350">
+              <a:defRPr sz="1700">
+                <a:latin typeface="TH Sarabun New"/>
+              </a:defRPr>
+            </a:pPr>
+            <a:r>
+              <a:rPr b="1">
+                <a:solidFill>
+                  <a:srgbClr val="0F172A"/>
+                </a:solidFill>
+              </a:rPr>
+              <a:t>• Centralized Infrastructure Governance: </a:t>
+            </a:r>
+            <a:r>
+              <a:rPr b="0">
                 <a:solidFill>
                   <a:srgbClr val="000000"/>
                 </a:solidFill>
-                <a:latin typeface="TH Sarabun New"/>
-              </a:defRPr>
-            </a:pPr>
-            <a:r>
-              <a:t>• Centralized Infrastructure Governance: Unified asset tracking anchored by cryptographic hardware composite fingerprints.</a:t>
+              </a:rPr>
+              <a:t>Unified asset tracking anchored by cryptographic hardware composite fingerprints.</a:t>
             </a:r>
           </a:p>
           <a:p>
             <a:pPr>
               <a:spcAft>
-                <a:spcPts val="100"/>
+                <a:spcPts val="150"/>
               </a:spcAft>
-              <a:defRPr sz="1350">
+              <a:defRPr sz="1700">
+                <a:latin typeface="TH Sarabun New"/>
+              </a:defRPr>
+            </a:pPr>
+            <a:r>
+              <a:rPr b="1">
+                <a:solidFill>
+                  <a:srgbClr val="0F172A"/>
+                </a:solidFill>
+              </a:rPr>
+              <a:t>• Air-Gapped Evidence Acquisition: </a:t>
+            </a:r>
+            <a:r>
+              <a:rPr b="0">
                 <a:solidFill>
                   <a:srgbClr val="000000"/>
                 </a:solidFill>
-                <a:latin typeface="TH Sarabun New"/>
-              </a:defRPr>
-            </a:pPr>
-            <a:r>
-              <a:t>• Air-Gapped Evidence Acquisition: Non-destructive offline collection utilizing self-contained embedded CPython 3.14.3.</a:t>
+              </a:rPr>
+              <a:t>Non-destructive offline collection utilizing self-contained embedded CPython 3.14.3.</a:t>
             </a:r>
           </a:p>
           <a:p>
             <a:pPr>
               <a:spcAft>
-                <a:spcPts val="100"/>
+                <a:spcPts val="150"/>
               </a:spcAft>
-              <a:defRPr sz="1350">
+              <a:defRPr sz="1700">
+                <a:latin typeface="TH Sarabun New"/>
+              </a:defRPr>
+            </a:pPr>
+            <a:r>
+              <a:rPr b="1">
+                <a:solidFill>
+                  <a:srgbClr val="0F172A"/>
+                </a:solidFill>
+              </a:rPr>
+              <a:t>• Deterministic Deduplication &amp; Bounded Triage: </a:t>
+            </a:r>
+            <a:r>
+              <a:rPr b="0">
                 <a:solidFill>
                   <a:srgbClr val="000000"/>
                 </a:solidFill>
-                <a:latin typeface="TH Sarabun New"/>
-              </a:defRPr>
-            </a:pPr>
-            <a:r>
-              <a:t>• Deterministic Deduplication &amp; Bounded Triage: Enforced sequential SHA-256 event fingerprinting and 10-event RAG triage.</a:t>
+              </a:rPr>
+              <a:t>Enforced sequential SHA-256 event fingerprinting and 10-event RAG triage.</a:t>
             </a:r>
           </a:p>
           <a:p>
             <a:pPr>
               <a:spcAft>
-                <a:spcPts val="100"/>
+                <a:spcPts val="150"/>
               </a:spcAft>
-              <a:defRPr sz="1350">
+              <a:defRPr sz="1700">
+                <a:latin typeface="TH Sarabun New"/>
+              </a:defRPr>
+            </a:pPr>
+            <a:r>
+              <a:rPr b="1">
+                <a:solidFill>
+                  <a:srgbClr val="0F172A"/>
+                </a:solidFill>
+              </a:rPr>
+              <a:t>• Empirically Validated Pipeline: </a:t>
+            </a:r>
+            <a:r>
+              <a:rPr b="0">
                 <a:solidFill>
                   <a:srgbClr val="000000"/>
                 </a:solidFill>
-                <a:latin typeface="TH Sarabun New"/>
-              </a:defRPr>
-            </a:pPr>
-            <a:r>
-              <a:t>• Empirically Validated Pipeline: Confirmed end-to-end data integrity across 49 field events, HTTP 200 API, and Gate A9.</a:t>
+              </a:rPr>
+              <a:t>Confirmed end-to-end data integrity across 49 field events, HTTP 200 API, and Gate A9.</a:t>
             </a:r>
           </a:p>
           <a:p>
@@ -5919,7 +5983,7 @@
               <a:spcAft>
                 <a:spcPts val="100"/>
               </a:spcAft>
-              <a:defRPr sz="1500" b="1">
+              <a:defRPr sz="1900" b="1">
                 <a:solidFill>
                   <a:srgbClr val="0F172A"/>
                 </a:solidFill>
@@ -5933,65 +5997,105 @@
           <a:p>
             <a:pPr>
               <a:spcAft>
-                <a:spcPts val="100"/>
+                <a:spcPts val="150"/>
               </a:spcAft>
-              <a:defRPr sz="1350">
+              <a:defRPr sz="1700">
+                <a:latin typeface="TH Sarabun New"/>
+              </a:defRPr>
+            </a:pPr>
+            <a:r>
+              <a:rPr b="1">
+                <a:solidFill>
+                  <a:srgbClr val="0F172A"/>
+                </a:solidFill>
+              </a:rPr>
+              <a:t>• Database-Level Concurrency: </a:t>
+            </a:r>
+            <a:r>
+              <a:rPr b="0">
                 <a:solidFill>
                   <a:srgbClr val="000000"/>
                 </a:solidFill>
-                <a:latin typeface="TH Sarabun New"/>
-              </a:defRPr>
-            </a:pPr>
-            <a:r>
-              <a:t>• Database-Level Concurrency: Enforce PostgreSQL composite UNIQUE constraints with ON CONFLICT DO NOTHING for parallel imports.</a:t>
+              </a:rPr>
+              <a:t>Enforce PostgreSQL composite UNIQUE constraints with ON CONFLICT DO NOTHING for parallel imports.</a:t>
             </a:r>
           </a:p>
           <a:p>
             <a:pPr>
               <a:spcAft>
-                <a:spcPts val="100"/>
+                <a:spcPts val="150"/>
               </a:spcAft>
-              <a:defRPr sz="1350">
+              <a:defRPr sz="1700">
+                <a:latin typeface="TH Sarabun New"/>
+              </a:defRPr>
+            </a:pPr>
+            <a:r>
+              <a:rPr b="1">
+                <a:solidFill>
+                  <a:srgbClr val="0F172A"/>
+                </a:solidFill>
+              </a:rPr>
+              <a:t>• Cross-Endpoint Event Correlation: </a:t>
+            </a:r>
+            <a:r>
+              <a:rPr b="0">
                 <a:solidFill>
                   <a:srgbClr val="000000"/>
                 </a:solidFill>
-                <a:latin typeface="TH Sarabun New"/>
-              </a:defRPr>
-            </a:pPr>
-            <a:r>
-              <a:t>• Cross-Endpoint Event Correlation: Implement multi-host temporal clustering to detect infrastructure-wide incident chains.</a:t>
+              </a:rPr>
+              <a:t>Implement multi-host temporal clustering to detect infrastructure-wide incident chains.</a:t>
             </a:r>
           </a:p>
           <a:p>
             <a:pPr>
               <a:spcAft>
-                <a:spcPts val="100"/>
+                <a:spcPts val="150"/>
               </a:spcAft>
-              <a:defRPr sz="1350">
+              <a:defRPr sz="1700">
+                <a:latin typeface="TH Sarabun New"/>
+              </a:defRPr>
+            </a:pPr>
+            <a:r>
+              <a:rPr b="1">
+                <a:solidFill>
+                  <a:srgbClr val="0F172A"/>
+                </a:solidFill>
+              </a:rPr>
+              <a:t>• Enterprise Directory Federation: </a:t>
+            </a:r>
+            <a:r>
+              <a:rPr b="0">
                 <a:solidFill>
                   <a:srgbClr val="000000"/>
                 </a:solidFill>
-                <a:latin typeface="TH Sarabun New"/>
-              </a:defRPr>
-            </a:pPr>
-            <a:r>
-              <a:t>• Enterprise Directory Federation: Integrate SAML 2.0 / OIDC single sign-on with corporate Active Directory domain controllers.</a:t>
+              </a:rPr>
+              <a:t>Integrate SAML 2.0 / OIDC single sign-on with corporate Active Directory domain controllers.</a:t>
             </a:r>
           </a:p>
           <a:p>
             <a:pPr>
               <a:spcAft>
-                <a:spcPts val="100"/>
+                <a:spcPts val="150"/>
               </a:spcAft>
-              <a:defRPr sz="1350">
+              <a:defRPr sz="1700">
+                <a:latin typeface="TH Sarabun New"/>
+              </a:defRPr>
+            </a:pPr>
+            <a:r>
+              <a:rPr b="1">
+                <a:solidFill>
+                  <a:srgbClr val="0F172A"/>
+                </a:solidFill>
+              </a:rPr>
+              <a:t>• Cross-Platform Collection: </a:t>
+            </a:r>
+            <a:r>
+              <a:rPr b="0">
                 <a:solidFill>
                   <a:srgbClr val="000000"/>
                 </a:solidFill>
-                <a:latin typeface="TH Sarabun New"/>
-              </a:defRPr>
-            </a:pPr>
-            <a:r>
-              <a:t>• Cross-Platform Collection: Develop lightweight portable collectors for Linux systemd journals and macOS logging subsystems.</a:t>
+              </a:rPr>
+              <a:t>Develop lightweight portable collectors for Linux systemd journals and macOS logging subsystems.</a:t>
             </a:r>
           </a:p>
         </p:txBody>

</xml_diff>

<commit_message>
docs(poster): align final poster with KMITL example
</commit_message>
<xml_diff>
--- a/docs/poster/EIMS_COOP_POSTER_2026.pptx
+++ b/docs/poster/EIMS_COOP_POSTER_2026.pptx
@@ -3126,14 +3126,99 @@
           </a:fontRef>
         </p:style>
         <p:txBody>
-          <a:bodyPr rtlCol="0" anchor="ctr" wrap="square" lIns="288000" rIns="288000" tIns="180000" bIns="144000"/>
+          <a:bodyPr rtlCol="0" anchor="ctr"/>
+          <a:lstStyle/>
+          <a:p>
+            <a:pPr algn="ctr"/>
+          </a:p>
+        </p:txBody>
+      </p:sp>
+      <p:sp>
+        <p:nvSpPr>
+          <p:cNvPr id="3" name="Rounded Rectangle 2"/>
+          <p:cNvSpPr/>
+          <p:nvPr/>
+        </p:nvSpPr>
+        <p:spPr>
+          <a:xfrm>
+            <a:off x="792000" y="540000"/>
+            <a:ext cx="1224000" cy="1224000"/>
+          </a:xfrm>
+          <a:prstGeom prst="roundRect">
+            <a:avLst/>
+          </a:prstGeom>
+          <a:solidFill>
+            <a:srgbClr val="1E293B"/>
+          </a:solidFill>
+          <a:ln w="19050">
+            <a:solidFill>
+              <a:srgbClr val="94A3B8"/>
+            </a:solidFill>
+          </a:ln>
+        </p:spPr>
+        <p:style>
+          <a:lnRef idx="1">
+            <a:schemeClr val="accent1"/>
+          </a:lnRef>
+          <a:fillRef idx="3">
+            <a:schemeClr val="accent1"/>
+          </a:fillRef>
+          <a:effectRef idx="2">
+            <a:schemeClr val="accent1"/>
+          </a:effectRef>
+          <a:fontRef idx="minor">
+            <a:schemeClr val="lt1"/>
+          </a:fontRef>
+        </p:style>
+        <p:txBody>
+          <a:bodyPr rtlCol="0" anchor="ctr" wrap="square" lIns="36000" rIns="36000" tIns="180000"/>
+          <a:lstStyle/>
+          <a:p>
+            <a:pPr algn="ctr">
+              <a:defRPr sz="1200" b="1">
+                <a:solidFill>
+                  <a:srgbClr val="E2E8F0"/>
+                </a:solidFill>
+                <a:latin typeface="TH Sarabun New"/>
+              </a:defRPr>
+            </a:pPr>
+            <a:r>
+              <a:t>KMITL</a:t>
+            </a:r>
+            <a:br/>
+            <a:r>
+              <a:t>SEAL</a:t>
+            </a:r>
+          </a:p>
+        </p:txBody>
+      </p:sp>
+      <p:sp>
+        <p:nvSpPr>
+          <p:cNvPr id="4" name="TextBox 3"/>
+          <p:cNvSpPr txBox="1"/>
+          <p:nvPr/>
+        </p:nvSpPr>
+        <p:spPr>
+          <a:xfrm>
+            <a:off x="2088000" y="360000"/>
+            <a:ext cx="18504000" cy="2952000"/>
+          </a:xfrm>
+          <a:prstGeom prst="rect">
+            <a:avLst/>
+          </a:prstGeom>
+          <a:noFill/>
+        </p:spPr>
+        <p:txBody>
+          <a:bodyPr wrap="square" lIns="144000" rIns="216000" tIns="108000" bIns="72000">
+            <a:spAutoFit/>
+          </a:bodyPr>
           <a:lstStyle/>
           <a:p>
             <a:pPr algn="ctr">
               <a:spcAft>
-                <a:spcPts val="200"/>
+                <a:spcPts val="100"/>
               </a:spcAft>
-              <a:defRPr sz="1950" b="1">
+              <a:defRPr sz="1500" b="1">
                 <a:solidFill>
                   <a:srgbClr val="94A3B8"/>
                 </a:solidFill>
@@ -3142,6 +3227,10 @@
             </a:pPr>
             <a:r>
               <a:t>FACULTY OF ENGINEERING • KING MONGKUT'S INSTITUTE OF TECHNOLOGY LADKRABANG</a:t>
+            </a:r>
+            <a:br/>
+            <a:r>
+              <a:t>COMPUTER ENGINEERING (INTERNATIONAL PROGRAM) • COOPERATIVE EDUCATION 2026</a:t>
             </a:r>
           </a:p>
           <a:p>
@@ -3152,7 +3241,7 @@
               <a:spcAft>
                 <a:spcPts val="200"/>
               </a:spcAft>
-              <a:defRPr sz="5000" b="1">
+              <a:defRPr sz="4000" b="1">
                 <a:solidFill>
                   <a:srgbClr val="FFFFFF"/>
                 </a:solidFill>
@@ -3168,7 +3257,7 @@
               <a:spcAft>
                 <a:spcPts val="100"/>
               </a:spcAft>
-              <a:defRPr sz="2000" b="1">
+              <a:defRPr sz="1700" b="1">
                 <a:solidFill>
                   <a:srgbClr val="E2E8F0"/>
                 </a:solidFill>
@@ -3176,12 +3265,12 @@
               </a:defRPr>
             </a:pPr>
             <a:r>
-              <a:t>Author: Ratthabhumi Peansukmanee (Student ID: 66011198) | Computer Engineering (International Program)</a:t>
+              <a:t>Student: Ratthabhumi Peansukmanee (Student ID: 66011198) | Project Advisor: Asst. Prof. Dr. Phongsak Keeratiwintakorn</a:t>
             </a:r>
           </a:p>
           <a:p>
             <a:pPr algn="ctr">
-              <a:defRPr sz="1800">
+              <a:defRPr sz="1550">
                 <a:solidFill>
                   <a:srgbClr val="CBD5E1"/>
                 </a:solidFill>
@@ -3189,21 +3278,21 @@
               </a:defRPr>
             </a:pPr>
             <a:r>
-              <a:t>Host Enterprise: KANEMATSU ELECTRONICS (THAILAND) | Workplace Supervisor: Mr. Chalermpol Phuangchalam | Academic Supervisor: Asst. Prof. Dr. Phongsak Keeratiwintakorn</a:t>
-            </a:r>
-          </a:p>
-        </p:txBody>
-      </p:sp>
-      <p:sp>
-        <p:nvSpPr>
-          <p:cNvPr id="3" name="Rounded Rectangle 2"/>
+              <a:t>Host Enterprise: KANEMATSU ELECTRONICS (THAILAND) | Workplace Supervisor: Mr. Chalermpol Phuangchalam</a:t>
+            </a:r>
+          </a:p>
+        </p:txBody>
+      </p:sp>
+      <p:sp>
+        <p:nvSpPr>
+          <p:cNvPr id="5" name="Rounded Rectangle 4"/>
           <p:cNvSpPr/>
           <p:nvPr/>
         </p:nvSpPr>
         <p:spPr>
           <a:xfrm>
             <a:off x="576000" y="3528000"/>
-            <a:ext cx="9828000" cy="2772000"/>
+            <a:ext cx="6408000" cy="5184000"/>
           </a:xfrm>
           <a:prstGeom prst="roundRect">
             <a:avLst/>
@@ -3241,14 +3330,14 @@
       </p:sp>
       <p:sp>
         <p:nvSpPr>
-          <p:cNvPr id="4" name="Rectangle 3"/>
+          <p:cNvPr id="6" name="Rectangle 5"/>
           <p:cNvSpPr/>
           <p:nvPr/>
         </p:nvSpPr>
         <p:spPr>
           <a:xfrm>
             <a:off x="576000" y="3528000"/>
-            <a:ext cx="9828000" cy="612000"/>
+            <a:ext cx="6408000" cy="540000"/>
           </a:xfrm>
           <a:prstGeom prst="rect">
             <a:avLst/>
@@ -3277,11 +3366,11 @@
           </a:fontRef>
         </p:style>
         <p:txBody>
-          <a:bodyPr rtlCol="0" anchor="ctr" wrap="square" lIns="288000" tIns="72000"/>
+          <a:bodyPr rtlCol="0" anchor="ctr" wrap="square" lIns="180000" tIns="54000"/>
           <a:lstStyle/>
           <a:p>
             <a:pPr algn="l">
-              <a:defRPr sz="2600" b="1">
+              <a:defRPr sz="2100" b="1">
                 <a:solidFill>
                   <a:srgbClr val="FFFFFF"/>
                 </a:solidFill>
@@ -3289,21 +3378,21 @@
               </a:defRPr>
             </a:pPr>
             <a:r>
-              <a:t>1. Background &amp; Problem Statement</a:t>
-            </a:r>
-          </a:p>
-        </p:txBody>
-      </p:sp>
-      <p:sp>
-        <p:nvSpPr>
-          <p:cNvPr id="5" name="TextBox 4"/>
+              <a:t>1. Abstract</a:t>
+            </a:r>
+          </a:p>
+        </p:txBody>
+      </p:sp>
+      <p:sp>
+        <p:nvSpPr>
+          <p:cNvPr id="7" name="TextBox 6"/>
           <p:cNvSpPr txBox="1"/>
           <p:nvPr/>
         </p:nvSpPr>
         <p:spPr>
           <a:xfrm>
-            <a:off x="720000" y="4176000"/>
-            <a:ext cx="9540000" cy="2052000"/>
+            <a:off x="684000" y="4140000"/>
+            <a:ext cx="6192000" cy="4464000"/>
           </a:xfrm>
           <a:prstGeom prst="rect">
             <a:avLst/>
@@ -3311,126 +3400,38 @@
           <a:noFill/>
         </p:spPr>
         <p:txBody>
-          <a:bodyPr wrap="square" lIns="108000" tIns="36000">
+          <a:bodyPr wrap="square" lIns="72000" tIns="72000">
             <a:spAutoFit/>
           </a:bodyPr>
           <a:lstStyle/>
           <a:p>
             <a:pPr>
               <a:spcAft>
-                <a:spcPts val="350"/>
+                <a:spcPts val="200"/>
               </a:spcAft>
-              <a:defRPr sz="1900">
-                <a:latin typeface="TH Sarabun New"/>
-              </a:defRPr>
-            </a:pPr>
-            <a:r>
-              <a:rPr b="1">
-                <a:solidFill>
-                  <a:srgbClr val="0F172A"/>
-                </a:solidFill>
-              </a:rPr>
-              <a:t>• Network Enclave Isolation: </a:t>
-            </a:r>
-            <a:r>
-              <a:rPr b="0">
+              <a:defRPr sz="1550">
                 <a:solidFill>
                   <a:srgbClr val="000000"/>
                 </a:solidFill>
-              </a:rPr>
-              <a:t>High-security enterprise servers prohibit continuous outbound monitoring connections.</a:t>
-            </a:r>
-          </a:p>
-          <a:p>
-            <a:pPr>
-              <a:spcAft>
-                <a:spcPts val="350"/>
-              </a:spcAft>
-              <a:defRPr sz="1900">
-                <a:latin typeface="TH Sarabun New"/>
-              </a:defRPr>
-            </a:pPr>
-            <a:r>
-              <a:rPr b="1">
-                <a:solidFill>
-                  <a:srgbClr val="0F172A"/>
-                </a:solidFill>
-              </a:rPr>
-              <a:t>• Fragile Ephemeral Identity: </a:t>
-            </a:r>
-            <a:r>
-              <a:rPr b="0">
-                <a:solidFill>
-                  <a:srgbClr val="000000"/>
-                </a:solidFill>
-              </a:rPr>
-              <a:t>DHCP leases and host renames break asset history without hardware-anchored identity.</a:t>
-            </a:r>
-          </a:p>
-          <a:p>
-            <a:pPr>
-              <a:spcAft>
-                <a:spcPts val="350"/>
-              </a:spcAft>
-              <a:defRPr sz="1900">
-                <a:latin typeface="TH Sarabun New"/>
-              </a:defRPr>
-            </a:pPr>
-            <a:r>
-              <a:rPr b="1">
-                <a:solidFill>
-                  <a:srgbClr val="0F172A"/>
-                </a:solidFill>
-              </a:rPr>
-              <a:t>• Manual Diagnostic Friction: </a:t>
-            </a:r>
-            <a:r>
-              <a:rPr b="0">
-                <a:solidFill>
-                  <a:srgbClr val="000000"/>
-                </a:solidFill>
-              </a:rPr>
-              <a:t>Ad-hoc scripts produce fragmented, unverified diagnostic notes without provenance.</a:t>
-            </a:r>
-          </a:p>
-          <a:p>
-            <a:pPr>
-              <a:spcAft>
-                <a:spcPts val="350"/>
-              </a:spcAft>
-              <a:defRPr sz="1900">
-                <a:latin typeface="TH Sarabun New"/>
-              </a:defRPr>
-            </a:pPr>
-            <a:r>
-              <a:rPr b="1">
-                <a:solidFill>
-                  <a:srgbClr val="0F172A"/>
-                </a:solidFill>
-              </a:rPr>
-              <a:t>• Telemetry Volume Overload: </a:t>
-            </a:r>
-            <a:r>
-              <a:rPr b="0">
-                <a:solidFill>
-                  <a:srgbClr val="000000"/>
-                </a:solidFill>
-              </a:rPr>
-              <a:t>Windows Event Logs generate thousands of routine records daily, slowing fault triage.</a:t>
-            </a:r>
-          </a:p>
-        </p:txBody>
-      </p:sp>
-      <p:sp>
-        <p:nvSpPr>
-          <p:cNvPr id="6" name="Rounded Rectangle 5"/>
+                <a:latin typeface="TH Sarabun New"/>
+              </a:defRPr>
+            </a:pPr>
+            <a:r>
+              <a:t>Enterprise infrastructure auditing across isolated corporate networks is hindered by air-gapped endpoints and fragmented diagnostic records. When failures occur on hosts lacking persistent agents, administrators face manual triage without verifiable traceability. The Enterprise Infrastructure Management System (EIMS) addresses this challenge through an integrated evidence management and AI-assisted investigation platform. EIMS combines a central PostgreSQL asset registry with a portable USB collector powered by embedded CPython 3.14.3, extracting non-destructive WMI telemetry and Windows Event Logs (System and Application channels, default maximum 500 events) into schema-validated JSON reports. Upon ingestion, sequential SHA-256 deduplication and bounded semantic retrieval triage prioritized events (cap &lt;= 10). Empirical validation confirmed end-to-end data flow across 49 persisted field events, 10 AnalysisHistory records, HTTP 200 API responses, and browser runtime verification (A9 PASS).</a:t>
+            </a:r>
+          </a:p>
+        </p:txBody>
+      </p:sp>
+      <p:sp>
+        <p:nvSpPr>
+          <p:cNvPr id="8" name="Rounded Rectangle 7"/>
           <p:cNvSpPr/>
           <p:nvPr/>
         </p:nvSpPr>
         <p:spPr>
           <a:xfrm>
-            <a:off x="576000" y="6480000"/>
-            <a:ext cx="9828000" cy="3528000"/>
+            <a:off x="576000" y="8928000"/>
+            <a:ext cx="6408000" cy="7920000"/>
           </a:xfrm>
           <a:prstGeom prst="roundRect">
             <a:avLst/>
@@ -3468,14 +3469,14 @@
       </p:sp>
       <p:sp>
         <p:nvSpPr>
-          <p:cNvPr id="7" name="Rectangle 6"/>
+          <p:cNvPr id="9" name="Rectangle 8"/>
           <p:cNvSpPr/>
           <p:nvPr/>
         </p:nvSpPr>
         <p:spPr>
           <a:xfrm>
-            <a:off x="576000" y="6480000"/>
-            <a:ext cx="9828000" cy="612000"/>
+            <a:off x="576000" y="8928000"/>
+            <a:ext cx="6408000" cy="540000"/>
           </a:xfrm>
           <a:prstGeom prst="rect">
             <a:avLst/>
@@ -3504,11 +3505,11 @@
           </a:fontRef>
         </p:style>
         <p:txBody>
-          <a:bodyPr rtlCol="0" anchor="ctr" wrap="square" lIns="288000" tIns="72000"/>
+          <a:bodyPr rtlCol="0" anchor="ctr" wrap="square" lIns="180000" tIns="54000"/>
           <a:lstStyle/>
           <a:p>
             <a:pPr algn="l">
-              <a:defRPr sz="2600" b="1">
+              <a:defRPr sz="2100" b="1">
                 <a:solidFill>
                   <a:srgbClr val="FFFFFF"/>
                 </a:solidFill>
@@ -3516,21 +3517,21 @@
               </a:defRPr>
             </a:pPr>
             <a:r>
-              <a:t>2. Project Engineering Objectives (Chapter 1)</a:t>
-            </a:r>
-          </a:p>
-        </p:txBody>
-      </p:sp>
-      <p:sp>
-        <p:nvSpPr>
-          <p:cNvPr id="8" name="TextBox 7"/>
+              <a:t>2. Background &amp; Problem Statement</a:t>
+            </a:r>
+          </a:p>
+        </p:txBody>
+      </p:sp>
+      <p:sp>
+        <p:nvSpPr>
+          <p:cNvPr id="10" name="TextBox 9"/>
           <p:cNvSpPr txBox="1"/>
           <p:nvPr/>
         </p:nvSpPr>
         <p:spPr>
           <a:xfrm>
-            <a:off x="720000" y="7128000"/>
-            <a:ext cx="9540000" cy="2808000"/>
+            <a:off x="684000" y="9540000"/>
+            <a:ext cx="6192000" cy="7200000"/>
           </a:xfrm>
           <a:prstGeom prst="rect">
             <a:avLst/>
@@ -3538,16 +3539,16 @@
           <a:noFill/>
         </p:spPr>
         <p:txBody>
-          <a:bodyPr wrap="square" lIns="108000" tIns="36000">
+          <a:bodyPr wrap="square" lIns="72000" tIns="72000">
             <a:spAutoFit/>
           </a:bodyPr>
           <a:lstStyle/>
           <a:p>
             <a:pPr>
               <a:spcAft>
-                <a:spcPts val="250"/>
+                <a:spcPts val="900"/>
               </a:spcAft>
-              <a:defRPr sz="1750">
+              <a:defRPr sz="1550">
                 <a:latin typeface="TH Sarabun New"/>
               </a:defRPr>
             </a:pPr>
@@ -3557,7 +3558,7 @@
                   <a:srgbClr val="0F172A"/>
                 </a:solidFill>
               </a:rPr>
-              <a:t>• OBJ-1 Central Asset Registry: </a:t>
+              <a:t>• Disconnected &amp; Enclave Isolation: </a:t>
             </a:r>
             <a:r>
               <a:rPr b="0">
@@ -3565,15 +3566,15 @@
                   <a:srgbClr val="000000"/>
                 </a:solidFill>
               </a:rPr>
-              <a:t>Hardware composite fingerprints anchoring canonical server identity.</a:t>
+              <a:t>High-security enterprise servers prohibit continuous outbound monitoring connections to central services.</a:t>
             </a:r>
           </a:p>
           <a:p>
             <a:pPr>
               <a:spcAft>
-                <a:spcPts val="250"/>
+                <a:spcPts val="900"/>
               </a:spcAft>
-              <a:defRPr sz="1750">
+              <a:defRPr sz="1550">
                 <a:latin typeface="TH Sarabun New"/>
               </a:defRPr>
             </a:pPr>
@@ -3583,7 +3584,7 @@
                   <a:srgbClr val="0F172A"/>
                 </a:solidFill>
               </a:rPr>
-              <a:t>• OBJ-2 Portable USB Auditor: </a:t>
+              <a:t>• Fragile Ephemeral Tracking: </a:t>
             </a:r>
             <a:r>
               <a:rPr b="0">
@@ -3591,15 +3592,15 @@
                   <a:srgbClr val="000000"/>
                 </a:solidFill>
               </a:rPr>
-              <a:t>Embedded CPython 3.14.3 runtime executing non-destructive read-only queries.</a:t>
+              <a:t>Dynamic DHCP IP churn and host renames disrupt historical telemetry without hardware-anchored identity.</a:t>
             </a:r>
           </a:p>
           <a:p>
             <a:pPr>
               <a:spcAft>
-                <a:spcPts val="250"/>
+                <a:spcPts val="900"/>
               </a:spcAft>
-              <a:defRPr sz="1750">
+              <a:defRPr sz="1550">
                 <a:latin typeface="TH Sarabun New"/>
               </a:defRPr>
             </a:pPr>
@@ -3609,7 +3610,7 @@
                   <a:srgbClr val="0F172A"/>
                 </a:solidFill>
               </a:rPr>
-              <a:t>• OBJ-3 Offline Ingestion Pipeline: </a:t>
+              <a:t>• Manual Diagnostic Friction: </a:t>
             </a:r>
             <a:r>
               <a:rPr b="0">
@@ -3617,15 +3618,15 @@
                   <a:srgbClr val="000000"/>
                 </a:solidFill>
               </a:rPr>
-              <a:t>Schema-validated normalization of offline JSON evidence reports.</a:t>
+              <a:t>Ad-hoc scripts produce fragmented diagnostic notes without verifiable provenance across server fleets.</a:t>
             </a:r>
           </a:p>
           <a:p>
             <a:pPr>
               <a:spcAft>
-                <a:spcPts val="250"/>
+                <a:spcPts val="900"/>
               </a:spcAft>
-              <a:defRPr sz="1750">
+              <a:defRPr sz="1550">
                 <a:latin typeface="TH Sarabun New"/>
               </a:defRPr>
             </a:pPr>
@@ -3635,7 +3636,7 @@
                   <a:srgbClr val="0F172A"/>
                 </a:solidFill>
               </a:rPr>
-              <a:t>• OBJ-4 Deterministic Deduplication: </a:t>
+              <a:t>• Telemetry Volume Overload: </a:t>
             </a:r>
             <a:r>
               <a:rPr b="0">
@@ -3643,99 +3644,21 @@
                   <a:srgbClr val="000000"/>
                 </a:solidFill>
               </a:rPr>
-              <a:t>Application-level sequential SHA-256 deduplication and severity queue.</a:t>
-            </a:r>
-          </a:p>
-          <a:p>
-            <a:pPr>
-              <a:spcAft>
-                <a:spcPts val="250"/>
-              </a:spcAft>
-              <a:defRPr sz="1750">
-                <a:latin typeface="TH Sarabun New"/>
-              </a:defRPr>
-            </a:pPr>
-            <a:r>
-              <a:rPr b="1">
-                <a:solidFill>
-                  <a:srgbClr val="0F172A"/>
-                </a:solidFill>
-              </a:rPr>
-              <a:t>• OBJ-5 Bounded AI Investigation: </a:t>
-            </a:r>
-            <a:r>
-              <a:rPr b="0">
-                <a:solidFill>
-                  <a:srgbClr val="000000"/>
-                </a:solidFill>
-              </a:rPr>
-              <a:t>pgvector cosine similarity retrieval for prioritized events (cap &lt;= 10).</a:t>
-            </a:r>
-          </a:p>
-          <a:p>
-            <a:pPr>
-              <a:spcAft>
-                <a:spcPts val="250"/>
-              </a:spcAft>
-              <a:defRPr sz="1750">
-                <a:latin typeface="TH Sarabun New"/>
-              </a:defRPr>
-            </a:pPr>
-            <a:r>
-              <a:rPr b="1">
-                <a:solidFill>
-                  <a:srgbClr val="0F172A"/>
-                </a:solidFill>
-              </a:rPr>
-              <a:t>• OBJ-6 Web Dashboard: </a:t>
-            </a:r>
-            <a:r>
-              <a:rPr b="0">
-                <a:solidFill>
-                  <a:srgbClr val="000000"/>
-                </a:solidFill>
-              </a:rPr>
-              <a:t>Responsive Next.js 14 App Router UI for asset telemetry, evidence, and AI findings.</a:t>
-            </a:r>
-          </a:p>
-          <a:p>
-            <a:pPr>
-              <a:spcAft>
-                <a:spcPts val="250"/>
-              </a:spcAft>
-              <a:defRPr sz="1750">
-                <a:latin typeface="TH Sarabun New"/>
-              </a:defRPr>
-            </a:pPr>
-            <a:r>
-              <a:rPr b="1">
-                <a:solidFill>
-                  <a:srgbClr val="0F172A"/>
-                </a:solidFill>
-              </a:rPr>
-              <a:t>• OBJ-7 Empirical Validation: </a:t>
-            </a:r>
-            <a:r>
-              <a:rPr b="0">
-                <a:solidFill>
-                  <a:srgbClr val="000000"/>
-                </a:solidFill>
-              </a:rPr>
-              <a:t>End-to-end multi-tier verification from USB extraction to live browser display.</a:t>
-            </a:r>
-          </a:p>
-        </p:txBody>
-      </p:sp>
-      <p:sp>
-        <p:nvSpPr>
-          <p:cNvPr id="9" name="Rounded Rectangle 8"/>
+              <a:t>Windows Event Logs generate thousands of routine records daily, obscuring actionable infrastructure faults.</a:t>
+            </a:r>
+          </a:p>
+        </p:txBody>
+      </p:sp>
+      <p:sp>
+        <p:nvSpPr>
+          <p:cNvPr id="11" name="Rounded Rectangle 10"/>
           <p:cNvSpPr/>
           <p:nvPr/>
         </p:nvSpPr>
         <p:spPr>
           <a:xfrm>
-            <a:off x="576000" y="10188000"/>
-            <a:ext cx="9828000" cy="9180000"/>
+            <a:off x="576000" y="17064000"/>
+            <a:ext cx="6408000" cy="12744000"/>
           </a:xfrm>
           <a:prstGeom prst="roundRect">
             <a:avLst/>
@@ -3773,14 +3696,14 @@
       </p:sp>
       <p:sp>
         <p:nvSpPr>
-          <p:cNvPr id="10" name="Rectangle 9"/>
+          <p:cNvPr id="12" name="Rectangle 11"/>
           <p:cNvSpPr/>
           <p:nvPr/>
         </p:nvSpPr>
         <p:spPr>
           <a:xfrm>
-            <a:off x="576000" y="10188000"/>
-            <a:ext cx="9828000" cy="612000"/>
+            <a:off x="576000" y="17064000"/>
+            <a:ext cx="6408000" cy="540000"/>
           </a:xfrm>
           <a:prstGeom prst="rect">
             <a:avLst/>
@@ -3809,11 +3732,11 @@
           </a:fontRef>
         </p:style>
         <p:txBody>
-          <a:bodyPr rtlCol="0" anchor="ctr" wrap="square" lIns="288000" tIns="72000"/>
+          <a:bodyPr rtlCol="0" anchor="ctr" wrap="square" lIns="180000" tIns="54000"/>
           <a:lstStyle/>
           <a:p>
             <a:pPr algn="l">
-              <a:defRPr sz="2600" b="1">
+              <a:defRPr sz="2100" b="1">
                 <a:solidFill>
                   <a:srgbClr val="FFFFFF"/>
                 </a:solidFill>
@@ -3821,45 +3744,21 @@
               </a:defRPr>
             </a:pPr>
             <a:r>
-              <a:t>3. Multi-Tier System Architecture (Hybrid Modular Monolith)</a:t>
-            </a:r>
-          </a:p>
-        </p:txBody>
-      </p:sp>
-      <p:pic>
-        <p:nvPicPr>
-          <p:cNvPr id="11" name="Picture 10" descr="fig3_1_architecture.png"/>
-          <p:cNvPicPr>
-            <a:picLocks noChangeAspect="1"/>
-          </p:cNvPicPr>
+              <a:t>3. Project Objectives (Chapter 1)</a:t>
+            </a:r>
+          </a:p>
+        </p:txBody>
+      </p:sp>
+      <p:sp>
+        <p:nvSpPr>
+          <p:cNvPr id="13" name="TextBox 12"/>
+          <p:cNvSpPr txBox="1"/>
           <p:nvPr/>
-        </p:nvPicPr>
-        <p:blipFill>
-          <a:blip r:embed="rId2"/>
-          <a:stretch>
-            <a:fillRect/>
-          </a:stretch>
-        </p:blipFill>
+        </p:nvSpPr>
         <p:spPr>
           <a:xfrm>
-            <a:off x="792000" y="10836000"/>
-            <a:ext cx="9396000" cy="5328000"/>
-          </a:xfrm>
-          <a:prstGeom prst="rect">
-            <a:avLst/>
-          </a:prstGeom>
-        </p:spPr>
-      </p:pic>
-      <p:sp>
-        <p:nvSpPr>
-          <p:cNvPr id="12" name="TextBox 11"/>
-          <p:cNvSpPr txBox="1"/>
-          <p:nvPr/>
-        </p:nvSpPr>
-        <p:spPr>
-          <a:xfrm>
-            <a:off x="720000" y="16308000"/>
-            <a:ext cx="9540000" cy="2952000"/>
+            <a:off x="684000" y="17676000"/>
+            <a:ext cx="6192000" cy="12024000"/>
           </a:xfrm>
           <a:prstGeom prst="rect">
             <a:avLst/>
@@ -3867,16 +3766,16 @@
           <a:noFill/>
         </p:spPr>
         <p:txBody>
-          <a:bodyPr wrap="square" lIns="108000" tIns="36000">
+          <a:bodyPr wrap="square" lIns="72000" tIns="72000">
             <a:spAutoFit/>
           </a:bodyPr>
           <a:lstStyle/>
           <a:p>
             <a:pPr>
               <a:spcAft>
-                <a:spcPts val="300"/>
+                <a:spcPts val="1000"/>
               </a:spcAft>
-              <a:defRPr sz="1800">
+              <a:defRPr sz="1500">
                 <a:latin typeface="TH Sarabun New"/>
               </a:defRPr>
             </a:pPr>
@@ -3886,7 +3785,7 @@
                   <a:srgbClr val="0F172A"/>
                 </a:solidFill>
               </a:rPr>
-              <a:t>• Hybrid Modular Monolith: </a:t>
+              <a:t>• OBJ-1 Central Asset Registry: </a:t>
             </a:r>
             <a:r>
               <a:rPr b="0">
@@ -3894,15 +3793,15 @@
                   <a:srgbClr val="000000"/>
                 </a:solidFill>
               </a:rPr>
-              <a:t>Consolidates collection, ingestion, dedup, and AI triage in a single maintainable service without microservice networking overhead.</a:t>
+              <a:t>Anchor canonical asset records with cryptographic hardware composite fingerprints across lifecycle changes.</a:t>
             </a:r>
           </a:p>
           <a:p>
             <a:pPr>
               <a:spcAft>
-                <a:spcPts val="300"/>
+                <a:spcPts val="1000"/>
               </a:spcAft>
-              <a:defRPr sz="1800">
+              <a:defRPr sz="1500">
                 <a:latin typeface="TH Sarabun New"/>
               </a:defRPr>
             </a:pPr>
@@ -3912,7 +3811,7 @@
                   <a:srgbClr val="0F172A"/>
                 </a:solidFill>
               </a:rPr>
-              <a:t>• Persistence &amp; Vector Separation: </a:t>
+              <a:t>• OBJ-2 Portable USB Auditor: </a:t>
             </a:r>
             <a:r>
               <a:rPr b="0">
@@ -3920,15 +3819,15 @@
                   <a:srgbClr val="000000"/>
                 </a:solidFill>
               </a:rPr>
-              <a:t>PostgreSQL 16 handles ACID relational entities while pgvector computes 384-dimensional cosine distance in unified SQL queries.</a:t>
+              <a:t>Lightweight, non-destructive collection utility executing on embedded CPython 3.14.3.</a:t>
             </a:r>
           </a:p>
           <a:p>
             <a:pPr>
               <a:spcAft>
-                <a:spcPts val="300"/>
+                <a:spcPts val="1000"/>
               </a:spcAft>
-              <a:defRPr sz="1800">
+              <a:defRPr sz="1500">
                 <a:latin typeface="TH Sarabun New"/>
               </a:defRPr>
             </a:pPr>
@@ -3938,7 +3837,7 @@
                   <a:srgbClr val="0F172A"/>
                 </a:solidFill>
               </a:rPr>
-              <a:t>• Decoupled Supporting Tier: </a:t>
+              <a:t>• OBJ-3 Offline Ingestion Pipeline: </a:t>
             </a:r>
             <a:r>
               <a:rPr b="0">
@@ -3946,21 +3845,125 @@
                   <a:srgbClr val="000000"/>
                 </a:solidFill>
               </a:rPr>
-              <a:t>Redis manages message queuing/caching, MinIO provides S3-compatible storage, and Next.js 14 delivers hybrid server/client rendering.</a:t>
-            </a:r>
-          </a:p>
-        </p:txBody>
-      </p:sp>
-      <p:sp>
-        <p:nvSpPr>
-          <p:cNvPr id="13" name="Rounded Rectangle 12"/>
+              <a:t>Schema-validated normalization of offline multipart JSON evidence reports into relational schemas.</a:t>
+            </a:r>
+          </a:p>
+          <a:p>
+            <a:pPr>
+              <a:spcAft>
+                <a:spcPts val="1000"/>
+              </a:spcAft>
+              <a:defRPr sz="1500">
+                <a:latin typeface="TH Sarabun New"/>
+              </a:defRPr>
+            </a:pPr>
+            <a:r>
+              <a:rPr b="1">
+                <a:solidFill>
+                  <a:srgbClr val="0F172A"/>
+                </a:solidFill>
+              </a:rPr>
+              <a:t>• OBJ-4 Deterministic Deduplication: </a:t>
+            </a:r>
+            <a:r>
+              <a:rPr b="0">
+                <a:solidFill>
+                  <a:srgbClr val="000000"/>
+                </a:solidFill>
+              </a:rPr>
+              <a:t>Application-level sequential SHA-256 deduplication and severity queue ordering.</a:t>
+            </a:r>
+          </a:p>
+          <a:p>
+            <a:pPr>
+              <a:spcAft>
+                <a:spcPts val="1000"/>
+              </a:spcAft>
+              <a:defRPr sz="1500">
+                <a:latin typeface="TH Sarabun New"/>
+              </a:defRPr>
+            </a:pPr>
+            <a:r>
+              <a:rPr b="1">
+                <a:solidFill>
+                  <a:srgbClr val="0F172A"/>
+                </a:solidFill>
+              </a:rPr>
+              <a:t>• OBJ-5 Bounded AI Investigation: </a:t>
+            </a:r>
+            <a:r>
+              <a:rPr b="0">
+                <a:solidFill>
+                  <a:srgbClr val="000000"/>
+                </a:solidFill>
+              </a:rPr>
+              <a:t>pgvector cosine similarity retrieval for prioritized events (bounded workload cap &lt;= 10).</a:t>
+            </a:r>
+          </a:p>
+          <a:p>
+            <a:pPr>
+              <a:spcAft>
+                <a:spcPts val="1000"/>
+              </a:spcAft>
+              <a:defRPr sz="1500">
+                <a:latin typeface="TH Sarabun New"/>
+              </a:defRPr>
+            </a:pPr>
+            <a:r>
+              <a:rPr b="1">
+                <a:solidFill>
+                  <a:srgbClr val="0F172A"/>
+                </a:solidFill>
+              </a:rPr>
+              <a:t>• OBJ-6 Unified Web Dashboard: </a:t>
+            </a:r>
+            <a:r>
+              <a:rPr b="0">
+                <a:solidFill>
+                  <a:srgbClr val="000000"/>
+                </a:solidFill>
+              </a:rPr>
+              <a:t>Responsive Next.js 14 App Router UI for asset telemetry, evidence inspection, and AI findings.</a:t>
+            </a:r>
+          </a:p>
+          <a:p>
+            <a:pPr>
+              <a:spcAft>
+                <a:spcPts val="1000"/>
+              </a:spcAft>
+              <a:defRPr sz="1500">
+                <a:latin typeface="TH Sarabun New"/>
+              </a:defRPr>
+            </a:pPr>
+            <a:r>
+              <a:rPr b="1">
+                <a:solidFill>
+                  <a:srgbClr val="0F172A"/>
+                </a:solidFill>
+              </a:rPr>
+              <a:t>• OBJ-7 Empirical Validation: </a:t>
+            </a:r>
+            <a:r>
+              <a:rPr b="0">
+                <a:solidFill>
+                  <a:srgbClr val="000000"/>
+                </a:solidFill>
+              </a:rPr>
+              <a:t>End-to-end multi-tier verification from portable USB extraction to live browser display.</a:t>
+            </a:r>
+          </a:p>
+        </p:txBody>
+      </p:sp>
+      <p:sp>
+        <p:nvSpPr>
+          <p:cNvPr id="14" name="Rounded Rectangle 13"/>
           <p:cNvSpPr/>
           <p:nvPr/>
         </p:nvSpPr>
         <p:spPr>
           <a:xfrm>
-            <a:off x="576000" y="19548000"/>
-            <a:ext cx="9828000" cy="4140000"/>
+            <a:off x="7488000" y="3528000"/>
+            <a:ext cx="6408000" cy="10080000"/>
           </a:xfrm>
           <a:prstGeom prst="roundRect">
             <a:avLst/>
@@ -3998,14 +4001,14 @@
       </p:sp>
       <p:sp>
         <p:nvSpPr>
-          <p:cNvPr id="14" name="Rectangle 13"/>
+          <p:cNvPr id="15" name="Rectangle 14"/>
           <p:cNvSpPr/>
           <p:nvPr/>
         </p:nvSpPr>
         <p:spPr>
           <a:xfrm>
-            <a:off x="576000" y="19548000"/>
-            <a:ext cx="9828000" cy="612000"/>
+            <a:off x="7488000" y="3528000"/>
+            <a:ext cx="6408000" cy="540000"/>
           </a:xfrm>
           <a:prstGeom prst="rect">
             <a:avLst/>
@@ -4034,11 +4037,11 @@
           </a:fontRef>
         </p:style>
         <p:txBody>
-          <a:bodyPr rtlCol="0" anchor="ctr" wrap="square" lIns="288000" tIns="72000"/>
+          <a:bodyPr rtlCol="0" anchor="ctr" wrap="square" lIns="180000" tIns="54000"/>
           <a:lstStyle/>
           <a:p>
             <a:pPr algn="l">
-              <a:defRPr sz="2600" b="1">
+              <a:defRPr sz="2100" b="1">
                 <a:solidFill>
                   <a:srgbClr val="FFFFFF"/>
                 </a:solidFill>
@@ -4046,21 +4049,45 @@
               </a:defRPr>
             </a:pPr>
             <a:r>
-              <a:t>4. Core Technology Implementation Stack</a:t>
-            </a:r>
-          </a:p>
-        </p:txBody>
-      </p:sp>
-      <p:sp>
-        <p:nvSpPr>
-          <p:cNvPr id="15" name="TextBox 14"/>
+              <a:t>4. Multi-Tier System Architecture</a:t>
+            </a:r>
+          </a:p>
+        </p:txBody>
+      </p:sp>
+      <p:pic>
+        <p:nvPicPr>
+          <p:cNvPr id="16" name="Picture 15" descr="fig3_1_architecture.png"/>
+          <p:cNvPicPr>
+            <a:picLocks noChangeAspect="1"/>
+          </p:cNvPicPr>
+          <p:nvPr/>
+        </p:nvPicPr>
+        <p:blipFill>
+          <a:blip r:embed="rId2"/>
+          <a:stretch>
+            <a:fillRect/>
+          </a:stretch>
+        </p:blipFill>
+        <p:spPr>
+          <a:xfrm>
+            <a:off x="7632000" y="4140000"/>
+            <a:ext cx="6120000" cy="3960000"/>
+          </a:xfrm>
+          <a:prstGeom prst="rect">
+            <a:avLst/>
+          </a:prstGeom>
+        </p:spPr>
+      </p:pic>
+      <p:sp>
+        <p:nvSpPr>
+          <p:cNvPr id="17" name="TextBox 16"/>
           <p:cNvSpPr txBox="1"/>
           <p:nvPr/>
         </p:nvSpPr>
         <p:spPr>
           <a:xfrm>
-            <a:off x="720000" y="20196000"/>
-            <a:ext cx="9540000" cy="3420000"/>
+            <a:off x="7596000" y="8208000"/>
+            <a:ext cx="6192000" cy="5292000"/>
           </a:xfrm>
           <a:prstGeom prst="rect">
             <a:avLst/>
@@ -4068,16 +4095,16 @@
           <a:noFill/>
         </p:spPr>
         <p:txBody>
-          <a:bodyPr wrap="square" lIns="108000" tIns="36000">
+          <a:bodyPr wrap="square" lIns="72000" tIns="72000">
             <a:spAutoFit/>
           </a:bodyPr>
           <a:lstStyle/>
           <a:p>
             <a:pPr>
               <a:spcAft>
-                <a:spcPts val="350"/>
+                <a:spcPts val="600"/>
               </a:spcAft>
-              <a:defRPr sz="1800">
+              <a:defRPr sz="1500">
                 <a:latin typeface="TH Sarabun New"/>
               </a:defRPr>
             </a:pPr>
@@ -4087,7 +4114,7 @@
                   <a:srgbClr val="0F172A"/>
                 </a:solidFill>
               </a:rPr>
-              <a:t>• Backend API Gateway: </a:t>
+              <a:t>• Hybrid Modular Monolith: </a:t>
             </a:r>
             <a:r>
               <a:rPr b="0">
@@ -4095,15 +4122,15 @@
                   <a:srgbClr val="000000"/>
                 </a:solidFill>
               </a:rPr>
-              <a:t>FastAPI + Pydantic + Starlette delivering REST APIs and schema validation.</a:t>
+              <a:t>Consolidates collection, ingestion, dedup, and AI triage in a single maintainable service without microservice networking overhead.</a:t>
             </a:r>
           </a:p>
           <a:p>
             <a:pPr>
               <a:spcAft>
-                <a:spcPts val="350"/>
+                <a:spcPts val="600"/>
               </a:spcAft>
-              <a:defRPr sz="1800">
+              <a:defRPr sz="1500">
                 <a:latin typeface="TH Sarabun New"/>
               </a:defRPr>
             </a:pPr>
@@ -4113,7 +4140,7 @@
                   <a:srgbClr val="0F172A"/>
                 </a:solidFill>
               </a:rPr>
-              <a:t>• Database &amp; Vector Store: </a:t>
+              <a:t>• Persistence &amp; Vector Separation: </a:t>
             </a:r>
             <a:r>
               <a:rPr b="0">
@@ -4121,15 +4148,15 @@
                   <a:srgbClr val="000000"/>
                 </a:solidFill>
               </a:rPr>
-              <a:t>PostgreSQL 16 with pgvector (384-d dense vector cosine distance search).</a:t>
+              <a:t>PostgreSQL 16 handles ACID relational entities while pgvector computes 384-dimensional cosine distance in unified SQL queries.</a:t>
             </a:r>
           </a:p>
           <a:p>
             <a:pPr>
               <a:spcAft>
-                <a:spcPts val="350"/>
+                <a:spcPts val="600"/>
               </a:spcAft>
-              <a:defRPr sz="1800">
+              <a:defRPr sz="1500">
                 <a:latin typeface="TH Sarabun New"/>
               </a:defRPr>
             </a:pPr>
@@ -4139,7 +4166,7 @@
                   <a:srgbClr val="0F172A"/>
                 </a:solidFill>
               </a:rPr>
-              <a:t>• Broker &amp; Object Store: </a:t>
+              <a:t>• Decoupled Supporting Tier: </a:t>
             </a:r>
             <a:r>
               <a:rPr b="0">
@@ -4147,99 +4174,21 @@
                   <a:srgbClr val="000000"/>
                 </a:solidFill>
               </a:rPr>
-              <a:t>Redis 7 (caching/queues) and MinIO (S3-compatible storage for OCR/specs).</a:t>
-            </a:r>
-          </a:p>
-          <a:p>
-            <a:pPr>
-              <a:spcAft>
-                <a:spcPts val="350"/>
-              </a:spcAft>
-              <a:defRPr sz="1800">
-                <a:latin typeface="TH Sarabun New"/>
-              </a:defRPr>
-            </a:pPr>
-            <a:r>
-              <a:rPr b="1">
-                <a:solidFill>
-                  <a:srgbClr val="0F172A"/>
-                </a:solidFill>
-              </a:rPr>
-              <a:t>• Operator Web Dashboard: </a:t>
-            </a:r>
-            <a:r>
-              <a:rPr b="0">
-                <a:solidFill>
-                  <a:srgbClr val="000000"/>
-                </a:solidFill>
-              </a:rPr>
-              <a:t>Next.js 14 App Router, React 18, TypeScript, and Tailwind CSS.</a:t>
-            </a:r>
-          </a:p>
-          <a:p>
-            <a:pPr>
-              <a:spcAft>
-                <a:spcPts val="350"/>
-              </a:spcAft>
-              <a:defRPr sz="1800">
-                <a:latin typeface="TH Sarabun New"/>
-              </a:defRPr>
-            </a:pPr>
-            <a:r>
-              <a:rPr b="1">
-                <a:solidFill>
-                  <a:srgbClr val="0F172A"/>
-                </a:solidFill>
-              </a:rPr>
-              <a:t>• Portable USB Auditor: </a:t>
-            </a:r>
-            <a:r>
-              <a:rPr b="0">
-                <a:solidFill>
-                  <a:srgbClr val="000000"/>
-                </a:solidFill>
-              </a:rPr>
-              <a:t>Embedded CPython 3.14.3 amd64 distribution (no target dependencies).</a:t>
-            </a:r>
-          </a:p>
-          <a:p>
-            <a:pPr>
-              <a:spcAft>
-                <a:spcPts val="350"/>
-              </a:spcAft>
-              <a:defRPr sz="1800">
-                <a:latin typeface="TH Sarabun New"/>
-              </a:defRPr>
-            </a:pPr>
-            <a:r>
-              <a:rPr b="1">
-                <a:solidFill>
-                  <a:srgbClr val="0F172A"/>
-                </a:solidFill>
-              </a:rPr>
-              <a:t>• AI Embedding Hierarchy: </a:t>
-            </a:r>
-            <a:r>
-              <a:rPr b="0">
-                <a:solidFill>
-                  <a:srgbClr val="000000"/>
-                </a:solidFill>
-              </a:rPr>
-              <a:t>FastEmbed BAAI/bge-small-en-v1.5 primary / SentenceTransformer fallback.</a:t>
-            </a:r>
-          </a:p>
-        </p:txBody>
-      </p:sp>
-      <p:sp>
-        <p:nvSpPr>
-          <p:cNvPr id="16" name="Rounded Rectangle 15"/>
+              <a:t>Redis manages message caching/queues, MinIO provides S3-compatible storage, and Next.js 14 delivers hybrid server/client rendering.</a:t>
+            </a:r>
+          </a:p>
+        </p:txBody>
+      </p:sp>
+      <p:sp>
+        <p:nvSpPr>
+          <p:cNvPr id="18" name="Rounded Rectangle 17"/>
           <p:cNvSpPr/>
           <p:nvPr/>
         </p:nvSpPr>
         <p:spPr>
           <a:xfrm>
-            <a:off x="576000" y="23868000"/>
-            <a:ext cx="9828000" cy="5868000"/>
+            <a:off x="7488000" y="13824000"/>
+            <a:ext cx="6408000" cy="7560000"/>
           </a:xfrm>
           <a:prstGeom prst="roundRect">
             <a:avLst/>
@@ -4277,14 +4226,14 @@
       </p:sp>
       <p:sp>
         <p:nvSpPr>
-          <p:cNvPr id="17" name="Rectangle 16"/>
+          <p:cNvPr id="19" name="Rectangle 18"/>
           <p:cNvSpPr/>
           <p:nvPr/>
         </p:nvSpPr>
         <p:spPr>
           <a:xfrm>
-            <a:off x="576000" y="23868000"/>
-            <a:ext cx="9828000" cy="612000"/>
+            <a:off x="7488000" y="13824000"/>
+            <a:ext cx="6408000" cy="540000"/>
           </a:xfrm>
           <a:prstGeom prst="rect">
             <a:avLst/>
@@ -4313,11 +4262,11 @@
           </a:fontRef>
         </p:style>
         <p:txBody>
-          <a:bodyPr rtlCol="0" anchor="ctr" wrap="square" lIns="288000" tIns="72000"/>
+          <a:bodyPr rtlCol="0" anchor="ctr" wrap="square" lIns="180000" tIns="54000"/>
           <a:lstStyle/>
           <a:p>
             <a:pPr algn="l">
-              <a:defRPr sz="2600" b="1">
+              <a:defRPr sz="2100" b="1">
                 <a:solidFill>
                   <a:srgbClr val="FFFFFF"/>
                 </a:solidFill>
@@ -4325,21 +4274,21 @@
               </a:defRPr>
             </a:pPr>
             <a:r>
-              <a:t>5. Event Deduplication &amp; Bounded AI Role</a:t>
-            </a:r>
-          </a:p>
-        </p:txBody>
-      </p:sp>
-      <p:sp>
-        <p:nvSpPr>
-          <p:cNvPr id="18" name="TextBox 17"/>
+              <a:t>5. Technology Implementation Stack</a:t>
+            </a:r>
+          </a:p>
+        </p:txBody>
+      </p:sp>
+      <p:sp>
+        <p:nvSpPr>
+          <p:cNvPr id="20" name="TextBox 19"/>
           <p:cNvSpPr txBox="1"/>
           <p:nvPr/>
         </p:nvSpPr>
         <p:spPr>
           <a:xfrm>
-            <a:off x="720000" y="24516000"/>
-            <a:ext cx="9540000" cy="5148000"/>
+            <a:off x="7596000" y="14436000"/>
+            <a:ext cx="6192000" cy="6840000"/>
           </a:xfrm>
           <a:prstGeom prst="rect">
             <a:avLst/>
@@ -4347,32 +4296,42 @@
           <a:noFill/>
         </p:spPr>
         <p:txBody>
-          <a:bodyPr wrap="square" lIns="108000" tIns="36000">
+          <a:bodyPr wrap="square" lIns="72000" tIns="72000">
             <a:spAutoFit/>
           </a:bodyPr>
           <a:lstStyle/>
           <a:p>
             <a:pPr>
               <a:spcAft>
-                <a:spcPts val="300"/>
+                <a:spcPts val="700"/>
               </a:spcAft>
-              <a:defRPr sz="1500" b="1">
-                <a:solidFill>
-                  <a:srgbClr val="1E40AF"/>
-                </a:solidFill>
-                <a:latin typeface="Consolas"/>
-              </a:defRPr>
-            </a:pPr>
-            <a:r>
-              <a:t>DedupKey = SHA-256(asset_id || channel || provider || record_id || occurrence_time)</a:t>
+              <a:defRPr sz="1500">
+                <a:latin typeface="TH Sarabun New"/>
+              </a:defRPr>
+            </a:pPr>
+            <a:r>
+              <a:rPr b="1">
+                <a:solidFill>
+                  <a:srgbClr val="0F172A"/>
+                </a:solidFill>
+              </a:rPr>
+              <a:t>• Backend API Gateway: </a:t>
+            </a:r>
+            <a:r>
+              <a:rPr b="0">
+                <a:solidFill>
+                  <a:srgbClr val="000000"/>
+                </a:solidFill>
+              </a:rPr>
+              <a:t>FastAPI + Pydantic + Starlette delivering REST APIs and schema validation.</a:t>
             </a:r>
           </a:p>
           <a:p>
             <a:pPr>
               <a:spcAft>
-                <a:spcPts val="300"/>
+                <a:spcPts val="700"/>
               </a:spcAft>
-              <a:defRPr sz="1800">
+              <a:defRPr sz="1500">
                 <a:latin typeface="TH Sarabun New"/>
               </a:defRPr>
             </a:pPr>
@@ -4382,7 +4341,7 @@
                   <a:srgbClr val="0F172A"/>
                 </a:solidFill>
               </a:rPr>
-              <a:t>• Sequential Dedup Integrity: </a:t>
+              <a:t>• Database &amp; Vector Store: </a:t>
             </a:r>
             <a:r>
               <a:rPr b="0">
@@ -4390,15 +4349,15 @@
                   <a:srgbClr val="000000"/>
                 </a:solidFill>
               </a:rPr>
-              <a:t>Windows record_id is monotonically assigned; hash enables deterministic duplicate skipping across sequential imports.</a:t>
+              <a:t>PostgreSQL 16 with pgvector (384-d dense vector cosine distance search).</a:t>
             </a:r>
           </a:p>
           <a:p>
             <a:pPr>
               <a:spcAft>
-                <a:spcPts val="300"/>
+                <a:spcPts val="700"/>
               </a:spcAft>
-              <a:defRPr sz="1800">
+              <a:defRPr sz="1500">
                 <a:latin typeface="TH Sarabun New"/>
               </a:defRPr>
             </a:pPr>
@@ -4408,7 +4367,7 @@
                   <a:srgbClr val="0F172A"/>
                 </a:solidFill>
               </a:rPr>
-              <a:t>• Concurrency Boundary: </a:t>
+              <a:t>• Broker &amp; Object Store: </a:t>
             </a:r>
             <a:r>
               <a:rPr b="0">
@@ -4416,15 +4375,15 @@
                   <a:srgbClr val="000000"/>
                 </a:solidFill>
               </a:rPr>
-              <a:t>Enforced sequentially in memory. Concurrent parallel imports may race as database-level uniqueness is not enforced.</a:t>
+              <a:t>Redis 7 (caching/queues) and MinIO (S3-compatible storage for OCR/specs).</a:t>
             </a:r>
           </a:p>
           <a:p>
             <a:pPr>
               <a:spcAft>
-                <a:spcPts val="300"/>
+                <a:spcPts val="700"/>
               </a:spcAft>
-              <a:defRPr sz="1800">
+              <a:defRPr sz="1500">
                 <a:latin typeface="TH Sarabun New"/>
               </a:defRPr>
             </a:pPr>
@@ -4434,7 +4393,7 @@
                   <a:srgbClr val="0F172A"/>
                 </a:solidFill>
               </a:rPr>
-              <a:t>• Severity Ranking: </a:t>
+              <a:t>• Operator Web Dashboard: </a:t>
             </a:r>
             <a:r>
               <a:rPr b="0">
@@ -4442,15 +4401,15 @@
                   <a:srgbClr val="000000"/>
                 </a:solidFill>
               </a:rPr>
-              <a:t>Candidate events prioritized: Critical (Level 1) &gt; Error (Level 2) &gt; Warning (Level 3) &gt; Info (Level 4).</a:t>
+              <a:t>Next.js 14 App Router, React 18, TypeScript, and Tailwind CSS.</a:t>
             </a:r>
           </a:p>
           <a:p>
             <a:pPr>
               <a:spcAft>
-                <a:spcPts val="300"/>
+                <a:spcPts val="700"/>
               </a:spcAft>
-              <a:defRPr sz="1800">
+              <a:defRPr sz="1500">
                 <a:latin typeface="TH Sarabun New"/>
               </a:defRPr>
             </a:pPr>
@@ -4460,7 +4419,7 @@
                   <a:srgbClr val="0F172A"/>
                 </a:solidFill>
               </a:rPr>
-              <a:t>• Bounded Workload Cap: </a:t>
+              <a:t>• Portable USB Auditor: </a:t>
             </a:r>
             <a:r>
               <a:rPr b="0">
@@ -4468,15 +4427,15 @@
                   <a:srgbClr val="000000"/>
                 </a:solidFill>
               </a:rPr>
-              <a:t>Analyzer strictly triages at most 10 selected new events per import, protecting worker threads.</a:t>
+              <a:t>Embedded CPython 3.14.3 amd64 distribution (no target dependencies).</a:t>
             </a:r>
           </a:p>
           <a:p>
             <a:pPr>
               <a:spcAft>
-                <a:spcPts val="300"/>
+                <a:spcPts val="700"/>
               </a:spcAft>
-              <a:defRPr sz="1800">
+              <a:defRPr sz="1500">
                 <a:latin typeface="TH Sarabun New"/>
               </a:defRPr>
             </a:pPr>
@@ -4486,7 +4445,7 @@
                   <a:srgbClr val="0F172A"/>
                 </a:solidFill>
               </a:rPr>
-              <a:t>• Assistive Role: </a:t>
+              <a:t>• AI Embedding Hierarchy: </a:t>
             </a:r>
             <a:r>
               <a:rPr b="0">
@@ -4494,21 +4453,21 @@
                   <a:srgbClr val="000000"/>
                 </a:solidFill>
               </a:rPr>
-              <a:t>AI provides diagnostic hypotheses and suggested verification checks; does NOT execute autonomous remediation.</a:t>
-            </a:r>
-          </a:p>
-        </p:txBody>
-      </p:sp>
-      <p:sp>
-        <p:nvSpPr>
-          <p:cNvPr id="19" name="Rounded Rectangle 18"/>
+              <a:t>FastEmbed BAAI/bge-small-en-v1.5 primary / SentenceTransformer fallback.</a:t>
+            </a:r>
+          </a:p>
+        </p:txBody>
+      </p:sp>
+      <p:sp>
+        <p:nvSpPr>
+          <p:cNvPr id="21" name="Rounded Rectangle 20"/>
           <p:cNvSpPr/>
           <p:nvPr/>
         </p:nvSpPr>
         <p:spPr>
           <a:xfrm>
-            <a:off x="10980000" y="3528000"/>
-            <a:ext cx="9828000" cy="8568000"/>
+            <a:off x="7488000" y="21600000"/>
+            <a:ext cx="6408000" cy="8208000"/>
           </a:xfrm>
           <a:prstGeom prst="roundRect">
             <a:avLst/>
@@ -4546,14 +4505,14 @@
       </p:sp>
       <p:sp>
         <p:nvSpPr>
-          <p:cNvPr id="20" name="Rectangle 19"/>
+          <p:cNvPr id="22" name="Rectangle 21"/>
           <p:cNvSpPr/>
           <p:nvPr/>
         </p:nvSpPr>
         <p:spPr>
           <a:xfrm>
-            <a:off x="10980000" y="3528000"/>
-            <a:ext cx="9828000" cy="612000"/>
+            <a:off x="7488000" y="21600000"/>
+            <a:ext cx="6408000" cy="540000"/>
           </a:xfrm>
           <a:prstGeom prst="rect">
             <a:avLst/>
@@ -4582,11 +4541,11 @@
           </a:fontRef>
         </p:style>
         <p:txBody>
-          <a:bodyPr rtlCol="0" anchor="ctr" wrap="square" lIns="288000" tIns="72000"/>
+          <a:bodyPr rtlCol="0" anchor="ctr" wrap="square" lIns="180000" tIns="54000"/>
           <a:lstStyle/>
           <a:p>
             <a:pPr algn="l">
-              <a:defRPr sz="2600" b="1">
+              <a:defRPr sz="2100" b="1">
                 <a:solidFill>
                   <a:srgbClr val="FFFFFF"/>
                 </a:solidFill>
@@ -4594,45 +4553,21 @@
               </a:defRPr>
             </a:pPr>
             <a:r>
-              <a:t>6. Portable Disconnected Collection Workflow</a:t>
-            </a:r>
-          </a:p>
-        </p:txBody>
-      </p:sp>
-      <p:pic>
-        <p:nvPicPr>
-          <p:cNvPr id="21" name="Picture 20" descr="fig3_3_sequence.png"/>
-          <p:cNvPicPr>
-            <a:picLocks noChangeAspect="1"/>
-          </p:cNvPicPr>
+              <a:t>6. Event Deduplication &amp; AI Role</a:t>
+            </a:r>
+          </a:p>
+        </p:txBody>
+      </p:sp>
+      <p:sp>
+        <p:nvSpPr>
+          <p:cNvPr id="23" name="TextBox 22"/>
+          <p:cNvSpPr txBox="1"/>
           <p:nvPr/>
-        </p:nvPicPr>
-        <p:blipFill>
-          <a:blip r:embed="rId3"/>
-          <a:stretch>
-            <a:fillRect/>
-          </a:stretch>
-        </p:blipFill>
+        </p:nvSpPr>
         <p:spPr>
           <a:xfrm>
-            <a:off x="11196000" y="4176000"/>
-            <a:ext cx="9396000" cy="4896000"/>
-          </a:xfrm>
-          <a:prstGeom prst="rect">
-            <a:avLst/>
-          </a:prstGeom>
-        </p:spPr>
-      </p:pic>
-      <p:sp>
-        <p:nvSpPr>
-          <p:cNvPr id="22" name="TextBox 21"/>
-          <p:cNvSpPr txBox="1"/>
-          <p:nvPr/>
-        </p:nvSpPr>
-        <p:spPr>
-          <a:xfrm>
-            <a:off x="11124000" y="9144000"/>
-            <a:ext cx="9540000" cy="2880000"/>
+            <a:off x="7596000" y="22212000"/>
+            <a:ext cx="6192000" cy="7488000"/>
           </a:xfrm>
           <a:prstGeom prst="rect">
             <a:avLst/>
@@ -4640,42 +4575,32 @@
           <a:noFill/>
         </p:spPr>
         <p:txBody>
-          <a:bodyPr wrap="square" lIns="108000" tIns="36000">
+          <a:bodyPr wrap="square" lIns="72000" tIns="72000">
             <a:spAutoFit/>
           </a:bodyPr>
           <a:lstStyle/>
           <a:p>
             <a:pPr>
               <a:spcAft>
-                <a:spcPts val="300"/>
+                <a:spcPts val="500"/>
               </a:spcAft>
-              <a:defRPr sz="1800">
-                <a:latin typeface="TH Sarabun New"/>
-              </a:defRPr>
-            </a:pPr>
-            <a:r>
-              <a:rPr b="1">
-                <a:solidFill>
-                  <a:srgbClr val="0F172A"/>
-                </a:solidFill>
-              </a:rPr>
-              <a:t>• Bundled Portable Runtime: </a:t>
-            </a:r>
-            <a:r>
-              <a:rPr b="0">
-                <a:solidFill>
-                  <a:srgbClr val="000000"/>
-                </a:solidFill>
-              </a:rPr>
-              <a:t>Embedded CPython 3.14.3 amd64; requires NO preinstalled Python, pip, Git, or Docker on target hosts.</a:t>
+              <a:defRPr sz="1300" b="1">
+                <a:solidFill>
+                  <a:srgbClr val="1E40AF"/>
+                </a:solidFill>
+                <a:latin typeface="Consolas"/>
+              </a:defRPr>
+            </a:pPr>
+            <a:r>
+              <a:t>DedupKey = SHA-256(asset_id || channel || provider || record_id || occurrence_time)</a:t>
             </a:r>
           </a:p>
           <a:p>
             <a:pPr>
               <a:spcAft>
-                <a:spcPts val="300"/>
+                <a:spcPts val="600"/>
               </a:spcAft>
-              <a:defRPr sz="1800">
+              <a:defRPr sz="1450">
                 <a:latin typeface="TH Sarabun New"/>
               </a:defRPr>
             </a:pPr>
@@ -4685,7 +4610,7 @@
                   <a:srgbClr val="0F172A"/>
                 </a:solidFill>
               </a:rPr>
-              <a:t>• Non-Destructive Posture: </a:t>
+              <a:t>• Sequential In-Memory Dedup: </a:t>
             </a:r>
             <a:r>
               <a:rPr b="0">
@@ -4693,15 +4618,15 @@
                   <a:srgbClr val="000000"/>
                 </a:solidFill>
               </a:rPr>
-              <a:t>Read-only WMI/CIM and event queries; writes reports/logs strictly to configured USB directories.</a:t>
+              <a:t>Windows record_id is monotonically assigned; SHA-256 hash enables deterministic duplicate skipping across sequential imports.</a:t>
             </a:r>
           </a:p>
           <a:p>
             <a:pPr>
               <a:spcAft>
-                <a:spcPts val="300"/>
+                <a:spcPts val="600"/>
               </a:spcAft>
-              <a:defRPr sz="1800">
+              <a:defRPr sz="1450">
                 <a:latin typeface="TH Sarabun New"/>
               </a:defRPr>
             </a:pPr>
@@ -4711,7 +4636,7 @@
                   <a:srgbClr val="0F172A"/>
                 </a:solidFill>
               </a:rPr>
-              <a:t>• Scoped Telemetry Window: </a:t>
+              <a:t>• Concurrency Boundary: </a:t>
             </a:r>
             <a:r>
               <a:rPr b="0">
@@ -4719,15 +4644,15 @@
                   <a:srgbClr val="000000"/>
                 </a:solidFill>
               </a:rPr>
-              <a:t>Captures System and Application logs over 24h (default maximum 500 events across combined query).</a:t>
+              <a:t>Enforced sequentially in memory. Concurrent identical imports may race as database-level uniqueness is not currently enforced.</a:t>
             </a:r>
           </a:p>
           <a:p>
             <a:pPr>
               <a:spcAft>
-                <a:spcPts val="300"/>
+                <a:spcPts val="600"/>
               </a:spcAft>
-              <a:defRPr sz="1800">
+              <a:defRPr sz="1450">
                 <a:latin typeface="TH Sarabun New"/>
               </a:defRPr>
             </a:pPr>
@@ -4737,7 +4662,7 @@
                   <a:srgbClr val="0F172A"/>
                 </a:solidFill>
               </a:rPr>
-              <a:t>• Deterministic JSON Output: </a:t>
+              <a:t>• Severity Priority Ranking: </a:t>
             </a:r>
             <a:r>
               <a:rPr b="0">
@@ -4745,21 +4670,73 @@
                   <a:srgbClr val="000000"/>
                 </a:solidFill>
               </a:rPr>
-              <a:t>Produces structured, schema-compliant JSON payloads for central offline import.</a:t>
-            </a:r>
-          </a:p>
-        </p:txBody>
-      </p:sp>
-      <p:sp>
-        <p:nvSpPr>
-          <p:cNvPr id="23" name="Rounded Rectangle 22"/>
+              <a:t>Candidate events prioritized: Critical (Level 1) &gt; Error (Level 2) &gt; Warning (Level 3) &gt; Info (Level 4).</a:t>
+            </a:r>
+          </a:p>
+          <a:p>
+            <a:pPr>
+              <a:spcAft>
+                <a:spcPts val="600"/>
+              </a:spcAft>
+              <a:defRPr sz="1450">
+                <a:latin typeface="TH Sarabun New"/>
+              </a:defRPr>
+            </a:pPr>
+            <a:r>
+              <a:rPr b="1">
+                <a:solidFill>
+                  <a:srgbClr val="0F172A"/>
+                </a:solidFill>
+              </a:rPr>
+              <a:t>• Bounded Workload Cap: </a:t>
+            </a:r>
+            <a:r>
+              <a:rPr b="0">
+                <a:solidFill>
+                  <a:srgbClr val="000000"/>
+                </a:solidFill>
+              </a:rPr>
+              <a:t>Analyzer strictly triages at most 10 selected new events per import, protecting worker threads from load spikes.</a:t>
+            </a:r>
+          </a:p>
+          <a:p>
+            <a:pPr>
+              <a:spcAft>
+                <a:spcPts val="600"/>
+              </a:spcAft>
+              <a:defRPr sz="1450">
+                <a:latin typeface="TH Sarabun New"/>
+              </a:defRPr>
+            </a:pPr>
+            <a:r>
+              <a:rPr b="1">
+                <a:solidFill>
+                  <a:srgbClr val="0F172A"/>
+                </a:solidFill>
+              </a:rPr>
+              <a:t>• Assistive Role Boundary: </a:t>
+            </a:r>
+            <a:r>
+              <a:rPr b="0">
+                <a:solidFill>
+                  <a:srgbClr val="000000"/>
+                </a:solidFill>
+              </a:rPr>
+              <a:t>AI provides diagnostic hypotheses and suggested verification checks; does NOT execute autonomous remediation or guaranteed RCA.</a:t>
+            </a:r>
+          </a:p>
+        </p:txBody>
+      </p:sp>
+      <p:sp>
+        <p:nvSpPr>
+          <p:cNvPr id="24" name="Rounded Rectangle 23"/>
           <p:cNvSpPr/>
           <p:nvPr/>
         </p:nvSpPr>
         <p:spPr>
           <a:xfrm>
-            <a:off x="10980000" y="12276000"/>
-            <a:ext cx="9828000" cy="7092000"/>
+            <a:off x="14400000" y="3528000"/>
+            <a:ext cx="6408000" cy="8640000"/>
           </a:xfrm>
           <a:prstGeom prst="roundRect">
             <a:avLst/>
@@ -4797,14 +4774,14 @@
       </p:sp>
       <p:sp>
         <p:nvSpPr>
-          <p:cNvPr id="24" name="Rectangle 23"/>
+          <p:cNvPr id="25" name="Rectangle 24"/>
           <p:cNvSpPr/>
           <p:nvPr/>
         </p:nvSpPr>
         <p:spPr>
           <a:xfrm>
-            <a:off x="10980000" y="12276000"/>
-            <a:ext cx="9828000" cy="612000"/>
+            <a:off x="14400000" y="3528000"/>
+            <a:ext cx="6408000" cy="540000"/>
           </a:xfrm>
           <a:prstGeom prst="rect">
             <a:avLst/>
@@ -4833,11 +4810,11 @@
           </a:fontRef>
         </p:style>
         <p:txBody>
-          <a:bodyPr rtlCol="0" anchor="ctr" wrap="square" lIns="288000" tIns="72000"/>
+          <a:bodyPr rtlCol="0" anchor="ctr" wrap="square" lIns="180000" tIns="54000"/>
           <a:lstStyle/>
           <a:p>
             <a:pPr algn="l">
-              <a:defRPr sz="2600" b="1">
+              <a:defRPr sz="2100" b="1">
                 <a:solidFill>
                   <a:srgbClr val="FFFFFF"/>
                 </a:solidFill>
@@ -4845,21 +4822,272 @@
               </a:defRPr>
             </a:pPr>
             <a:r>
-              <a:t>7. Empirical Validation Results &amp; Measured Metrics</a:t>
-            </a:r>
-          </a:p>
-        </p:txBody>
-      </p:sp>
-      <p:sp>
-        <p:nvSpPr>
-          <p:cNvPr id="25" name="Rounded Rectangle 24"/>
+              <a:t>7. Portable Offline Workflow</a:t>
+            </a:r>
+          </a:p>
+        </p:txBody>
+      </p:sp>
+      <p:pic>
+        <p:nvPicPr>
+          <p:cNvPr id="26" name="Picture 25" descr="fig3_3_sequence.png"/>
+          <p:cNvPicPr>
+            <a:picLocks noChangeAspect="1"/>
+          </p:cNvPicPr>
+          <p:nvPr/>
+        </p:nvPicPr>
+        <p:blipFill>
+          <a:blip r:embed="rId3"/>
+          <a:stretch>
+            <a:fillRect/>
+          </a:stretch>
+        </p:blipFill>
+        <p:spPr>
+          <a:xfrm>
+            <a:off x="14544000" y="4140000"/>
+            <a:ext cx="6120000" cy="3780000"/>
+          </a:xfrm>
+          <a:prstGeom prst="rect">
+            <a:avLst/>
+          </a:prstGeom>
+        </p:spPr>
+      </p:pic>
+      <p:sp>
+        <p:nvSpPr>
+          <p:cNvPr id="27" name="TextBox 26"/>
+          <p:cNvSpPr txBox="1"/>
+          <p:nvPr/>
+        </p:nvSpPr>
+        <p:spPr>
+          <a:xfrm>
+            <a:off x="14508000" y="8028000"/>
+            <a:ext cx="6192000" cy="4032000"/>
+          </a:xfrm>
+          <a:prstGeom prst="rect">
+            <a:avLst/>
+          </a:prstGeom>
+          <a:noFill/>
+        </p:spPr>
+        <p:txBody>
+          <a:bodyPr wrap="square" lIns="72000" tIns="72000">
+            <a:spAutoFit/>
+          </a:bodyPr>
+          <a:lstStyle/>
+          <a:p>
+            <a:pPr>
+              <a:spcAft>
+                <a:spcPts val="400"/>
+              </a:spcAft>
+              <a:defRPr sz="1450">
+                <a:latin typeface="TH Sarabun New"/>
+              </a:defRPr>
+            </a:pPr>
+            <a:r>
+              <a:rPr b="1">
+                <a:solidFill>
+                  <a:srgbClr val="0F172A"/>
+                </a:solidFill>
+              </a:rPr>
+              <a:t>• Bundled Portable Runtime: </a:t>
+            </a:r>
+            <a:r>
+              <a:rPr b="0">
+                <a:solidFill>
+                  <a:srgbClr val="000000"/>
+                </a:solidFill>
+              </a:rPr>
+              <a:t>Embedded CPython 3.14.3 amd64; requires NO preinstalled Python, pip, Git, or Docker on target hosts.</a:t>
+            </a:r>
+          </a:p>
+          <a:p>
+            <a:pPr>
+              <a:spcAft>
+                <a:spcPts val="400"/>
+              </a:spcAft>
+              <a:defRPr sz="1450">
+                <a:latin typeface="TH Sarabun New"/>
+              </a:defRPr>
+            </a:pPr>
+            <a:r>
+              <a:rPr b="1">
+                <a:solidFill>
+                  <a:srgbClr val="0F172A"/>
+                </a:solidFill>
+              </a:rPr>
+              <a:t>• Non-Destructive Posture: </a:t>
+            </a:r>
+            <a:r>
+              <a:rPr b="0">
+                <a:solidFill>
+                  <a:srgbClr val="000000"/>
+                </a:solidFill>
+              </a:rPr>
+              <a:t>Read-only WMI/CIM and event queries; writes reports/logs strictly to configured USB directories.</a:t>
+            </a:r>
+          </a:p>
+          <a:p>
+            <a:pPr>
+              <a:spcAft>
+                <a:spcPts val="400"/>
+              </a:spcAft>
+              <a:defRPr sz="1450">
+                <a:latin typeface="TH Sarabun New"/>
+              </a:defRPr>
+            </a:pPr>
+            <a:r>
+              <a:rPr b="1">
+                <a:solidFill>
+                  <a:srgbClr val="0F172A"/>
+                </a:solidFill>
+              </a:rPr>
+              <a:t>• Scoped Telemetry Window: </a:t>
+            </a:r>
+            <a:r>
+              <a:rPr b="0">
+                <a:solidFill>
+                  <a:srgbClr val="000000"/>
+                </a:solidFill>
+              </a:rPr>
+              <a:t>Captures System and Application logs over 24h (default maximum 500 events across combined query).</a:t>
+            </a:r>
+          </a:p>
+          <a:p>
+            <a:pPr>
+              <a:spcAft>
+                <a:spcPts val="400"/>
+              </a:spcAft>
+              <a:defRPr sz="1450">
+                <a:latin typeface="TH Sarabun New"/>
+              </a:defRPr>
+            </a:pPr>
+            <a:r>
+              <a:rPr b="1">
+                <a:solidFill>
+                  <a:srgbClr val="0F172A"/>
+                </a:solidFill>
+              </a:rPr>
+              <a:t>• Deterministic JSON Output: </a:t>
+            </a:r>
+            <a:r>
+              <a:rPr b="0">
+                <a:solidFill>
+                  <a:srgbClr val="000000"/>
+                </a:solidFill>
+              </a:rPr>
+              <a:t>Produces structured, schema-compliant JSON payloads for central offline import.</a:t>
+            </a:r>
+          </a:p>
+        </p:txBody>
+      </p:sp>
+      <p:sp>
+        <p:nvSpPr>
+          <p:cNvPr id="28" name="Rounded Rectangle 27"/>
           <p:cNvSpPr/>
           <p:nvPr/>
         </p:nvSpPr>
         <p:spPr>
           <a:xfrm>
-            <a:off x="11124000" y="12924000"/>
-            <a:ext cx="3060000" cy="1440000"/>
+            <a:off x="14400000" y="12384000"/>
+            <a:ext cx="6408000" cy="9360000"/>
+          </a:xfrm>
+          <a:prstGeom prst="roundRect">
+            <a:avLst/>
+          </a:prstGeom>
+          <a:solidFill>
+            <a:srgbClr val="F8FAFC"/>
+          </a:solidFill>
+          <a:ln w="19050">
+            <a:solidFill>
+              <a:srgbClr val="CBD5E1"/>
+            </a:solidFill>
+          </a:ln>
+        </p:spPr>
+        <p:style>
+          <a:lnRef idx="1">
+            <a:schemeClr val="accent1"/>
+          </a:lnRef>
+          <a:fillRef idx="3">
+            <a:schemeClr val="accent1"/>
+          </a:fillRef>
+          <a:effectRef idx="2">
+            <a:schemeClr val="accent1"/>
+          </a:effectRef>
+          <a:fontRef idx="minor">
+            <a:schemeClr val="lt1"/>
+          </a:fontRef>
+        </p:style>
+        <p:txBody>
+          <a:bodyPr rtlCol="0" anchor="ctr"/>
+          <a:lstStyle/>
+          <a:p>
+            <a:pPr algn="ctr"/>
+          </a:p>
+        </p:txBody>
+      </p:sp>
+      <p:sp>
+        <p:nvSpPr>
+          <p:cNvPr id="29" name="Rectangle 28"/>
+          <p:cNvSpPr/>
+          <p:nvPr/>
+        </p:nvSpPr>
+        <p:spPr>
+          <a:xfrm>
+            <a:off x="14400000" y="12384000"/>
+            <a:ext cx="6408000" cy="540000"/>
+          </a:xfrm>
+          <a:prstGeom prst="rect">
+            <a:avLst/>
+          </a:prstGeom>
+          <a:solidFill>
+            <a:srgbClr val="0F172A"/>
+          </a:solidFill>
+          <a:ln w="12700">
+            <a:solidFill>
+              <a:srgbClr val="CBD5E1"/>
+            </a:solidFill>
+          </a:ln>
+        </p:spPr>
+        <p:style>
+          <a:lnRef idx="1">
+            <a:schemeClr val="accent1"/>
+          </a:lnRef>
+          <a:fillRef idx="3">
+            <a:schemeClr val="accent1"/>
+          </a:fillRef>
+          <a:effectRef idx="2">
+            <a:schemeClr val="accent1"/>
+          </a:effectRef>
+          <a:fontRef idx="minor">
+            <a:schemeClr val="lt1"/>
+          </a:fontRef>
+        </p:style>
+        <p:txBody>
+          <a:bodyPr rtlCol="0" anchor="ctr" wrap="square" lIns="180000" tIns="54000"/>
+          <a:lstStyle/>
+          <a:p>
+            <a:pPr algn="l">
+              <a:defRPr sz="2100" b="1">
+                <a:solidFill>
+                  <a:srgbClr val="FFFFFF"/>
+                </a:solidFill>
+                <a:latin typeface="TH Sarabun New"/>
+              </a:defRPr>
+            </a:pPr>
+            <a:r>
+              <a:t>8. Validation Results &amp; Metrics</a:t>
+            </a:r>
+          </a:p>
+        </p:txBody>
+      </p:sp>
+      <p:sp>
+        <p:nvSpPr>
+          <p:cNvPr id="30" name="Rounded Rectangle 29"/>
+          <p:cNvSpPr/>
+          <p:nvPr/>
+        </p:nvSpPr>
+        <p:spPr>
+          <a:xfrm>
+            <a:off x="14544000" y="12996000"/>
+            <a:ext cx="2952000" cy="1152000"/>
           </a:xfrm>
           <a:prstGeom prst="roundRect">
             <a:avLst/>
@@ -4888,14 +5116,11 @@
           </a:fontRef>
         </p:style>
         <p:txBody>
-          <a:bodyPr rtlCol="0" anchor="ctr" wrap="square" lIns="72000" rIns="72000" tIns="72000" bIns="36000"/>
+          <a:bodyPr rtlCol="0" anchor="ctr" wrap="square" lIns="54000" rIns="54000" tIns="54000" bIns="36000"/>
           <a:lstStyle/>
           <a:p>
             <a:pPr algn="ctr">
-              <a:spcAft>
-                <a:spcPts val="100"/>
-              </a:spcAft>
-              <a:defRPr sz="3200" b="1">
+              <a:defRPr sz="2100" b="1">
                 <a:solidFill>
                   <a:srgbClr val="047857"/>
                 </a:solidFill>
@@ -4908,7 +5133,7 @@
           </a:p>
           <a:p>
             <a:pPr algn="ctr">
-              <a:defRPr sz="1600" b="1">
+              <a:defRPr sz="1150" b="1">
                 <a:solidFill>
                   <a:srgbClr val="0F172A"/>
                 </a:solidFill>
@@ -4919,31 +5144,18 @@
               <a:t>Hermetic Test Suite</a:t>
             </a:r>
           </a:p>
-          <a:p>
-            <a:pPr algn="ctr">
-              <a:defRPr sz="1300">
-                <a:solidFill>
-                  <a:srgbClr val="475569"/>
-                </a:solidFill>
-                <a:latin typeface="TH Sarabun New"/>
-              </a:defRPr>
-            </a:pPr>
-            <a:r>
-              <a:t>37 passed, 0 failed, 4 warnings</a:t>
-            </a:r>
-          </a:p>
-        </p:txBody>
-      </p:sp>
-      <p:sp>
-        <p:nvSpPr>
-          <p:cNvPr id="26" name="Rounded Rectangle 25"/>
+        </p:txBody>
+      </p:sp>
+      <p:sp>
+        <p:nvSpPr>
+          <p:cNvPr id="31" name="Rounded Rectangle 30"/>
           <p:cNvSpPr/>
           <p:nvPr/>
         </p:nvSpPr>
         <p:spPr>
           <a:xfrm>
-            <a:off x="14364000" y="12924000"/>
-            <a:ext cx="3060000" cy="1440000"/>
+            <a:off x="17712000" y="12996000"/>
+            <a:ext cx="2952000" cy="1152000"/>
           </a:xfrm>
           <a:prstGeom prst="roundRect">
             <a:avLst/>
@@ -4972,14 +5184,11 @@
           </a:fontRef>
         </p:style>
         <p:txBody>
-          <a:bodyPr rtlCol="0" anchor="ctr" wrap="square" lIns="72000" rIns="72000" tIns="72000" bIns="36000"/>
+          <a:bodyPr rtlCol="0" anchor="ctr" wrap="square" lIns="54000" rIns="54000" tIns="54000" bIns="36000"/>
           <a:lstStyle/>
           <a:p>
             <a:pPr algn="ctr">
-              <a:spcAft>
-                <a:spcPts val="100"/>
-              </a:spcAft>
-              <a:defRPr sz="3200" b="1">
+              <a:defRPr sz="2100" b="1">
                 <a:solidFill>
                   <a:srgbClr val="0F172A"/>
                 </a:solidFill>
@@ -4992,7 +5201,7 @@
           </a:p>
           <a:p>
             <a:pPr algn="ctr">
-              <a:defRPr sz="1600" b="1">
+              <a:defRPr sz="1150" b="1">
                 <a:solidFill>
                   <a:srgbClr val="0F172A"/>
                 </a:solidFill>
@@ -5000,34 +5209,21 @@
               </a:defRPr>
             </a:pPr>
             <a:r>
-              <a:t>Persisted Field Telemetry</a:t>
-            </a:r>
-          </a:p>
-          <a:p>
-            <a:pPr algn="ctr">
-              <a:defRPr sz="1300">
-                <a:solidFill>
-                  <a:srgbClr val="475569"/>
-                </a:solidFill>
-                <a:latin typeface="TH Sarabun New"/>
-              </a:defRPr>
-            </a:pPr>
-            <a:r>
-              <a:t>34 System + 15 Application</a:t>
-            </a:r>
-          </a:p>
-        </p:txBody>
-      </p:sp>
-      <p:sp>
-        <p:nvSpPr>
-          <p:cNvPr id="27" name="Rounded Rectangle 26"/>
+              <a:t>Persisted Telemetry</a:t>
+            </a:r>
+          </a:p>
+        </p:txBody>
+      </p:sp>
+      <p:sp>
+        <p:nvSpPr>
+          <p:cNvPr id="32" name="Rounded Rectangle 31"/>
           <p:cNvSpPr/>
           <p:nvPr/>
         </p:nvSpPr>
         <p:spPr>
           <a:xfrm>
-            <a:off x="17604000" y="12924000"/>
-            <a:ext cx="3060000" cy="1440000"/>
+            <a:off x="14544000" y="14256000"/>
+            <a:ext cx="2952000" cy="1152000"/>
           </a:xfrm>
           <a:prstGeom prst="roundRect">
             <a:avLst/>
@@ -5056,14 +5252,11 @@
           </a:fontRef>
         </p:style>
         <p:txBody>
-          <a:bodyPr rtlCol="0" anchor="ctr" wrap="square" lIns="72000" rIns="72000" tIns="72000" bIns="36000"/>
+          <a:bodyPr rtlCol="0" anchor="ctr" wrap="square" lIns="54000" rIns="54000" tIns="54000" bIns="36000"/>
           <a:lstStyle/>
           <a:p>
             <a:pPr algn="ctr">
-              <a:spcAft>
-                <a:spcPts val="100"/>
-              </a:spcAft>
-              <a:defRPr sz="3200" b="1">
+              <a:defRPr sz="2100" b="1">
                 <a:solidFill>
                   <a:srgbClr val="047857"/>
                 </a:solidFill>
@@ -5076,7 +5269,7 @@
           </a:p>
           <a:p>
             <a:pPr algn="ctr">
-              <a:defRPr sz="1600" b="1">
+              <a:defRPr sz="1150" b="1">
                 <a:solidFill>
                   <a:srgbClr val="0F172A"/>
                 </a:solidFill>
@@ -5087,31 +5280,18 @@
               <a:t>AnalysisHistory Cap</a:t>
             </a:r>
           </a:p>
-          <a:p>
-            <a:pPr algn="ctr">
-              <a:defRPr sz="1300">
-                <a:solidFill>
-                  <a:srgbClr val="475569"/>
-                </a:solidFill>
-                <a:latin typeface="TH Sarabun New"/>
-              </a:defRPr>
-            </a:pPr>
-            <a:r>
-              <a:t>10/10 prioritized events triaged</a:t>
-            </a:r>
-          </a:p>
-        </p:txBody>
-      </p:sp>
-      <p:sp>
-        <p:nvSpPr>
-          <p:cNvPr id="28" name="Rounded Rectangle 27"/>
+        </p:txBody>
+      </p:sp>
+      <p:sp>
+        <p:nvSpPr>
+          <p:cNvPr id="33" name="Rounded Rectangle 32"/>
           <p:cNvSpPr/>
           <p:nvPr/>
         </p:nvSpPr>
         <p:spPr>
           <a:xfrm>
-            <a:off x="11124000" y="14508000"/>
-            <a:ext cx="3060000" cy="1440000"/>
+            <a:off x="17712000" y="14256000"/>
+            <a:ext cx="2952000" cy="1152000"/>
           </a:xfrm>
           <a:prstGeom prst="roundRect">
             <a:avLst/>
@@ -5140,14 +5320,11 @@
           </a:fontRef>
         </p:style>
         <p:txBody>
-          <a:bodyPr rtlCol="0" anchor="ctr" wrap="square" lIns="72000" rIns="72000" tIns="72000" bIns="36000"/>
+          <a:bodyPr rtlCol="0" anchor="ctr" wrap="square" lIns="54000" rIns="54000" tIns="54000" bIns="36000"/>
           <a:lstStyle/>
           <a:p>
             <a:pPr algn="ctr">
-              <a:spcAft>
-                <a:spcPts val="100"/>
-              </a:spcAft>
-              <a:defRPr sz="3200" b="1">
+              <a:defRPr sz="2100" b="1">
                 <a:solidFill>
                   <a:srgbClr val="047857"/>
                 </a:solidFill>
@@ -5160,7 +5337,7 @@
           </a:p>
           <a:p>
             <a:pPr algn="ctr">
-              <a:defRPr sz="1600" b="1">
+              <a:defRPr sz="1150" b="1">
                 <a:solidFill>
                   <a:srgbClr val="0F172A"/>
                 </a:solidFill>
@@ -5171,31 +5348,18 @@
               <a:t>Filtered History API</a:t>
             </a:r>
           </a:p>
-          <a:p>
-            <a:pPr algn="ctr">
-              <a:defRPr sz="1300">
-                <a:solidFill>
-                  <a:srgbClr val="475569"/>
-                </a:solidFill>
-                <a:latin typeface="TH Sarabun New"/>
-              </a:defRPr>
-            </a:pPr>
-            <a:r>
-              <a:t>GET /api/v1/history?asset_id=...</a:t>
-            </a:r>
-          </a:p>
-        </p:txBody>
-      </p:sp>
-      <p:sp>
-        <p:nvSpPr>
-          <p:cNvPr id="29" name="Rounded Rectangle 28"/>
+        </p:txBody>
+      </p:sp>
+      <p:sp>
+        <p:nvSpPr>
+          <p:cNvPr id="34" name="Rounded Rectangle 33"/>
           <p:cNvSpPr/>
           <p:nvPr/>
         </p:nvSpPr>
         <p:spPr>
           <a:xfrm>
-            <a:off x="14364000" y="14508000"/>
-            <a:ext cx="3060000" cy="1440000"/>
+            <a:off x="14544000" y="15516000"/>
+            <a:ext cx="2952000" cy="1152000"/>
           </a:xfrm>
           <a:prstGeom prst="roundRect">
             <a:avLst/>
@@ -5224,14 +5388,11 @@
           </a:fontRef>
         </p:style>
         <p:txBody>
-          <a:bodyPr rtlCol="0" anchor="ctr" wrap="square" lIns="72000" rIns="72000" tIns="72000" bIns="36000"/>
+          <a:bodyPr rtlCol="0" anchor="ctr" wrap="square" lIns="54000" rIns="54000" tIns="54000" bIns="36000"/>
           <a:lstStyle/>
           <a:p>
             <a:pPr algn="ctr">
-              <a:spcAft>
-                <a:spcPts val="100"/>
-              </a:spcAft>
-              <a:defRPr sz="3200" b="1">
+              <a:defRPr sz="2100" b="1">
                 <a:solidFill>
                   <a:srgbClr val="047857"/>
                 </a:solidFill>
@@ -5244,7 +5405,7 @@
           </a:p>
           <a:p>
             <a:pPr algn="ctr">
-              <a:defRPr sz="1600" b="1">
+              <a:defRPr sz="1150" b="1">
                 <a:solidFill>
                   <a:srgbClr val="0F172A"/>
                 </a:solidFill>
@@ -5255,31 +5416,18 @@
               <a:t>Browser Runtime Gate</a:t>
             </a:r>
           </a:p>
-          <a:p>
-            <a:pPr algn="ctr">
-              <a:defRPr sz="1300">
-                <a:solidFill>
-                  <a:srgbClr val="475569"/>
-                </a:solidFill>
-                <a:latin typeface="TH Sarabun New"/>
-              </a:defRPr>
-            </a:pPr>
-            <a:r>
-              <a:t>49 events + active AI findings</a:t>
-            </a:r>
-          </a:p>
-        </p:txBody>
-      </p:sp>
-      <p:sp>
-        <p:nvSpPr>
-          <p:cNvPr id="30" name="Rounded Rectangle 29"/>
+        </p:txBody>
+      </p:sp>
+      <p:sp>
+        <p:nvSpPr>
+          <p:cNvPr id="35" name="Rounded Rectangle 34"/>
           <p:cNvSpPr/>
           <p:nvPr/>
         </p:nvSpPr>
         <p:spPr>
           <a:xfrm>
-            <a:off x="17604000" y="14508000"/>
-            <a:ext cx="3060000" cy="1440000"/>
+            <a:off x="17712000" y="15516000"/>
+            <a:ext cx="2952000" cy="1152000"/>
           </a:xfrm>
           <a:prstGeom prst="roundRect">
             <a:avLst/>
@@ -5308,14 +5456,11 @@
           </a:fontRef>
         </p:style>
         <p:txBody>
-          <a:bodyPr rtlCol="0" anchor="ctr" wrap="square" lIns="72000" rIns="72000" tIns="72000" bIns="36000"/>
+          <a:bodyPr rtlCol="0" anchor="ctr" wrap="square" lIns="54000" rIns="54000" tIns="54000" bIns="36000"/>
           <a:lstStyle/>
           <a:p>
             <a:pPr algn="ctr">
-              <a:spcAft>
-                <a:spcPts val="100"/>
-              </a:spcAft>
-              <a:defRPr sz="3200" b="1">
+              <a:defRPr sz="2100" b="1">
                 <a:solidFill>
                   <a:srgbClr val="047857"/>
                 </a:solidFill>
@@ -5328,7 +5473,7 @@
           </a:p>
           <a:p>
             <a:pPr algn="ctr">
-              <a:defRPr sz="1600" b="1">
+              <a:defRPr sz="1150" b="1">
                 <a:solidFill>
                   <a:srgbClr val="0F172A"/>
                 </a:solidFill>
@@ -5339,31 +5484,18 @@
               <a:t>Frontend Quality Gates</a:t>
             </a:r>
           </a:p>
-          <a:p>
-            <a:pPr algn="ctr">
-              <a:defRPr sz="1300">
-                <a:solidFill>
-                  <a:srgbClr val="475569"/>
-                </a:solidFill>
-                <a:latin typeface="TH Sarabun New"/>
-              </a:defRPr>
-            </a:pPr>
-            <a:r>
-              <a:t>Strict tsc &amp; Next.js build PASS</a:t>
-            </a:r>
-          </a:p>
-        </p:txBody>
-      </p:sp>
-      <p:sp>
-        <p:nvSpPr>
-          <p:cNvPr id="31" name="TextBox 30"/>
+        </p:txBody>
+      </p:sp>
+      <p:sp>
+        <p:nvSpPr>
+          <p:cNvPr id="36" name="TextBox 35"/>
           <p:cNvSpPr txBox="1"/>
           <p:nvPr/>
         </p:nvSpPr>
         <p:spPr>
           <a:xfrm>
-            <a:off x="11124000" y="16200000"/>
-            <a:ext cx="9540000" cy="3096000"/>
+            <a:off x="14508000" y="16920000"/>
+            <a:ext cx="6192000" cy="4680000"/>
           </a:xfrm>
           <a:prstGeom prst="rect">
             <a:avLst/>
@@ -5371,16 +5503,16 @@
           <a:noFill/>
         </p:spPr>
         <p:txBody>
-          <a:bodyPr wrap="square" lIns="108000" tIns="36000">
+          <a:bodyPr wrap="square" lIns="72000" tIns="36000">
             <a:spAutoFit/>
           </a:bodyPr>
           <a:lstStyle/>
           <a:p>
             <a:pPr>
               <a:spcAft>
-                <a:spcPts val="250"/>
+                <a:spcPts val="350"/>
               </a:spcAft>
-              <a:defRPr sz="1750">
+              <a:defRPr sz="1400">
                 <a:latin typeface="TH Sarabun New"/>
               </a:defRPr>
             </a:pPr>
@@ -5404,9 +5536,9 @@
           <a:p>
             <a:pPr>
               <a:spcAft>
-                <a:spcPts val="250"/>
+                <a:spcPts val="350"/>
               </a:spcAft>
-              <a:defRPr sz="1750">
+              <a:defRPr sz="1400">
                 <a:latin typeface="TH Sarabun New"/>
               </a:defRPr>
             </a:pPr>
@@ -5430,9 +5562,9 @@
           <a:p>
             <a:pPr>
               <a:spcAft>
-                <a:spcPts val="250"/>
+                <a:spcPts val="350"/>
               </a:spcAft>
-              <a:defRPr sz="1750">
+              <a:defRPr sz="1400">
                 <a:latin typeface="TH Sarabun New"/>
               </a:defRPr>
             </a:pPr>
@@ -5442,7 +5574,7 @@
                   <a:srgbClr val="0F172A"/>
                 </a:solidFill>
               </a:rPr>
-              <a:t>• Referential Provenance: </a:t>
+              <a:t>• A9 Runtime Verification: </a:t>
             </a:r>
             <a:r>
               <a:rPr b="0">
@@ -5450,21 +5582,21 @@
                   <a:srgbClr val="000000"/>
                 </a:solidFill>
               </a:rPr>
-              <a:t>Every AnalysisHistory recommendation maintains explicit referential linkage back to originating event_id, asset_id, and collection timestamp.</a:t>
-            </a:r>
-          </a:p>
-        </p:txBody>
-      </p:sp>
-      <p:sp>
-        <p:nvSpPr>
-          <p:cNvPr id="32" name="Rounded Rectangle 31"/>
+              <a:t>The field dataset contained 49 persisted Windows Event Evidence rows. The A9 browser check confirmed that Event Evidence and AI Findings were both available in the endpoint investigation view.</a:t>
+            </a:r>
+          </a:p>
+        </p:txBody>
+      </p:sp>
+      <p:sp>
+        <p:nvSpPr>
+          <p:cNvPr id="37" name="Rounded Rectangle 36"/>
           <p:cNvSpPr/>
           <p:nvPr/>
         </p:nvSpPr>
         <p:spPr>
           <a:xfrm>
-            <a:off x="10980000" y="19548000"/>
-            <a:ext cx="9828000" cy="4140000"/>
+            <a:off x="14400000" y="21960000"/>
+            <a:ext cx="6408000" cy="4140000"/>
           </a:xfrm>
           <a:prstGeom prst="roundRect">
             <a:avLst/>
@@ -5502,14 +5634,14 @@
       </p:sp>
       <p:sp>
         <p:nvSpPr>
-          <p:cNvPr id="33" name="Rectangle 32"/>
+          <p:cNvPr id="38" name="Rectangle 37"/>
           <p:cNvSpPr/>
           <p:nvPr/>
         </p:nvSpPr>
         <p:spPr>
           <a:xfrm>
-            <a:off x="10980000" y="19548000"/>
-            <a:ext cx="9828000" cy="612000"/>
+            <a:off x="14400000" y="21960000"/>
+            <a:ext cx="6408000" cy="540000"/>
           </a:xfrm>
           <a:prstGeom prst="rect">
             <a:avLst/>
@@ -5538,11 +5670,11 @@
           </a:fontRef>
         </p:style>
         <p:txBody>
-          <a:bodyPr rtlCol="0" anchor="ctr" wrap="square" lIns="288000" tIns="72000"/>
+          <a:bodyPr rtlCol="0" anchor="ctr" wrap="square" lIns="180000" tIns="54000"/>
           <a:lstStyle/>
           <a:p>
             <a:pPr algn="l">
-              <a:defRPr sz="2600" b="1">
+              <a:defRPr sz="2100" b="1">
                 <a:solidFill>
                   <a:srgbClr val="FFFFFF"/>
                 </a:solidFill>
@@ -5550,21 +5682,21 @@
               </a:defRPr>
             </a:pPr>
             <a:r>
-              <a:t>8. Scoped Limitations &amp; Operational Boundaries</a:t>
-            </a:r>
-          </a:p>
-        </p:txBody>
-      </p:sp>
-      <p:sp>
-        <p:nvSpPr>
-          <p:cNvPr id="34" name="TextBox 33"/>
+              <a:t>9. Limitations &amp; Future Work</a:t>
+            </a:r>
+          </a:p>
+        </p:txBody>
+      </p:sp>
+      <p:sp>
+        <p:nvSpPr>
+          <p:cNvPr id="39" name="TextBox 38"/>
           <p:cNvSpPr txBox="1"/>
           <p:nvPr/>
         </p:nvSpPr>
         <p:spPr>
           <a:xfrm>
-            <a:off x="11124000" y="20196000"/>
-            <a:ext cx="9540000" cy="3420000"/>
+            <a:off x="14508000" y="22536000"/>
+            <a:ext cx="6192000" cy="3456000"/>
           </a:xfrm>
           <a:prstGeom prst="rect">
             <a:avLst/>
@@ -5572,178 +5704,153 @@
           <a:noFill/>
         </p:spPr>
         <p:txBody>
-          <a:bodyPr wrap="square" lIns="108000" tIns="36000">
+          <a:bodyPr wrap="square" lIns="72000" tIns="36000">
             <a:spAutoFit/>
           </a:bodyPr>
           <a:lstStyle/>
           <a:p>
             <a:pPr>
               <a:spcAft>
-                <a:spcPts val="200"/>
+                <a:spcPts val="100"/>
               </a:spcAft>
-              <a:defRPr sz="1750">
-                <a:latin typeface="TH Sarabun New"/>
-              </a:defRPr>
-            </a:pPr>
-            <a:r>
-              <a:rPr b="1">
+              <a:defRPr sz="1400" b="1">
                 <a:solidFill>
                   <a:srgbClr val="0F172A"/>
                 </a:solidFill>
-              </a:rPr>
-              <a:t>• Windows-First Focus: </a:t>
-            </a:r>
-            <a:r>
-              <a:rPr b="0">
-                <a:solidFill>
-                  <a:srgbClr val="000000"/>
-                </a:solidFill>
-              </a:rPr>
-              <a:t>Portable collection targets Windows WMI/winevt subsystems; Linux/macOS collectors deferred.</a:t>
+                <a:latin typeface="TH Sarabun New"/>
+              </a:defRPr>
+            </a:pPr>
+            <a:r>
+              <a:t>Scoped Limitations:</a:t>
             </a:r>
           </a:p>
           <a:p>
             <a:pPr>
               <a:spcAft>
-                <a:spcPts val="200"/>
+                <a:spcPts val="100"/>
               </a:spcAft>
-              <a:defRPr sz="1750">
-                <a:latin typeface="TH Sarabun New"/>
-              </a:defRPr>
-            </a:pPr>
-            <a:r>
-              <a:rPr b="1">
-                <a:solidFill>
-                  <a:srgbClr val="0F172A"/>
-                </a:solidFill>
-              </a:rPr>
-              <a:t>• Scoped Telemetry Channels: </a:t>
-            </a:r>
-            <a:r>
-              <a:rPr b="0">
+              <a:defRPr sz="1300">
                 <a:solidFill>
                   <a:srgbClr val="000000"/>
                 </a:solidFill>
-              </a:rPr>
-              <a:t>Constrained to System and Application logs; high-volume Security authentication logs excluded.</a:t>
+                <a:latin typeface="TH Sarabun New"/>
+              </a:defRPr>
+            </a:pPr>
+            <a:r>
+              <a:t>• Windows-first collection focus (WMI/winevt); System and Application channels only.</a:t>
             </a:r>
           </a:p>
           <a:p>
             <a:pPr>
               <a:spcAft>
-                <a:spcPts val="200"/>
+                <a:spcPts val="100"/>
               </a:spcAft>
-              <a:defRPr sz="1750">
-                <a:latin typeface="TH Sarabun New"/>
-              </a:defRPr>
-            </a:pPr>
-            <a:r>
-              <a:rPr b="1">
-                <a:solidFill>
-                  <a:srgbClr val="0F172A"/>
-                </a:solidFill>
-              </a:rPr>
-              <a:t>• Sequential Dedup Only: </a:t>
-            </a:r>
-            <a:r>
-              <a:rPr b="0">
+              <a:defRPr sz="1300">
                 <a:solidFill>
                   <a:srgbClr val="000000"/>
                 </a:solidFill>
-              </a:rPr>
-              <a:t>Application-level sequential deduplication; does not provide distributed concurrent database locks.</a:t>
+                <a:latin typeface="TH Sarabun New"/>
+              </a:defRPr>
+            </a:pPr>
+            <a:r>
+              <a:t>• Sequential deduplication in memory; concurrent identical imports may race.</a:t>
             </a:r>
           </a:p>
           <a:p>
             <a:pPr>
               <a:spcAft>
+                <a:spcPts val="100"/>
+              </a:spcAft>
+              <a:defRPr sz="1300">
+                <a:solidFill>
+                  <a:srgbClr val="000000"/>
+                </a:solidFill>
+                <a:latin typeface="TH Sarabun New"/>
+              </a:defRPr>
+            </a:pPr>
+            <a:r>
+              <a:t>• Prototype baseline; does not include multi-region HA or enterprise SSO.</a:t>
+            </a:r>
+          </a:p>
+          <a:p>
+            <a:pPr>
+              <a:spcBef>
                 <a:spcPts val="200"/>
+              </a:spcBef>
+              <a:spcAft>
+                <a:spcPts val="100"/>
               </a:spcAft>
-              <a:defRPr sz="1750">
-                <a:latin typeface="TH Sarabun New"/>
-              </a:defRPr>
-            </a:pPr>
-            <a:r>
-              <a:rPr b="1">
+              <a:defRPr sz="1400" b="1">
                 <a:solidFill>
                   <a:srgbClr val="0F172A"/>
                 </a:solidFill>
-              </a:rPr>
-              <a:t>• Bounded Triage Capacity: </a:t>
-            </a:r>
-            <a:r>
-              <a:rPr b="0">
-                <a:solidFill>
-                  <a:srgbClr val="000000"/>
-                </a:solidFill>
-              </a:rPr>
-              <a:t>Analyzer cap strictly limits AI triage to at most 10 prioritized events per batch import.</a:t>
+                <a:latin typeface="TH Sarabun New"/>
+              </a:defRPr>
+            </a:pPr>
+            <a:r>
+              <a:t>Future Engineering Work:</a:t>
             </a:r>
           </a:p>
           <a:p>
             <a:pPr>
               <a:spcAft>
-                <a:spcPts val="200"/>
+                <a:spcPts val="100"/>
               </a:spcAft>
-              <a:defRPr sz="1750">
-                <a:latin typeface="TH Sarabun New"/>
-              </a:defRPr>
-            </a:pPr>
-            <a:r>
-              <a:rPr b="1">
-                <a:solidFill>
-                  <a:srgbClr val="0F172A"/>
-                </a:solidFill>
-              </a:rPr>
-              <a:t>• Assistive Role: </a:t>
-            </a:r>
-            <a:r>
-              <a:rPr b="0">
+              <a:defRPr sz="1300">
                 <a:solidFill>
                   <a:srgbClr val="000000"/>
                 </a:solidFill>
-              </a:rPr>
-              <a:t>AI suggests diagnostic hypotheses; does not act as autonomous authority or execute automated remediation.</a:t>
+                <a:latin typeface="TH Sarabun New"/>
+              </a:defRPr>
+            </a:pPr>
+            <a:r>
+              <a:t>• Database-level concurrency-safe deduplication (PostgreSQL composite UNIQUE constraints).</a:t>
             </a:r>
           </a:p>
           <a:p>
             <a:pPr>
               <a:spcAft>
-                <a:spcPts val="200"/>
+                <a:spcPts val="100"/>
               </a:spcAft>
-              <a:defRPr sz="1750">
-                <a:latin typeface="TH Sarabun New"/>
-              </a:defRPr>
-            </a:pPr>
-            <a:r>
-              <a:rPr b="1">
-                <a:solidFill>
-                  <a:srgbClr val="0F172A"/>
-                </a:solidFill>
-              </a:rPr>
-              <a:t>• Academic Prototype Baseline: </a:t>
-            </a:r>
-            <a:r>
-              <a:rPr b="0">
+              <a:defRPr sz="1300">
                 <a:solidFill>
                   <a:srgbClr val="000000"/>
                 </a:solidFill>
-              </a:rPr>
-              <a:t>Evaluated single-instance prototype baseline; not a commercial SIEM or certified forensics suite.</a:t>
-            </a:r>
-          </a:p>
-        </p:txBody>
-      </p:sp>
-      <p:sp>
-        <p:nvSpPr>
-          <p:cNvPr id="35" name="Rounded Rectangle 34"/>
+                <a:latin typeface="TH Sarabun New"/>
+              </a:defRPr>
+            </a:pPr>
+            <a:r>
+              <a:t>• Cross-endpoint event correlation (multi-host temporal incident clustering).</a:t>
+            </a:r>
+          </a:p>
+          <a:p>
+            <a:pPr>
+              <a:spcAft>
+                <a:spcPts val="100"/>
+              </a:spcAft>
+              <a:defRPr sz="1300">
+                <a:solidFill>
+                  <a:srgbClr val="000000"/>
+                </a:solidFill>
+                <a:latin typeface="TH Sarabun New"/>
+              </a:defRPr>
+            </a:pPr>
+            <a:r>
+              <a:t>• Production reliability and identity integration (clustering, SAML 2.0 / OIDC SSO).</a:t>
+            </a:r>
+          </a:p>
+        </p:txBody>
+      </p:sp>
+      <p:sp>
+        <p:nvSpPr>
+          <p:cNvPr id="40" name="Rounded Rectangle 39"/>
           <p:cNvSpPr/>
           <p:nvPr/>
         </p:nvSpPr>
         <p:spPr>
           <a:xfrm>
-            <a:off x="10980000" y="23868000"/>
-            <a:ext cx="9828000" cy="5868000"/>
+            <a:off x="14400000" y="26316000"/>
+            <a:ext cx="6408000" cy="3492000"/>
           </a:xfrm>
           <a:prstGeom prst="roundRect">
             <a:avLst/>
@@ -5781,14 +5888,14 @@
       </p:sp>
       <p:sp>
         <p:nvSpPr>
-          <p:cNvPr id="36" name="Rectangle 35"/>
+          <p:cNvPr id="41" name="Rectangle 40"/>
           <p:cNvSpPr/>
           <p:nvPr/>
         </p:nvSpPr>
         <p:spPr>
           <a:xfrm>
-            <a:off x="10980000" y="23868000"/>
-            <a:ext cx="9828000" cy="612000"/>
+            <a:off x="14400000" y="26316000"/>
+            <a:ext cx="6408000" cy="540000"/>
           </a:xfrm>
           <a:prstGeom prst="rect">
             <a:avLst/>
@@ -5817,11 +5924,11 @@
           </a:fontRef>
         </p:style>
         <p:txBody>
-          <a:bodyPr rtlCol="0" anchor="ctr" wrap="square" lIns="288000" tIns="72000"/>
+          <a:bodyPr rtlCol="0" anchor="ctr" wrap="square" lIns="180000" tIns="54000"/>
           <a:lstStyle/>
           <a:p>
             <a:pPr algn="l">
-              <a:defRPr sz="2600" b="1">
+              <a:defRPr sz="2100" b="1">
                 <a:solidFill>
                   <a:srgbClr val="FFFFFF"/>
                 </a:solidFill>
@@ -5829,21 +5936,21 @@
               </a:defRPr>
             </a:pPr>
             <a:r>
-              <a:t>9. Project Conclusion &amp; Future Roadmap</a:t>
-            </a:r>
-          </a:p>
-        </p:txBody>
-      </p:sp>
-      <p:sp>
-        <p:nvSpPr>
-          <p:cNvPr id="37" name="TextBox 36"/>
+              <a:t>10. Conclusion &amp; Approval</a:t>
+            </a:r>
+          </a:p>
+        </p:txBody>
+      </p:sp>
+      <p:sp>
+        <p:nvSpPr>
+          <p:cNvPr id="42" name="TextBox 41"/>
           <p:cNvSpPr txBox="1"/>
           <p:nvPr/>
         </p:nvSpPr>
         <p:spPr>
           <a:xfrm>
-            <a:off x="11124000" y="24516000"/>
-            <a:ext cx="9540000" cy="5148000"/>
+            <a:off x="14508000" y="26892000"/>
+            <a:ext cx="6192000" cy="2844000"/>
           </a:xfrm>
           <a:prstGeom prst="rect">
             <a:avLst/>
@@ -5851,7 +5958,7 @@
           <a:noFill/>
         </p:spPr>
         <p:txBody>
-          <a:bodyPr wrap="square" lIns="108000" tIns="36000">
+          <a:bodyPr wrap="square" lIns="72000" tIns="36000">
             <a:spAutoFit/>
           </a:bodyPr>
           <a:lstStyle/>
@@ -5860,7 +5967,7 @@
               <a:spcAft>
                 <a:spcPts val="100"/>
               </a:spcAft>
-              <a:defRPr sz="1900" b="1">
+              <a:defRPr sz="1350" b="1">
                 <a:solidFill>
                   <a:srgbClr val="0F172A"/>
                 </a:solidFill>
@@ -5868,7 +5975,74 @@
               </a:defRPr>
             </a:pPr>
             <a:r>
-              <a:t>Summary of Key Achievements:</a:t>
+              <a:t>Conclusion:</a:t>
+            </a:r>
+          </a:p>
+          <a:p>
+            <a:pPr>
+              <a:spcAft>
+                <a:spcPts val="50"/>
+              </a:spcAft>
+              <a:defRPr sz="1200">
+                <a:solidFill>
+                  <a:srgbClr val="000000"/>
+                </a:solidFill>
+                <a:latin typeface="TH Sarabun New"/>
+              </a:defRPr>
+            </a:pPr>
+            <a:r>
+              <a:t>• EIMS centralizes asset inventory and operational evidence through hardware fingerprints.</a:t>
+            </a:r>
+          </a:p>
+          <a:p>
+            <a:pPr>
+              <a:spcAft>
+                <a:spcPts val="50"/>
+              </a:spcAft>
+              <a:defRPr sz="1200">
+                <a:solidFill>
+                  <a:srgbClr val="000000"/>
+                </a:solidFill>
+                <a:latin typeface="TH Sarabun New"/>
+              </a:defRPr>
+            </a:pPr>
+            <a:r>
+              <a:t>• Portable collection safely acquires air-gapped evidence via embedded CPython 3.14.3.</a:t>
+            </a:r>
+          </a:p>
+          <a:p>
+            <a:pPr>
+              <a:spcAft>
+                <a:spcPts val="50"/>
+              </a:spcAft>
+              <a:defRPr sz="1200">
+                <a:solidFill>
+                  <a:srgbClr val="000000"/>
+                </a:solidFill>
+                <a:latin typeface="TH Sarabun New"/>
+              </a:defRPr>
+            </a:pPr>
+            <a:r>
+              <a:t>• Multi-tier validation confirmed end-to-end evidence ingestion and triage integrity.</a:t>
+            </a:r>
+          </a:p>
+          <a:p>
+            <a:pPr>
+              <a:spcBef>
+                <a:spcPts val="150"/>
+              </a:spcBef>
+              <a:spcAft>
+                <a:spcPts val="50"/>
+              </a:spcAft>
+              <a:defRPr sz="1250" b="1">
+                <a:solidFill>
+                  <a:srgbClr val="0F172A"/>
+                </a:solidFill>
+                <a:latin typeface="TH Sarabun New"/>
+              </a:defRPr>
+            </a:pPr>
+            <a:r>
+              <a:t>Acknowledgment:</a:t>
             </a:r>
           </a:p>
           <a:p>
@@ -5876,226 +6050,39 @@
               <a:spcAft>
                 <a:spcPts val="150"/>
               </a:spcAft>
-              <a:defRPr sz="1700">
-                <a:latin typeface="TH Sarabun New"/>
-              </a:defRPr>
-            </a:pPr>
-            <a:r>
-              <a:rPr b="1">
+              <a:defRPr sz="1150" i="1">
+                <a:solidFill>
+                  <a:srgbClr val="475569"/>
+                </a:solidFill>
+                <a:latin typeface="TH Sarabun New"/>
+              </a:defRPr>
+            </a:pPr>
+            <a:r>
+              <a:t>Sincere gratitude to KANEMATSU ELECTRONICS (THAILAND) for host enterprise support, Workplace Supervisor Mr. Chalermpol Phuangchalam for professional guidance, and Academic Supervisor Asst. Prof. Dr. Phongsak Keeratiwintakorn for academic mentorship.</a:t>
+            </a:r>
+          </a:p>
+          <a:p>
+            <a:pPr algn="ctr">
+              <a:spcBef>
+                <a:spcPts val="100"/>
+              </a:spcBef>
+              <a:defRPr sz="1150" b="1">
                 <a:solidFill>
                   <a:srgbClr val="0F172A"/>
                 </a:solidFill>
-              </a:rPr>
-              <a:t>• Centralized Infrastructure Governance: </a:t>
-            </a:r>
-            <a:r>
-              <a:rPr b="0">
-                <a:solidFill>
-                  <a:srgbClr val="000000"/>
-                </a:solidFill>
-              </a:rPr>
-              <a:t>Unified asset tracking anchored by cryptographic hardware composite fingerprints.</a:t>
-            </a:r>
-          </a:p>
-          <a:p>
-            <a:pPr>
-              <a:spcAft>
-                <a:spcPts val="150"/>
-              </a:spcAft>
-              <a:defRPr sz="1700">
-                <a:latin typeface="TH Sarabun New"/>
-              </a:defRPr>
-            </a:pPr>
-            <a:r>
-              <a:rPr b="1">
-                <a:solidFill>
-                  <a:srgbClr val="0F172A"/>
-                </a:solidFill>
-              </a:rPr>
-              <a:t>• Air-Gapped Evidence Acquisition: </a:t>
-            </a:r>
-            <a:r>
-              <a:rPr b="0">
-                <a:solidFill>
-                  <a:srgbClr val="000000"/>
-                </a:solidFill>
-              </a:rPr>
-              <a:t>Non-destructive offline collection utilizing self-contained embedded CPython 3.14.3.</a:t>
-            </a:r>
-          </a:p>
-          <a:p>
-            <a:pPr>
-              <a:spcAft>
-                <a:spcPts val="150"/>
-              </a:spcAft>
-              <a:defRPr sz="1700">
-                <a:latin typeface="TH Sarabun New"/>
-              </a:defRPr>
-            </a:pPr>
-            <a:r>
-              <a:rPr b="1">
-                <a:solidFill>
-                  <a:srgbClr val="0F172A"/>
-                </a:solidFill>
-              </a:rPr>
-              <a:t>• Deterministic Deduplication &amp; Bounded Triage: </a:t>
-            </a:r>
-            <a:r>
-              <a:rPr b="0">
-                <a:solidFill>
-                  <a:srgbClr val="000000"/>
-                </a:solidFill>
-              </a:rPr>
-              <a:t>Enforced sequential SHA-256 event fingerprinting and 10-event RAG triage.</a:t>
-            </a:r>
-          </a:p>
-          <a:p>
-            <a:pPr>
-              <a:spcAft>
-                <a:spcPts val="150"/>
-              </a:spcAft>
-              <a:defRPr sz="1700">
-                <a:latin typeface="TH Sarabun New"/>
-              </a:defRPr>
-            </a:pPr>
-            <a:r>
-              <a:rPr b="1">
-                <a:solidFill>
-                  <a:srgbClr val="0F172A"/>
-                </a:solidFill>
-              </a:rPr>
-              <a:t>• Empirically Validated Pipeline: </a:t>
-            </a:r>
-            <a:r>
-              <a:rPr b="0">
-                <a:solidFill>
-                  <a:srgbClr val="000000"/>
-                </a:solidFill>
-              </a:rPr>
-              <a:t>Confirmed end-to-end data integrity across 49 field events, HTTP 200 API, and Gate A9.</a:t>
-            </a:r>
-          </a:p>
-          <a:p>
-            <a:pPr>
-              <a:spcBef>
-                <a:spcPts val="300"/>
-              </a:spcBef>
-              <a:spcAft>
-                <a:spcPts val="100"/>
-              </a:spcAft>
-              <a:defRPr sz="1900" b="1">
-                <a:solidFill>
-                  <a:srgbClr val="0F172A"/>
-                </a:solidFill>
-                <a:latin typeface="TH Sarabun New"/>
-              </a:defRPr>
-            </a:pPr>
-            <a:r>
-              <a:t>Future Engineering Roadmap:</a:t>
-            </a:r>
-          </a:p>
-          <a:p>
-            <a:pPr>
-              <a:spcAft>
-                <a:spcPts val="150"/>
-              </a:spcAft>
-              <a:defRPr sz="1700">
-                <a:latin typeface="TH Sarabun New"/>
-              </a:defRPr>
-            </a:pPr>
-            <a:r>
-              <a:rPr b="1">
-                <a:solidFill>
-                  <a:srgbClr val="0F172A"/>
-                </a:solidFill>
-              </a:rPr>
-              <a:t>• Database-Level Concurrency: </a:t>
-            </a:r>
-            <a:r>
-              <a:rPr b="0">
-                <a:solidFill>
-                  <a:srgbClr val="000000"/>
-                </a:solidFill>
-              </a:rPr>
-              <a:t>Enforce PostgreSQL composite UNIQUE constraints with ON CONFLICT DO NOTHING for parallel imports.</a:t>
-            </a:r>
-          </a:p>
-          <a:p>
-            <a:pPr>
-              <a:spcAft>
-                <a:spcPts val="150"/>
-              </a:spcAft>
-              <a:defRPr sz="1700">
-                <a:latin typeface="TH Sarabun New"/>
-              </a:defRPr>
-            </a:pPr>
-            <a:r>
-              <a:rPr b="1">
-                <a:solidFill>
-                  <a:srgbClr val="0F172A"/>
-                </a:solidFill>
-              </a:rPr>
-              <a:t>• Cross-Endpoint Event Correlation: </a:t>
-            </a:r>
-            <a:r>
-              <a:rPr b="0">
-                <a:solidFill>
-                  <a:srgbClr val="000000"/>
-                </a:solidFill>
-              </a:rPr>
-              <a:t>Implement multi-host temporal clustering to detect infrastructure-wide incident chains.</a:t>
-            </a:r>
-          </a:p>
-          <a:p>
-            <a:pPr>
-              <a:spcAft>
-                <a:spcPts val="150"/>
-              </a:spcAft>
-              <a:defRPr sz="1700">
-                <a:latin typeface="TH Sarabun New"/>
-              </a:defRPr>
-            </a:pPr>
-            <a:r>
-              <a:rPr b="1">
-                <a:solidFill>
-                  <a:srgbClr val="0F172A"/>
-                </a:solidFill>
-              </a:rPr>
-              <a:t>• Enterprise Directory Federation: </a:t>
-            </a:r>
-            <a:r>
-              <a:rPr b="0">
-                <a:solidFill>
-                  <a:srgbClr val="000000"/>
-                </a:solidFill>
-              </a:rPr>
-              <a:t>Integrate SAML 2.0 / OIDC single sign-on with corporate Active Directory domain controllers.</a:t>
-            </a:r>
-          </a:p>
-          <a:p>
-            <a:pPr>
-              <a:spcAft>
-                <a:spcPts val="150"/>
-              </a:spcAft>
-              <a:defRPr sz="1700">
-                <a:latin typeface="TH Sarabun New"/>
-              </a:defRPr>
-            </a:pPr>
-            <a:r>
-              <a:rPr b="1">
-                <a:solidFill>
-                  <a:srgbClr val="0F172A"/>
-                </a:solidFill>
-              </a:rPr>
-              <a:t>• Cross-Platform Collection: </a:t>
-            </a:r>
-            <a:r>
-              <a:rPr b="0">
-                <a:solidFill>
-                  <a:srgbClr val="000000"/>
-                </a:solidFill>
-              </a:rPr>
-              <a:t>Develop lightweight portable collectors for Linux systemd journals and macOS logging subsystems.</a:t>
+                <a:latin typeface="TH Sarabun New"/>
+              </a:defRPr>
+            </a:pPr>
+            <a:r>
+              <a:t>___________________________________________________</a:t>
+            </a:r>
+            <a:br/>
+            <a:r>
+              <a:t>Asst. Prof. Dr. Phongsak Keeratiwintakorn (Project Advisor)</a:t>
+            </a:r>
+            <a:br/>
+            <a:r>
+              <a:t>Date: ________ / ________ / 2026</a:t>
             </a:r>
           </a:p>
         </p:txBody>

</xml_diff>

<commit_message>
docs: finalize cooperative education submission package
</commit_message>
<xml_diff>
--- a/docs/poster/EIMS_COOP_POSTER_2026.pptx
+++ b/docs/poster/EIMS_COOP_POSTER_2026.pptx
@@ -3148,11 +3148,11 @@
             <a:avLst/>
           </a:prstGeom>
           <a:solidFill>
-            <a:srgbClr val="1E293B"/>
+            <a:srgbClr val="FFFFFF"/>
           </a:solidFill>
           <a:ln w="19050">
             <a:solidFill>
-              <a:srgbClr val="94A3B8"/>
+              <a:srgbClr val="CBD5E1"/>
             </a:solidFill>
           </a:ln>
         </p:spPr>
@@ -3171,30 +3171,40 @@
           </a:fontRef>
         </p:style>
         <p:txBody>
-          <a:bodyPr rtlCol="0" anchor="ctr" wrap="square" lIns="36000" rIns="36000" tIns="180000"/>
-          <a:lstStyle/>
-          <a:p>
-            <a:pPr algn="ctr">
-              <a:defRPr sz="1200" b="1">
-                <a:solidFill>
-                  <a:srgbClr val="E2E8F0"/>
-                </a:solidFill>
-                <a:latin typeface="TH Sarabun New"/>
-              </a:defRPr>
-            </a:pPr>
-            <a:r>
-              <a:t>KMITL</a:t>
-            </a:r>
-            <a:br/>
-            <a:r>
-              <a:t>SEAL</a:t>
-            </a:r>
-          </a:p>
-        </p:txBody>
-      </p:sp>
-      <p:sp>
-        <p:nvSpPr>
-          <p:cNvPr id="4" name="TextBox 3"/>
+          <a:bodyPr rtlCol="0" anchor="ctr"/>
+          <a:lstStyle/>
+          <a:p>
+            <a:pPr algn="ctr"/>
+          </a:p>
+        </p:txBody>
+      </p:sp>
+      <p:pic>
+        <p:nvPicPr>
+          <p:cNvPr id="4" name="Picture 3" descr="kmitl_seal_clean.png"/>
+          <p:cNvPicPr>
+            <a:picLocks noChangeAspect="1"/>
+          </p:cNvPicPr>
+          <p:nvPr/>
+        </p:nvPicPr>
+        <p:blipFill>
+          <a:blip r:embed="rId2"/>
+          <a:stretch>
+            <a:fillRect/>
+          </a:stretch>
+        </p:blipFill>
+        <p:spPr>
+          <a:xfrm>
+            <a:off x="828000" y="576000"/>
+            <a:ext cx="1152000" cy="1152000"/>
+          </a:xfrm>
+          <a:prstGeom prst="rect">
+            <a:avLst/>
+          </a:prstGeom>
+        </p:spPr>
+      </p:pic>
+      <p:sp>
+        <p:nvSpPr>
+          <p:cNvPr id="5" name="TextBox 4"/>
           <p:cNvSpPr txBox="1"/>
           <p:nvPr/>
         </p:nvSpPr>
@@ -3222,7 +3232,7 @@
                 <a:solidFill>
                   <a:srgbClr val="94A3B8"/>
                 </a:solidFill>
-                <a:latin typeface="TH Sarabun New"/>
+                <a:latin typeface="Angsana New"/>
               </a:defRPr>
             </a:pPr>
             <a:r>
@@ -3245,7 +3255,7 @@
                 <a:solidFill>
                   <a:srgbClr val="FFFFFF"/>
                 </a:solidFill>
-                <a:latin typeface="TH Sarabun New"/>
+                <a:latin typeface="Angsana New"/>
               </a:defRPr>
             </a:pPr>
             <a:r>
@@ -3261,7 +3271,7 @@
                 <a:solidFill>
                   <a:srgbClr val="E2E8F0"/>
                 </a:solidFill>
-                <a:latin typeface="TH Sarabun New"/>
+                <a:latin typeface="Angsana New"/>
               </a:defRPr>
             </a:pPr>
             <a:r>
@@ -3274,7 +3284,7 @@
                 <a:solidFill>
                   <a:srgbClr val="CBD5E1"/>
                 </a:solidFill>
-                <a:latin typeface="TH Sarabun New"/>
+                <a:latin typeface="Angsana New"/>
               </a:defRPr>
             </a:pPr>
             <a:r>
@@ -3285,7 +3295,7 @@
       </p:sp>
       <p:sp>
         <p:nvSpPr>
-          <p:cNvPr id="5" name="Rounded Rectangle 4"/>
+          <p:cNvPr id="6" name="Rounded Rectangle 5"/>
           <p:cNvSpPr/>
           <p:nvPr/>
         </p:nvSpPr>
@@ -3330,7 +3340,7 @@
       </p:sp>
       <p:sp>
         <p:nvSpPr>
-          <p:cNvPr id="6" name="Rectangle 5"/>
+          <p:cNvPr id="7" name="Rectangle 6"/>
           <p:cNvSpPr/>
           <p:nvPr/>
         </p:nvSpPr>
@@ -3374,7 +3384,7 @@
                 <a:solidFill>
                   <a:srgbClr val="FFFFFF"/>
                 </a:solidFill>
-                <a:latin typeface="TH Sarabun New"/>
+                <a:latin typeface="Angsana New"/>
               </a:defRPr>
             </a:pPr>
             <a:r>
@@ -3385,7 +3395,7 @@
       </p:sp>
       <p:sp>
         <p:nvSpPr>
-          <p:cNvPr id="7" name="TextBox 6"/>
+          <p:cNvPr id="8" name="TextBox 7"/>
           <p:cNvSpPr txBox="1"/>
           <p:nvPr/>
         </p:nvSpPr>
@@ -3409,11 +3419,11 @@
               <a:spcAft>
                 <a:spcPts val="200"/>
               </a:spcAft>
-              <a:defRPr sz="1550">
+              <a:defRPr sz="1700">
                 <a:solidFill>
                   <a:srgbClr val="000000"/>
                 </a:solidFill>
-                <a:latin typeface="TH Sarabun New"/>
+                <a:latin typeface="Angsana New"/>
               </a:defRPr>
             </a:pPr>
             <a:r>
@@ -3424,7 +3434,7 @@
       </p:sp>
       <p:sp>
         <p:nvSpPr>
-          <p:cNvPr id="8" name="Rounded Rectangle 7"/>
+          <p:cNvPr id="9" name="Rounded Rectangle 8"/>
           <p:cNvSpPr/>
           <p:nvPr/>
         </p:nvSpPr>
@@ -3469,7 +3479,7 @@
       </p:sp>
       <p:sp>
         <p:nvSpPr>
-          <p:cNvPr id="9" name="Rectangle 8"/>
+          <p:cNvPr id="10" name="Rectangle 9"/>
           <p:cNvSpPr/>
           <p:nvPr/>
         </p:nvSpPr>
@@ -3513,7 +3523,7 @@
                 <a:solidFill>
                   <a:srgbClr val="FFFFFF"/>
                 </a:solidFill>
-                <a:latin typeface="TH Sarabun New"/>
+                <a:latin typeface="Angsana New"/>
               </a:defRPr>
             </a:pPr>
             <a:r>
@@ -3524,7 +3534,7 @@
       </p:sp>
       <p:sp>
         <p:nvSpPr>
-          <p:cNvPr id="10" name="TextBox 9"/>
+          <p:cNvPr id="11" name="TextBox 10"/>
           <p:cNvSpPr txBox="1"/>
           <p:nvPr/>
         </p:nvSpPr>
@@ -3546,10 +3556,10 @@
           <a:p>
             <a:pPr>
               <a:spcAft>
-                <a:spcPts val="900"/>
+                <a:spcPts val="1200"/>
               </a:spcAft>
-              <a:defRPr sz="1550">
-                <a:latin typeface="TH Sarabun New"/>
+              <a:defRPr sz="1650">
+                <a:latin typeface="Angsana New"/>
               </a:defRPr>
             </a:pPr>
             <a:r>
@@ -3572,10 +3582,10 @@
           <a:p>
             <a:pPr>
               <a:spcAft>
-                <a:spcPts val="900"/>
+                <a:spcPts val="1200"/>
               </a:spcAft>
-              <a:defRPr sz="1550">
-                <a:latin typeface="TH Sarabun New"/>
+              <a:defRPr sz="1650">
+                <a:latin typeface="Angsana New"/>
               </a:defRPr>
             </a:pPr>
             <a:r>
@@ -3598,10 +3608,10 @@
           <a:p>
             <a:pPr>
               <a:spcAft>
-                <a:spcPts val="900"/>
+                <a:spcPts val="1200"/>
               </a:spcAft>
-              <a:defRPr sz="1550">
-                <a:latin typeface="TH Sarabun New"/>
+              <a:defRPr sz="1650">
+                <a:latin typeface="Angsana New"/>
               </a:defRPr>
             </a:pPr>
             <a:r>
@@ -3624,10 +3634,10 @@
           <a:p>
             <a:pPr>
               <a:spcAft>
-                <a:spcPts val="900"/>
+                <a:spcPts val="1200"/>
               </a:spcAft>
-              <a:defRPr sz="1550">
-                <a:latin typeface="TH Sarabun New"/>
+              <a:defRPr sz="1650">
+                <a:latin typeface="Angsana New"/>
               </a:defRPr>
             </a:pPr>
             <a:r>
@@ -3651,7 +3661,7 @@
       </p:sp>
       <p:sp>
         <p:nvSpPr>
-          <p:cNvPr id="11" name="Rounded Rectangle 10"/>
+          <p:cNvPr id="12" name="Rounded Rectangle 11"/>
           <p:cNvSpPr/>
           <p:nvPr/>
         </p:nvSpPr>
@@ -3696,7 +3706,7 @@
       </p:sp>
       <p:sp>
         <p:nvSpPr>
-          <p:cNvPr id="12" name="Rectangle 11"/>
+          <p:cNvPr id="13" name="Rectangle 12"/>
           <p:cNvSpPr/>
           <p:nvPr/>
         </p:nvSpPr>
@@ -3740,7 +3750,7 @@
                 <a:solidFill>
                   <a:srgbClr val="FFFFFF"/>
                 </a:solidFill>
-                <a:latin typeface="TH Sarabun New"/>
+                <a:latin typeface="Angsana New"/>
               </a:defRPr>
             </a:pPr>
             <a:r>
@@ -3751,7 +3761,7 @@
       </p:sp>
       <p:sp>
         <p:nvSpPr>
-          <p:cNvPr id="13" name="TextBox 12"/>
+          <p:cNvPr id="14" name="TextBox 13"/>
           <p:cNvSpPr txBox="1"/>
           <p:nvPr/>
         </p:nvSpPr>
@@ -3773,10 +3783,10 @@
           <a:p>
             <a:pPr>
               <a:spcAft>
-                <a:spcPts val="1000"/>
+                <a:spcPts val="1200"/>
               </a:spcAft>
-              <a:defRPr sz="1500">
-                <a:latin typeface="TH Sarabun New"/>
+              <a:defRPr sz="1650">
+                <a:latin typeface="Angsana New"/>
               </a:defRPr>
             </a:pPr>
             <a:r>
@@ -3799,10 +3809,10 @@
           <a:p>
             <a:pPr>
               <a:spcAft>
-                <a:spcPts val="1000"/>
+                <a:spcPts val="1200"/>
               </a:spcAft>
-              <a:defRPr sz="1500">
-                <a:latin typeface="TH Sarabun New"/>
+              <a:defRPr sz="1650">
+                <a:latin typeface="Angsana New"/>
               </a:defRPr>
             </a:pPr>
             <a:r>
@@ -3825,10 +3835,10 @@
           <a:p>
             <a:pPr>
               <a:spcAft>
-                <a:spcPts val="1000"/>
+                <a:spcPts val="1200"/>
               </a:spcAft>
-              <a:defRPr sz="1500">
-                <a:latin typeface="TH Sarabun New"/>
+              <a:defRPr sz="1650">
+                <a:latin typeface="Angsana New"/>
               </a:defRPr>
             </a:pPr>
             <a:r>
@@ -3851,10 +3861,10 @@
           <a:p>
             <a:pPr>
               <a:spcAft>
-                <a:spcPts val="1000"/>
+                <a:spcPts val="1200"/>
               </a:spcAft>
-              <a:defRPr sz="1500">
-                <a:latin typeface="TH Sarabun New"/>
+              <a:defRPr sz="1650">
+                <a:latin typeface="Angsana New"/>
               </a:defRPr>
             </a:pPr>
             <a:r>
@@ -3877,10 +3887,10 @@
           <a:p>
             <a:pPr>
               <a:spcAft>
-                <a:spcPts val="1000"/>
+                <a:spcPts val="1200"/>
               </a:spcAft>
-              <a:defRPr sz="1500">
-                <a:latin typeface="TH Sarabun New"/>
+              <a:defRPr sz="1650">
+                <a:latin typeface="Angsana New"/>
               </a:defRPr>
             </a:pPr>
             <a:r>
@@ -3903,10 +3913,10 @@
           <a:p>
             <a:pPr>
               <a:spcAft>
-                <a:spcPts val="1000"/>
+                <a:spcPts val="1200"/>
               </a:spcAft>
-              <a:defRPr sz="1500">
-                <a:latin typeface="TH Sarabun New"/>
+              <a:defRPr sz="1650">
+                <a:latin typeface="Angsana New"/>
               </a:defRPr>
             </a:pPr>
             <a:r>
@@ -3929,10 +3939,10 @@
           <a:p>
             <a:pPr>
               <a:spcAft>
-                <a:spcPts val="1000"/>
+                <a:spcPts val="1200"/>
               </a:spcAft>
-              <a:defRPr sz="1500">
-                <a:latin typeface="TH Sarabun New"/>
+              <a:defRPr sz="1650">
+                <a:latin typeface="Angsana New"/>
               </a:defRPr>
             </a:pPr>
             <a:r>
@@ -3956,7 +3966,7 @@
       </p:sp>
       <p:sp>
         <p:nvSpPr>
-          <p:cNvPr id="14" name="Rounded Rectangle 13"/>
+          <p:cNvPr id="15" name="Rounded Rectangle 14"/>
           <p:cNvSpPr/>
           <p:nvPr/>
         </p:nvSpPr>
@@ -4001,7 +4011,7 @@
       </p:sp>
       <p:sp>
         <p:nvSpPr>
-          <p:cNvPr id="15" name="Rectangle 14"/>
+          <p:cNvPr id="16" name="Rectangle 15"/>
           <p:cNvSpPr/>
           <p:nvPr/>
         </p:nvSpPr>
@@ -4045,7 +4055,7 @@
                 <a:solidFill>
                   <a:srgbClr val="FFFFFF"/>
                 </a:solidFill>
-                <a:latin typeface="TH Sarabun New"/>
+                <a:latin typeface="Angsana New"/>
               </a:defRPr>
             </a:pPr>
             <a:r>
@@ -4056,14 +4066,14 @@
       </p:sp>
       <p:pic>
         <p:nvPicPr>
-          <p:cNvPr id="16" name="Picture 15" descr="fig3_1_architecture.png"/>
+          <p:cNvPr id="17" name="Picture 16" descr="fig3_1_architecture.png"/>
           <p:cNvPicPr>
             <a:picLocks noChangeAspect="1"/>
           </p:cNvPicPr>
           <p:nvPr/>
         </p:nvPicPr>
         <p:blipFill>
-          <a:blip r:embed="rId2"/>
+          <a:blip r:embed="rId3"/>
           <a:stretch>
             <a:fillRect/>
           </a:stretch>
@@ -4080,7 +4090,7 @@
       </p:pic>
       <p:sp>
         <p:nvSpPr>
-          <p:cNvPr id="17" name="TextBox 16"/>
+          <p:cNvPr id="18" name="TextBox 17"/>
           <p:cNvSpPr txBox="1"/>
           <p:nvPr/>
         </p:nvSpPr>
@@ -4102,10 +4112,10 @@
           <a:p>
             <a:pPr>
               <a:spcAft>
-                <a:spcPts val="600"/>
+                <a:spcPts val="800"/>
               </a:spcAft>
-              <a:defRPr sz="1500">
-                <a:latin typeface="TH Sarabun New"/>
+              <a:defRPr sz="1650">
+                <a:latin typeface="Angsana New"/>
               </a:defRPr>
             </a:pPr>
             <a:r>
@@ -4128,10 +4138,10 @@
           <a:p>
             <a:pPr>
               <a:spcAft>
-                <a:spcPts val="600"/>
+                <a:spcPts val="800"/>
               </a:spcAft>
-              <a:defRPr sz="1500">
-                <a:latin typeface="TH Sarabun New"/>
+              <a:defRPr sz="1650">
+                <a:latin typeface="Angsana New"/>
               </a:defRPr>
             </a:pPr>
             <a:r>
@@ -4154,10 +4164,10 @@
           <a:p>
             <a:pPr>
               <a:spcAft>
-                <a:spcPts val="600"/>
+                <a:spcPts val="800"/>
               </a:spcAft>
-              <a:defRPr sz="1500">
-                <a:latin typeface="TH Sarabun New"/>
+              <a:defRPr sz="1650">
+                <a:latin typeface="Angsana New"/>
               </a:defRPr>
             </a:pPr>
             <a:r>
@@ -4181,7 +4191,7 @@
       </p:sp>
       <p:sp>
         <p:nvSpPr>
-          <p:cNvPr id="18" name="Rounded Rectangle 17"/>
+          <p:cNvPr id="19" name="Rounded Rectangle 18"/>
           <p:cNvSpPr/>
           <p:nvPr/>
         </p:nvSpPr>
@@ -4226,7 +4236,7 @@
       </p:sp>
       <p:sp>
         <p:nvSpPr>
-          <p:cNvPr id="19" name="Rectangle 18"/>
+          <p:cNvPr id="20" name="Rectangle 19"/>
           <p:cNvSpPr/>
           <p:nvPr/>
         </p:nvSpPr>
@@ -4270,7 +4280,7 @@
                 <a:solidFill>
                   <a:srgbClr val="FFFFFF"/>
                 </a:solidFill>
-                <a:latin typeface="TH Sarabun New"/>
+                <a:latin typeface="Angsana New"/>
               </a:defRPr>
             </a:pPr>
             <a:r>
@@ -4281,7 +4291,7 @@
       </p:sp>
       <p:sp>
         <p:nvSpPr>
-          <p:cNvPr id="20" name="TextBox 19"/>
+          <p:cNvPr id="21" name="TextBox 20"/>
           <p:cNvSpPr txBox="1"/>
           <p:nvPr/>
         </p:nvSpPr>
@@ -4303,10 +4313,10 @@
           <a:p>
             <a:pPr>
               <a:spcAft>
-                <a:spcPts val="700"/>
+                <a:spcPts val="900"/>
               </a:spcAft>
-              <a:defRPr sz="1500">
-                <a:latin typeface="TH Sarabun New"/>
+              <a:defRPr sz="1650">
+                <a:latin typeface="Angsana New"/>
               </a:defRPr>
             </a:pPr>
             <a:r>
@@ -4329,10 +4339,10 @@
           <a:p>
             <a:pPr>
               <a:spcAft>
-                <a:spcPts val="700"/>
+                <a:spcPts val="900"/>
               </a:spcAft>
-              <a:defRPr sz="1500">
-                <a:latin typeface="TH Sarabun New"/>
+              <a:defRPr sz="1650">
+                <a:latin typeface="Angsana New"/>
               </a:defRPr>
             </a:pPr>
             <a:r>
@@ -4355,10 +4365,10 @@
           <a:p>
             <a:pPr>
               <a:spcAft>
-                <a:spcPts val="700"/>
+                <a:spcPts val="900"/>
               </a:spcAft>
-              <a:defRPr sz="1500">
-                <a:latin typeface="TH Sarabun New"/>
+              <a:defRPr sz="1650">
+                <a:latin typeface="Angsana New"/>
               </a:defRPr>
             </a:pPr>
             <a:r>
@@ -4381,10 +4391,10 @@
           <a:p>
             <a:pPr>
               <a:spcAft>
-                <a:spcPts val="700"/>
+                <a:spcPts val="900"/>
               </a:spcAft>
-              <a:defRPr sz="1500">
-                <a:latin typeface="TH Sarabun New"/>
+              <a:defRPr sz="1650">
+                <a:latin typeface="Angsana New"/>
               </a:defRPr>
             </a:pPr>
             <a:r>
@@ -4407,10 +4417,10 @@
           <a:p>
             <a:pPr>
               <a:spcAft>
-                <a:spcPts val="700"/>
+                <a:spcPts val="900"/>
               </a:spcAft>
-              <a:defRPr sz="1500">
-                <a:latin typeface="TH Sarabun New"/>
+              <a:defRPr sz="1650">
+                <a:latin typeface="Angsana New"/>
               </a:defRPr>
             </a:pPr>
             <a:r>
@@ -4433,10 +4443,10 @@
           <a:p>
             <a:pPr>
               <a:spcAft>
-                <a:spcPts val="700"/>
+                <a:spcPts val="900"/>
               </a:spcAft>
-              <a:defRPr sz="1500">
-                <a:latin typeface="TH Sarabun New"/>
+              <a:defRPr sz="1650">
+                <a:latin typeface="Angsana New"/>
               </a:defRPr>
             </a:pPr>
             <a:r>
@@ -4460,7 +4470,7 @@
       </p:sp>
       <p:sp>
         <p:nvSpPr>
-          <p:cNvPr id="21" name="Rounded Rectangle 20"/>
+          <p:cNvPr id="22" name="Rounded Rectangle 21"/>
           <p:cNvSpPr/>
           <p:nvPr/>
         </p:nvSpPr>
@@ -4505,7 +4515,7 @@
       </p:sp>
       <p:sp>
         <p:nvSpPr>
-          <p:cNvPr id="22" name="Rectangle 21"/>
+          <p:cNvPr id="23" name="Rectangle 22"/>
           <p:cNvSpPr/>
           <p:nvPr/>
         </p:nvSpPr>
@@ -4549,7 +4559,7 @@
                 <a:solidFill>
                   <a:srgbClr val="FFFFFF"/>
                 </a:solidFill>
-                <a:latin typeface="TH Sarabun New"/>
+                <a:latin typeface="Angsana New"/>
               </a:defRPr>
             </a:pPr>
             <a:r>
@@ -4560,7 +4570,7 @@
       </p:sp>
       <p:sp>
         <p:nvSpPr>
-          <p:cNvPr id="23" name="TextBox 22"/>
+          <p:cNvPr id="24" name="TextBox 23"/>
           <p:cNvSpPr txBox="1"/>
           <p:nvPr/>
         </p:nvSpPr>
@@ -4584,7 +4594,7 @@
               <a:spcAft>
                 <a:spcPts val="500"/>
               </a:spcAft>
-              <a:defRPr sz="1300" b="1">
+              <a:defRPr sz="1400" b="1">
                 <a:solidFill>
                   <a:srgbClr val="1E40AF"/>
                 </a:solidFill>
@@ -4600,8 +4610,8 @@
               <a:spcAft>
                 <a:spcPts val="600"/>
               </a:spcAft>
-              <a:defRPr sz="1450">
-                <a:latin typeface="TH Sarabun New"/>
+              <a:defRPr sz="1600">
+                <a:latin typeface="Angsana New"/>
               </a:defRPr>
             </a:pPr>
             <a:r>
@@ -4626,8 +4636,8 @@
               <a:spcAft>
                 <a:spcPts val="600"/>
               </a:spcAft>
-              <a:defRPr sz="1450">
-                <a:latin typeface="TH Sarabun New"/>
+              <a:defRPr sz="1600">
+                <a:latin typeface="Angsana New"/>
               </a:defRPr>
             </a:pPr>
             <a:r>
@@ -4652,8 +4662,8 @@
               <a:spcAft>
                 <a:spcPts val="600"/>
               </a:spcAft>
-              <a:defRPr sz="1450">
-                <a:latin typeface="TH Sarabun New"/>
+              <a:defRPr sz="1600">
+                <a:latin typeface="Angsana New"/>
               </a:defRPr>
             </a:pPr>
             <a:r>
@@ -4678,8 +4688,8 @@
               <a:spcAft>
                 <a:spcPts val="600"/>
               </a:spcAft>
-              <a:defRPr sz="1450">
-                <a:latin typeface="TH Sarabun New"/>
+              <a:defRPr sz="1600">
+                <a:latin typeface="Angsana New"/>
               </a:defRPr>
             </a:pPr>
             <a:r>
@@ -4704,8 +4714,8 @@
               <a:spcAft>
                 <a:spcPts val="600"/>
               </a:spcAft>
-              <a:defRPr sz="1450">
-                <a:latin typeface="TH Sarabun New"/>
+              <a:defRPr sz="1600">
+                <a:latin typeface="Angsana New"/>
               </a:defRPr>
             </a:pPr>
             <a:r>
@@ -4729,7 +4739,7 @@
       </p:sp>
       <p:sp>
         <p:nvSpPr>
-          <p:cNvPr id="24" name="Rounded Rectangle 23"/>
+          <p:cNvPr id="25" name="Rounded Rectangle 24"/>
           <p:cNvSpPr/>
           <p:nvPr/>
         </p:nvSpPr>
@@ -4774,7 +4784,7 @@
       </p:sp>
       <p:sp>
         <p:nvSpPr>
-          <p:cNvPr id="25" name="Rectangle 24"/>
+          <p:cNvPr id="26" name="Rectangle 25"/>
           <p:cNvSpPr/>
           <p:nvPr/>
         </p:nvSpPr>
@@ -4818,7 +4828,7 @@
                 <a:solidFill>
                   <a:srgbClr val="FFFFFF"/>
                 </a:solidFill>
-                <a:latin typeface="TH Sarabun New"/>
+                <a:latin typeface="Angsana New"/>
               </a:defRPr>
             </a:pPr>
             <a:r>
@@ -4829,14 +4839,14 @@
       </p:sp>
       <p:pic>
         <p:nvPicPr>
-          <p:cNvPr id="26" name="Picture 25" descr="fig3_3_sequence.png"/>
+          <p:cNvPr id="27" name="Picture 26" descr="fig3_3_sequence.png"/>
           <p:cNvPicPr>
             <a:picLocks noChangeAspect="1"/>
           </p:cNvPicPr>
           <p:nvPr/>
         </p:nvPicPr>
         <p:blipFill>
-          <a:blip r:embed="rId3"/>
+          <a:blip r:embed="rId4"/>
           <a:stretch>
             <a:fillRect/>
           </a:stretch>
@@ -4853,7 +4863,7 @@
       </p:pic>
       <p:sp>
         <p:nvSpPr>
-          <p:cNvPr id="27" name="TextBox 26"/>
+          <p:cNvPr id="28" name="TextBox 27"/>
           <p:cNvSpPr txBox="1"/>
           <p:nvPr/>
         </p:nvSpPr>
@@ -4875,10 +4885,10 @@
           <a:p>
             <a:pPr>
               <a:spcAft>
-                <a:spcPts val="400"/>
+                <a:spcPts val="600"/>
               </a:spcAft>
-              <a:defRPr sz="1450">
-                <a:latin typeface="TH Sarabun New"/>
+              <a:defRPr sz="1600">
+                <a:latin typeface="Angsana New"/>
               </a:defRPr>
             </a:pPr>
             <a:r>
@@ -4901,10 +4911,10 @@
           <a:p>
             <a:pPr>
               <a:spcAft>
-                <a:spcPts val="400"/>
+                <a:spcPts val="600"/>
               </a:spcAft>
-              <a:defRPr sz="1450">
-                <a:latin typeface="TH Sarabun New"/>
+              <a:defRPr sz="1600">
+                <a:latin typeface="Angsana New"/>
               </a:defRPr>
             </a:pPr>
             <a:r>
@@ -4927,10 +4937,10 @@
           <a:p>
             <a:pPr>
               <a:spcAft>
-                <a:spcPts val="400"/>
+                <a:spcPts val="600"/>
               </a:spcAft>
-              <a:defRPr sz="1450">
-                <a:latin typeface="TH Sarabun New"/>
+              <a:defRPr sz="1600">
+                <a:latin typeface="Angsana New"/>
               </a:defRPr>
             </a:pPr>
             <a:r>
@@ -4953,10 +4963,10 @@
           <a:p>
             <a:pPr>
               <a:spcAft>
-                <a:spcPts val="400"/>
+                <a:spcPts val="600"/>
               </a:spcAft>
-              <a:defRPr sz="1450">
-                <a:latin typeface="TH Sarabun New"/>
+              <a:defRPr sz="1600">
+                <a:latin typeface="Angsana New"/>
               </a:defRPr>
             </a:pPr>
             <a:r>
@@ -4980,7 +4990,7 @@
       </p:sp>
       <p:sp>
         <p:nvSpPr>
-          <p:cNvPr id="28" name="Rounded Rectangle 27"/>
+          <p:cNvPr id="29" name="Rounded Rectangle 28"/>
           <p:cNvSpPr/>
           <p:nvPr/>
         </p:nvSpPr>
@@ -5025,7 +5035,7 @@
       </p:sp>
       <p:sp>
         <p:nvSpPr>
-          <p:cNvPr id="29" name="Rectangle 28"/>
+          <p:cNvPr id="30" name="Rectangle 29"/>
           <p:cNvSpPr/>
           <p:nvPr/>
         </p:nvSpPr>
@@ -5069,7 +5079,7 @@
                 <a:solidFill>
                   <a:srgbClr val="FFFFFF"/>
                 </a:solidFill>
-                <a:latin typeface="TH Sarabun New"/>
+                <a:latin typeface="Angsana New"/>
               </a:defRPr>
             </a:pPr>
             <a:r>
@@ -5080,7 +5090,7 @@
       </p:sp>
       <p:sp>
         <p:nvSpPr>
-          <p:cNvPr id="30" name="Rounded Rectangle 29"/>
+          <p:cNvPr id="31" name="Rounded Rectangle 30"/>
           <p:cNvSpPr/>
           <p:nvPr/>
         </p:nvSpPr>
@@ -5124,7 +5134,7 @@
                 <a:solidFill>
                   <a:srgbClr val="047857"/>
                 </a:solidFill>
-                <a:latin typeface="TH Sarabun New"/>
+                <a:latin typeface="Angsana New"/>
               </a:defRPr>
             </a:pPr>
             <a:r>
@@ -5137,7 +5147,7 @@
                 <a:solidFill>
                   <a:srgbClr val="0F172A"/>
                 </a:solidFill>
-                <a:latin typeface="TH Sarabun New"/>
+                <a:latin typeface="Angsana New"/>
               </a:defRPr>
             </a:pPr>
             <a:r>
@@ -5148,7 +5158,7 @@
       </p:sp>
       <p:sp>
         <p:nvSpPr>
-          <p:cNvPr id="31" name="Rounded Rectangle 30"/>
+          <p:cNvPr id="32" name="Rounded Rectangle 31"/>
           <p:cNvSpPr/>
           <p:nvPr/>
         </p:nvSpPr>
@@ -5192,7 +5202,7 @@
                 <a:solidFill>
                   <a:srgbClr val="0F172A"/>
                 </a:solidFill>
-                <a:latin typeface="TH Sarabun New"/>
+                <a:latin typeface="Angsana New"/>
               </a:defRPr>
             </a:pPr>
             <a:r>
@@ -5205,7 +5215,7 @@
                 <a:solidFill>
                   <a:srgbClr val="0F172A"/>
                 </a:solidFill>
-                <a:latin typeface="TH Sarabun New"/>
+                <a:latin typeface="Angsana New"/>
               </a:defRPr>
             </a:pPr>
             <a:r>
@@ -5216,7 +5226,7 @@
       </p:sp>
       <p:sp>
         <p:nvSpPr>
-          <p:cNvPr id="32" name="Rounded Rectangle 31"/>
+          <p:cNvPr id="33" name="Rounded Rectangle 32"/>
           <p:cNvSpPr/>
           <p:nvPr/>
         </p:nvSpPr>
@@ -5260,7 +5270,7 @@
                 <a:solidFill>
                   <a:srgbClr val="047857"/>
                 </a:solidFill>
-                <a:latin typeface="TH Sarabun New"/>
+                <a:latin typeface="Angsana New"/>
               </a:defRPr>
             </a:pPr>
             <a:r>
@@ -5273,18 +5283,18 @@
                 <a:solidFill>
                   <a:srgbClr val="0F172A"/>
                 </a:solidFill>
-                <a:latin typeface="TH Sarabun New"/>
-              </a:defRPr>
-            </a:pPr>
-            <a:r>
-              <a:t>AnalysisHistory Cap</a:t>
-            </a:r>
-          </a:p>
-        </p:txBody>
-      </p:sp>
-      <p:sp>
-        <p:nvSpPr>
-          <p:cNvPr id="33" name="Rounded Rectangle 32"/>
+                <a:latin typeface="Angsana New"/>
+              </a:defRPr>
+            </a:pPr>
+            <a:r>
+              <a:t>AnalysisHistory Records</a:t>
+            </a:r>
+          </a:p>
+        </p:txBody>
+      </p:sp>
+      <p:sp>
+        <p:nvSpPr>
+          <p:cNvPr id="34" name="Rounded Rectangle 33"/>
           <p:cNvSpPr/>
           <p:nvPr/>
         </p:nvSpPr>
@@ -5328,7 +5338,7 @@
                 <a:solidFill>
                   <a:srgbClr val="047857"/>
                 </a:solidFill>
-                <a:latin typeface="TH Sarabun New"/>
+                <a:latin typeface="Angsana New"/>
               </a:defRPr>
             </a:pPr>
             <a:r>
@@ -5341,7 +5351,7 @@
                 <a:solidFill>
                   <a:srgbClr val="0F172A"/>
                 </a:solidFill>
-                <a:latin typeface="TH Sarabun New"/>
+                <a:latin typeface="Angsana New"/>
               </a:defRPr>
             </a:pPr>
             <a:r>
@@ -5352,7 +5362,7 @@
       </p:sp>
       <p:sp>
         <p:nvSpPr>
-          <p:cNvPr id="34" name="Rounded Rectangle 33"/>
+          <p:cNvPr id="35" name="Rounded Rectangle 34"/>
           <p:cNvSpPr/>
           <p:nvPr/>
         </p:nvSpPr>
@@ -5396,7 +5406,7 @@
                 <a:solidFill>
                   <a:srgbClr val="047857"/>
                 </a:solidFill>
-                <a:latin typeface="TH Sarabun New"/>
+                <a:latin typeface="Angsana New"/>
               </a:defRPr>
             </a:pPr>
             <a:r>
@@ -5409,7 +5419,7 @@
                 <a:solidFill>
                   <a:srgbClr val="0F172A"/>
                 </a:solidFill>
-                <a:latin typeface="TH Sarabun New"/>
+                <a:latin typeface="Angsana New"/>
               </a:defRPr>
             </a:pPr>
             <a:r>
@@ -5420,7 +5430,7 @@
       </p:sp>
       <p:sp>
         <p:nvSpPr>
-          <p:cNvPr id="35" name="Rounded Rectangle 34"/>
+          <p:cNvPr id="36" name="Rounded Rectangle 35"/>
           <p:cNvSpPr/>
           <p:nvPr/>
         </p:nvSpPr>
@@ -5464,7 +5474,7 @@
                 <a:solidFill>
                   <a:srgbClr val="047857"/>
                 </a:solidFill>
-                <a:latin typeface="TH Sarabun New"/>
+                <a:latin typeface="Angsana New"/>
               </a:defRPr>
             </a:pPr>
             <a:r>
@@ -5477,7 +5487,7 @@
                 <a:solidFill>
                   <a:srgbClr val="0F172A"/>
                 </a:solidFill>
-                <a:latin typeface="TH Sarabun New"/>
+                <a:latin typeface="Angsana New"/>
               </a:defRPr>
             </a:pPr>
             <a:r>
@@ -5488,7 +5498,7 @@
       </p:sp>
       <p:sp>
         <p:nvSpPr>
-          <p:cNvPr id="36" name="TextBox 35"/>
+          <p:cNvPr id="37" name="TextBox 36"/>
           <p:cNvSpPr txBox="1"/>
           <p:nvPr/>
         </p:nvSpPr>
@@ -5510,10 +5520,10 @@
           <a:p>
             <a:pPr>
               <a:spcAft>
-                <a:spcPts val="350"/>
+                <a:spcPts val="450"/>
               </a:spcAft>
-              <a:defRPr sz="1400">
-                <a:latin typeface="TH Sarabun New"/>
+              <a:defRPr sz="1500">
+                <a:latin typeface="Angsana New"/>
               </a:defRPr>
             </a:pPr>
             <a:r>
@@ -5530,16 +5540,16 @@
                   <a:srgbClr val="000000"/>
                 </a:solidFill>
               </a:rPr>
-              <a:t>The 49 events represent persisted evidence in the database. The analyzer is strictly bounded to at most 10 selected new events per import (not claiming all 49 were analyzed by AI).</a:t>
+              <a:t>The 49 events represent persisted evidence in the database. 10 AnalysisHistory records were created associated with the selected field dataset, matching the analyzer's strict cap of at most 10 selected new events per import.</a:t>
             </a:r>
           </a:p>
           <a:p>
             <a:pPr>
               <a:spcAft>
-                <a:spcPts val="350"/>
+                <a:spcPts val="450"/>
               </a:spcAft>
-              <a:defRPr sz="1400">
-                <a:latin typeface="TH Sarabun New"/>
+              <a:defRPr sz="1500">
+                <a:latin typeface="Angsana New"/>
               </a:defRPr>
             </a:pPr>
             <a:r>
@@ -5562,10 +5572,10 @@
           <a:p>
             <a:pPr>
               <a:spcAft>
-                <a:spcPts val="350"/>
+                <a:spcPts val="450"/>
               </a:spcAft>
-              <a:defRPr sz="1400">
-                <a:latin typeface="TH Sarabun New"/>
+              <a:defRPr sz="1500">
+                <a:latin typeface="Angsana New"/>
               </a:defRPr>
             </a:pPr>
             <a:r>
@@ -5589,7 +5599,7 @@
       </p:sp>
       <p:sp>
         <p:nvSpPr>
-          <p:cNvPr id="37" name="Rounded Rectangle 36"/>
+          <p:cNvPr id="38" name="Rounded Rectangle 37"/>
           <p:cNvSpPr/>
           <p:nvPr/>
         </p:nvSpPr>
@@ -5634,7 +5644,7 @@
       </p:sp>
       <p:sp>
         <p:nvSpPr>
-          <p:cNvPr id="38" name="Rectangle 37"/>
+          <p:cNvPr id="39" name="Rectangle 38"/>
           <p:cNvSpPr/>
           <p:nvPr/>
         </p:nvSpPr>
@@ -5678,7 +5688,7 @@
                 <a:solidFill>
                   <a:srgbClr val="FFFFFF"/>
                 </a:solidFill>
-                <a:latin typeface="TH Sarabun New"/>
+                <a:latin typeface="Angsana New"/>
               </a:defRPr>
             </a:pPr>
             <a:r>
@@ -5689,7 +5699,7 @@
       </p:sp>
       <p:sp>
         <p:nvSpPr>
-          <p:cNvPr id="39" name="TextBox 38"/>
+          <p:cNvPr id="40" name="TextBox 39"/>
           <p:cNvSpPr txBox="1"/>
           <p:nvPr/>
         </p:nvSpPr>
@@ -5713,11 +5723,11 @@
               <a:spcAft>
                 <a:spcPts val="100"/>
               </a:spcAft>
-              <a:defRPr sz="1400" b="1">
+              <a:defRPr sz="1550" b="1">
                 <a:solidFill>
                   <a:srgbClr val="0F172A"/>
                 </a:solidFill>
-                <a:latin typeface="TH Sarabun New"/>
+                <a:latin typeface="Angsana New"/>
               </a:defRPr>
             </a:pPr>
             <a:r>
@@ -5727,13 +5737,13 @@
           <a:p>
             <a:pPr>
               <a:spcAft>
-                <a:spcPts val="100"/>
+                <a:spcPts val="200"/>
               </a:spcAft>
-              <a:defRPr sz="1300">
+              <a:defRPr sz="1450">
                 <a:solidFill>
                   <a:srgbClr val="000000"/>
                 </a:solidFill>
-                <a:latin typeface="TH Sarabun New"/>
+                <a:latin typeface="Angsana New"/>
               </a:defRPr>
             </a:pPr>
             <a:r>
@@ -5743,13 +5753,13 @@
           <a:p>
             <a:pPr>
               <a:spcAft>
-                <a:spcPts val="100"/>
+                <a:spcPts val="200"/>
               </a:spcAft>
-              <a:defRPr sz="1300">
+              <a:defRPr sz="1450">
                 <a:solidFill>
                   <a:srgbClr val="000000"/>
                 </a:solidFill>
-                <a:latin typeface="TH Sarabun New"/>
+                <a:latin typeface="Angsana New"/>
               </a:defRPr>
             </a:pPr>
             <a:r>
@@ -5759,13 +5769,13 @@
           <a:p>
             <a:pPr>
               <a:spcAft>
-                <a:spcPts val="100"/>
+                <a:spcPts val="200"/>
               </a:spcAft>
-              <a:defRPr sz="1300">
+              <a:defRPr sz="1450">
                 <a:solidFill>
                   <a:srgbClr val="000000"/>
                 </a:solidFill>
-                <a:latin typeface="TH Sarabun New"/>
+                <a:latin typeface="Angsana New"/>
               </a:defRPr>
             </a:pPr>
             <a:r>
@@ -5775,16 +5785,16 @@
           <a:p>
             <a:pPr>
               <a:spcBef>
-                <a:spcPts val="200"/>
+                <a:spcPts val="300"/>
               </a:spcBef>
               <a:spcAft>
                 <a:spcPts val="100"/>
               </a:spcAft>
-              <a:defRPr sz="1400" b="1">
+              <a:defRPr sz="1550" b="1">
                 <a:solidFill>
                   <a:srgbClr val="0F172A"/>
                 </a:solidFill>
-                <a:latin typeface="TH Sarabun New"/>
+                <a:latin typeface="Angsana New"/>
               </a:defRPr>
             </a:pPr>
             <a:r>
@@ -5794,13 +5804,13 @@
           <a:p>
             <a:pPr>
               <a:spcAft>
-                <a:spcPts val="100"/>
+                <a:spcPts val="200"/>
               </a:spcAft>
-              <a:defRPr sz="1300">
+              <a:defRPr sz="1450">
                 <a:solidFill>
                   <a:srgbClr val="000000"/>
                 </a:solidFill>
-                <a:latin typeface="TH Sarabun New"/>
+                <a:latin typeface="Angsana New"/>
               </a:defRPr>
             </a:pPr>
             <a:r>
@@ -5810,13 +5820,13 @@
           <a:p>
             <a:pPr>
               <a:spcAft>
-                <a:spcPts val="100"/>
+                <a:spcPts val="200"/>
               </a:spcAft>
-              <a:defRPr sz="1300">
+              <a:defRPr sz="1450">
                 <a:solidFill>
                   <a:srgbClr val="000000"/>
                 </a:solidFill>
-                <a:latin typeface="TH Sarabun New"/>
+                <a:latin typeface="Angsana New"/>
               </a:defRPr>
             </a:pPr>
             <a:r>
@@ -5826,13 +5836,13 @@
           <a:p>
             <a:pPr>
               <a:spcAft>
-                <a:spcPts val="100"/>
+                <a:spcPts val="200"/>
               </a:spcAft>
-              <a:defRPr sz="1300">
+              <a:defRPr sz="1450">
                 <a:solidFill>
                   <a:srgbClr val="000000"/>
                 </a:solidFill>
-                <a:latin typeface="TH Sarabun New"/>
+                <a:latin typeface="Angsana New"/>
               </a:defRPr>
             </a:pPr>
             <a:r>
@@ -5843,7 +5853,7 @@
       </p:sp>
       <p:sp>
         <p:nvSpPr>
-          <p:cNvPr id="40" name="Rounded Rectangle 39"/>
+          <p:cNvPr id="41" name="Rounded Rectangle 40"/>
           <p:cNvSpPr/>
           <p:nvPr/>
         </p:nvSpPr>
@@ -5888,7 +5898,7 @@
       </p:sp>
       <p:sp>
         <p:nvSpPr>
-          <p:cNvPr id="41" name="Rectangle 40"/>
+          <p:cNvPr id="42" name="Rectangle 41"/>
           <p:cNvSpPr/>
           <p:nvPr/>
         </p:nvSpPr>
@@ -5932,7 +5942,7 @@
                 <a:solidFill>
                   <a:srgbClr val="FFFFFF"/>
                 </a:solidFill>
-                <a:latin typeface="TH Sarabun New"/>
+                <a:latin typeface="Angsana New"/>
               </a:defRPr>
             </a:pPr>
             <a:r>
@@ -5943,7 +5953,7 @@
       </p:sp>
       <p:sp>
         <p:nvSpPr>
-          <p:cNvPr id="42" name="TextBox 41"/>
+          <p:cNvPr id="43" name="TextBox 42"/>
           <p:cNvSpPr txBox="1"/>
           <p:nvPr/>
         </p:nvSpPr>
@@ -5967,11 +5977,11 @@
               <a:spcAft>
                 <a:spcPts val="100"/>
               </a:spcAft>
-              <a:defRPr sz="1350" b="1">
+              <a:defRPr sz="1500" b="1">
                 <a:solidFill>
                   <a:srgbClr val="0F172A"/>
                 </a:solidFill>
-                <a:latin typeface="TH Sarabun New"/>
+                <a:latin typeface="Angsana New"/>
               </a:defRPr>
             </a:pPr>
             <a:r>
@@ -5981,13 +5991,13 @@
           <a:p>
             <a:pPr>
               <a:spcAft>
-                <a:spcPts val="50"/>
+                <a:spcPts val="100"/>
               </a:spcAft>
-              <a:defRPr sz="1200">
+              <a:defRPr sz="1350">
                 <a:solidFill>
                   <a:srgbClr val="000000"/>
                 </a:solidFill>
-                <a:latin typeface="TH Sarabun New"/>
+                <a:latin typeface="Angsana New"/>
               </a:defRPr>
             </a:pPr>
             <a:r>
@@ -5997,13 +6007,13 @@
           <a:p>
             <a:pPr>
               <a:spcAft>
-                <a:spcPts val="50"/>
+                <a:spcPts val="100"/>
               </a:spcAft>
-              <a:defRPr sz="1200">
+              <a:defRPr sz="1350">
                 <a:solidFill>
                   <a:srgbClr val="000000"/>
                 </a:solidFill>
-                <a:latin typeface="TH Sarabun New"/>
+                <a:latin typeface="Angsana New"/>
               </a:defRPr>
             </a:pPr>
             <a:r>
@@ -6013,32 +6023,32 @@
           <a:p>
             <a:pPr>
               <a:spcAft>
-                <a:spcPts val="50"/>
+                <a:spcPts val="100"/>
               </a:spcAft>
-              <a:defRPr sz="1200">
+              <a:defRPr sz="1350">
                 <a:solidFill>
                   <a:srgbClr val="000000"/>
                 </a:solidFill>
-                <a:latin typeface="TH Sarabun New"/>
-              </a:defRPr>
-            </a:pPr>
-            <a:r>
-              <a:t>• Multi-tier validation confirmed end-to-end evidence ingestion and triage integrity.</a:t>
+                <a:latin typeface="Angsana New"/>
+              </a:defRPr>
+            </a:pPr>
+            <a:r>
+              <a:t>• Combined validation evidence covered portable acquisition/import behavior and the downstream database, API, analysis-history, and UI path.</a:t>
             </a:r>
           </a:p>
           <a:p>
             <a:pPr>
               <a:spcBef>
-                <a:spcPts val="150"/>
+                <a:spcPts val="200"/>
               </a:spcBef>
               <a:spcAft>
-                <a:spcPts val="50"/>
+                <a:spcPts val="100"/>
               </a:spcAft>
-              <a:defRPr sz="1250" b="1">
+              <a:defRPr sz="1400" b="1">
                 <a:solidFill>
                   <a:srgbClr val="0F172A"/>
                 </a:solidFill>
-                <a:latin typeface="TH Sarabun New"/>
+                <a:latin typeface="Angsana New"/>
               </a:defRPr>
             </a:pPr>
             <a:r>
@@ -6048,13 +6058,13 @@
           <a:p>
             <a:pPr>
               <a:spcAft>
-                <a:spcPts val="150"/>
+                <a:spcPts val="200"/>
               </a:spcAft>
-              <a:defRPr sz="1150" i="1">
+              <a:defRPr sz="1250" i="1">
                 <a:solidFill>
                   <a:srgbClr val="475569"/>
                 </a:solidFill>
-                <a:latin typeface="TH Sarabun New"/>
+                <a:latin typeface="Angsana New"/>
               </a:defRPr>
             </a:pPr>
             <a:r>
@@ -6064,13 +6074,13 @@
           <a:p>
             <a:pPr algn="ctr">
               <a:spcBef>
-                <a:spcPts val="100"/>
+                <a:spcPts val="200"/>
               </a:spcBef>
-              <a:defRPr sz="1150" b="1">
+              <a:defRPr sz="1300" b="1">
                 <a:solidFill>
                   <a:srgbClr val="0F172A"/>
                 </a:solidFill>
-                <a:latin typeface="TH Sarabun New"/>
+                <a:latin typeface="Angsana New"/>
               </a:defRPr>
             </a:pPr>
             <a:r>

</xml_diff>